<commit_message>
Update blue light detection slides
</commit_message>
<xml_diff>
--- a/blue-light-detection/解题ppt.pptx
+++ b/blue-light-detection/解题ppt.pptx
@@ -1,20 +1,21 @@
 
 <file path=ppt/presentation.xml><?xml version="1.0" encoding="utf-8"?>
-<p:presentation xmlns:a="http://schemas.openxmlformats.org/drawingml/2006/main" xmlns:p="http://schemas.openxmlformats.org/presentationml/2006/main" xmlns:r="http://schemas.openxmlformats.org/officeDocument/2006/relationships" autoCompressPictures="0" saveSubsetFonts="1">
+<p:presentation xmlns:a="http://schemas.openxmlformats.org/drawingml/2006/main" xmlns:r="http://schemas.openxmlformats.org/officeDocument/2006/relationships" xmlns:p="http://schemas.openxmlformats.org/presentationml/2006/main" autoCompressPictures="0">
   <p:sldMasterIdLst>
     <p:sldMasterId id="2147483648" r:id="rId1"/>
+    <p:sldMasterId id="2147483660" r:id="rId3"/>
   </p:sldMasterIdLst>
   <p:sldIdLst>
-    <p:sldId id="256" r:id="rId2"/>
-    <p:sldId id="257" r:id="rId3"/>
-    <p:sldId id="258" r:id="rId4"/>
-    <p:sldId id="259" r:id="rId5"/>
-    <p:sldId id="260" r:id="rId6"/>
-    <p:sldId id="261" r:id="rId7"/>
-    <p:sldId id="262" r:id="rId8"/>
-    <p:sldId id="263" r:id="rId9"/>
-    <p:sldId id="264" r:id="rId10"/>
-    <p:sldId id="265" r:id="rId11"/>
+    <p:sldId id="266" r:id="rId4"/>
+    <p:sldId id="257" r:id="rId5"/>
+    <p:sldId id="258" r:id="rId6"/>
+    <p:sldId id="259" r:id="rId7"/>
+    <p:sldId id="260" r:id="rId8"/>
+    <p:sldId id="261" r:id="rId9"/>
+    <p:sldId id="262" r:id="rId10"/>
+    <p:sldId id="263" r:id="rId11"/>
+    <p:sldId id="264" r:id="rId12"/>
+    <p:sldId id="265" r:id="rId13"/>
   </p:sldIdLst>
   <p:sldSz cx="9144000" cy="5143500" type="screen16x9"/>
   <p:notesSz cx="6858000" cy="9144000"/>
@@ -22,8 +23,8 @@
     <a:defPPr>
       <a:defRPr lang="en-US"/>
     </a:defPPr>
-    <a:lvl1pPr algn="l" defTabSz="457200" eaLnBrk="1" hangingPunct="1" latinLnBrk="0" marL="0" rtl="0">
-      <a:defRPr kern="1200" sz="1800">
+    <a:lvl1pPr marL="0" algn="l" defTabSz="457200" rtl="0" eaLnBrk="1" latinLnBrk="0" hangingPunct="1">
+      <a:defRPr sz="1800" kern="1200">
         <a:solidFill>
           <a:schemeClr val="tx1"/>
         </a:solidFill>
@@ -32,8 +33,8 @@
         <a:cs typeface="+mn-cs"/>
       </a:defRPr>
     </a:lvl1pPr>
-    <a:lvl2pPr algn="l" defTabSz="457200" eaLnBrk="1" hangingPunct="1" latinLnBrk="0" marL="457200" rtl="0">
-      <a:defRPr kern="1200" sz="1800">
+    <a:lvl2pPr marL="457200" algn="l" defTabSz="457200" rtl="0" eaLnBrk="1" latinLnBrk="0" hangingPunct="1">
+      <a:defRPr sz="1800" kern="1200">
         <a:solidFill>
           <a:schemeClr val="tx1"/>
         </a:solidFill>
@@ -42,8 +43,8 @@
         <a:cs typeface="+mn-cs"/>
       </a:defRPr>
     </a:lvl2pPr>
-    <a:lvl3pPr algn="l" defTabSz="457200" eaLnBrk="1" hangingPunct="1" latinLnBrk="0" marL="914400" rtl="0">
-      <a:defRPr kern="1200" sz="1800">
+    <a:lvl3pPr marL="914400" algn="l" defTabSz="457200" rtl="0" eaLnBrk="1" latinLnBrk="0" hangingPunct="1">
+      <a:defRPr sz="1800" kern="1200">
         <a:solidFill>
           <a:schemeClr val="tx1"/>
         </a:solidFill>
@@ -52,8 +53,8 @@
         <a:cs typeface="+mn-cs"/>
       </a:defRPr>
     </a:lvl3pPr>
-    <a:lvl4pPr algn="l" defTabSz="457200" eaLnBrk="1" hangingPunct="1" latinLnBrk="0" marL="1371600" rtl="0">
-      <a:defRPr kern="1200" sz="1800">
+    <a:lvl4pPr marL="1371600" algn="l" defTabSz="457200" rtl="0" eaLnBrk="1" latinLnBrk="0" hangingPunct="1">
+      <a:defRPr sz="1800" kern="1200">
         <a:solidFill>
           <a:schemeClr val="tx1"/>
         </a:solidFill>
@@ -62,8 +63,8 @@
         <a:cs typeface="+mn-cs"/>
       </a:defRPr>
     </a:lvl4pPr>
-    <a:lvl5pPr algn="l" defTabSz="457200" eaLnBrk="1" hangingPunct="1" latinLnBrk="0" marL="1828800" rtl="0">
-      <a:defRPr kern="1200" sz="1800">
+    <a:lvl5pPr marL="1828800" algn="l" defTabSz="457200" rtl="0" eaLnBrk="1" latinLnBrk="0" hangingPunct="1">
+      <a:defRPr sz="1800" kern="1200">
         <a:solidFill>
           <a:schemeClr val="tx1"/>
         </a:solidFill>
@@ -72,8 +73,8 @@
         <a:cs typeface="+mn-cs"/>
       </a:defRPr>
     </a:lvl5pPr>
-    <a:lvl6pPr algn="l" defTabSz="457200" eaLnBrk="1" hangingPunct="1" latinLnBrk="0" marL="2286000" rtl="0">
-      <a:defRPr kern="1200" sz="1800">
+    <a:lvl6pPr marL="2286000" algn="l" defTabSz="457200" rtl="0" eaLnBrk="1" latinLnBrk="0" hangingPunct="1">
+      <a:defRPr sz="1800" kern="1200">
         <a:solidFill>
           <a:schemeClr val="tx1"/>
         </a:solidFill>
@@ -82,8 +83,8 @@
         <a:cs typeface="+mn-cs"/>
       </a:defRPr>
     </a:lvl6pPr>
-    <a:lvl7pPr algn="l" defTabSz="457200" eaLnBrk="1" hangingPunct="1" latinLnBrk="0" marL="2743200" rtl="0">
-      <a:defRPr kern="1200" sz="1800">
+    <a:lvl7pPr marL="2743200" algn="l" defTabSz="457200" rtl="0" eaLnBrk="1" latinLnBrk="0" hangingPunct="1">
+      <a:defRPr sz="1800" kern="1200">
         <a:solidFill>
           <a:schemeClr val="tx1"/>
         </a:solidFill>
@@ -92,8 +93,8 @@
         <a:cs typeface="+mn-cs"/>
       </a:defRPr>
     </a:lvl7pPr>
-    <a:lvl8pPr algn="l" defTabSz="457200" eaLnBrk="1" hangingPunct="1" latinLnBrk="0" marL="3200400" rtl="0">
-      <a:defRPr kern="1200" sz="1800">
+    <a:lvl8pPr marL="3200400" algn="l" defTabSz="457200" rtl="0" eaLnBrk="1" latinLnBrk="0" hangingPunct="1">
+      <a:defRPr sz="1800" kern="1200">
         <a:solidFill>
           <a:schemeClr val="tx1"/>
         </a:solidFill>
@@ -102,8 +103,8 @@
         <a:cs typeface="+mn-cs"/>
       </a:defRPr>
     </a:lvl8pPr>
-    <a:lvl9pPr algn="l" defTabSz="457200" eaLnBrk="1" hangingPunct="1" latinLnBrk="0" marL="3657600" rtl="0">
-      <a:defRPr kern="1200" sz="1800">
+    <a:lvl9pPr marL="3657600" algn="l" defTabSz="457200" rtl="0" eaLnBrk="1" latinLnBrk="0" hangingPunct="1">
+      <a:defRPr sz="1800" kern="1200">
         <a:solidFill>
           <a:schemeClr val="tx1"/>
         </a:solidFill>
@@ -132,6 +133,12 @@
 </p:presentation>
 </file>
 
+<file path=ppt/commentAuthors.xml><?xml version="1.0" encoding="utf-8"?>
+<p:cmAuthorLst xmlns:a="http://schemas.openxmlformats.org/drawingml/2006/main" xmlns:r="http://schemas.openxmlformats.org/officeDocument/2006/relationships" xmlns:p="http://schemas.openxmlformats.org/presentationml/2006/main">
+  <p:cmAuthor id="1" name="kechuying" initials="k" lastIdx="1" clrIdx="0"/>
+</p:cmAuthorLst>
+</file>
+
 <file path=ppt/slideLayouts/slideLayout1.xml><?xml version="1.0" encoding="utf-8"?>
 <p:sldLayout xmlns:a="http://schemas.openxmlformats.org/drawingml/2006/main" xmlns:r="http://schemas.openxmlformats.org/officeDocument/2006/relationships" xmlns:p="http://schemas.openxmlformats.org/presentationml/2006/main" type="title" preserve="1">
   <p:cSld name="Title Slide">
@@ -173,6 +180,7 @@
               <a:rPr lang="en-US"/>
               <a:t>Click to edit Master title style</a:t>
             </a:r>
+            <a:endParaRPr lang="en-US"/>
           </a:p>
         </p:txBody>
       </p:sp>
@@ -291,6 +299,7 @@
               <a:rPr lang="en-US"/>
               <a:t>Click to edit Master subtitle style</a:t>
             </a:r>
+            <a:endParaRPr lang="en-US"/>
           </a:p>
         </p:txBody>
       </p:sp>
@@ -311,7 +320,6 @@
           <a:p>
             <a:fld id="{241EB5C9-1307-BA42-ABA2-0BC069CD8E7F}" type="datetimeFigureOut">
               <a:rPr lang="en-US" smtClean="0"/>
-              <a:t>1/2/22</a:t>
             </a:fld>
             <a:endParaRPr lang="en-US"/>
           </a:p>
@@ -353,18 +361,12 @@
           <a:p>
             <a:fld id="{C5EF2332-01BF-834F-8236-50238282D533}" type="slidenum">
               <a:rPr lang="en-US" smtClean="0"/>
-              <a:t>‹#›</a:t>
             </a:fld>
             <a:endParaRPr lang="en-US"/>
           </a:p>
         </p:txBody>
       </p:sp>
     </p:spTree>
-    <p:extLst>
-      <p:ext uri="{BB962C8B-B14F-4D97-AF65-F5344CB8AC3E}">
-        <p14:creationId xmlns:p14="http://schemas.microsoft.com/office/powerpoint/2010/main" val="1444357513"/>
-      </p:ext>
-    </p:extLst>
   </p:cSld>
   <p:clrMapOvr>
     <a:masterClrMapping/>
@@ -408,6 +410,7 @@
               <a:rPr lang="en-US"/>
               <a:t>Click to edit Master title style</a:t>
             </a:r>
+            <a:endParaRPr lang="en-US"/>
           </a:p>
         </p:txBody>
       </p:sp>
@@ -431,6 +434,7 @@
               <a:rPr lang="en-US"/>
               <a:t>Click to edit Master text styles</a:t>
             </a:r>
+            <a:endParaRPr lang="en-US"/>
           </a:p>
           <a:p>
             <a:pPr lvl="1"/>
@@ -438,6 +442,7 @@
               <a:rPr lang="en-US"/>
               <a:t>Second level</a:t>
             </a:r>
+            <a:endParaRPr lang="en-US"/>
           </a:p>
           <a:p>
             <a:pPr lvl="2"/>
@@ -445,6 +450,7 @@
               <a:rPr lang="en-US"/>
               <a:t>Third level</a:t>
             </a:r>
+            <a:endParaRPr lang="en-US"/>
           </a:p>
           <a:p>
             <a:pPr lvl="3"/>
@@ -452,6 +458,7 @@
               <a:rPr lang="en-US"/>
               <a:t>Fourth level</a:t>
             </a:r>
+            <a:endParaRPr lang="en-US"/>
           </a:p>
           <a:p>
             <a:pPr lvl="4"/>
@@ -459,6 +466,7 @@
               <a:rPr lang="en-US"/>
               <a:t>Fifth level</a:t>
             </a:r>
+            <a:endParaRPr lang="en-US"/>
           </a:p>
         </p:txBody>
       </p:sp>
@@ -479,7 +487,6 @@
           <a:p>
             <a:fld id="{241EB5C9-1307-BA42-ABA2-0BC069CD8E7F}" type="datetimeFigureOut">
               <a:rPr lang="en-US" smtClean="0"/>
-              <a:t>1/2/22</a:t>
             </a:fld>
             <a:endParaRPr lang="en-US"/>
           </a:p>
@@ -521,18 +528,12 @@
           <a:p>
             <a:fld id="{C5EF2332-01BF-834F-8236-50238282D533}" type="slidenum">
               <a:rPr lang="en-US" smtClean="0"/>
-              <a:t>‹#›</a:t>
             </a:fld>
             <a:endParaRPr lang="en-US"/>
           </a:p>
         </p:txBody>
       </p:sp>
     </p:spTree>
-    <p:extLst>
-      <p:ext uri="{BB962C8B-B14F-4D97-AF65-F5344CB8AC3E}">
-        <p14:creationId xmlns:p14="http://schemas.microsoft.com/office/powerpoint/2010/main" val="313914798"/>
-      </p:ext>
-    </p:extLst>
   </p:cSld>
   <p:clrMapOvr>
     <a:masterClrMapping/>
@@ -581,6 +582,7 @@
               <a:rPr lang="en-US"/>
               <a:t>Click to edit Master title style</a:t>
             </a:r>
+            <a:endParaRPr lang="en-US"/>
           </a:p>
         </p:txBody>
       </p:sp>
@@ -609,6 +611,7 @@
               <a:rPr lang="en-US"/>
               <a:t>Click to edit Master text styles</a:t>
             </a:r>
+            <a:endParaRPr lang="en-US"/>
           </a:p>
           <a:p>
             <a:pPr lvl="1"/>
@@ -616,6 +619,7 @@
               <a:rPr lang="en-US"/>
               <a:t>Second level</a:t>
             </a:r>
+            <a:endParaRPr lang="en-US"/>
           </a:p>
           <a:p>
             <a:pPr lvl="2"/>
@@ -623,6 +627,7 @@
               <a:rPr lang="en-US"/>
               <a:t>Third level</a:t>
             </a:r>
+            <a:endParaRPr lang="en-US"/>
           </a:p>
           <a:p>
             <a:pPr lvl="3"/>
@@ -630,6 +635,7 @@
               <a:rPr lang="en-US"/>
               <a:t>Fourth level</a:t>
             </a:r>
+            <a:endParaRPr lang="en-US"/>
           </a:p>
           <a:p>
             <a:pPr lvl="4"/>
@@ -637,6 +643,7 @@
               <a:rPr lang="en-US"/>
               <a:t>Fifth level</a:t>
             </a:r>
+            <a:endParaRPr lang="en-US"/>
           </a:p>
         </p:txBody>
       </p:sp>
@@ -657,7 +664,6 @@
           <a:p>
             <a:fld id="{241EB5C9-1307-BA42-ABA2-0BC069CD8E7F}" type="datetimeFigureOut">
               <a:rPr lang="en-US" smtClean="0"/>
-              <a:t>1/2/22</a:t>
             </a:fld>
             <a:endParaRPr lang="en-US"/>
           </a:p>
@@ -699,18 +705,1212 @@
           <a:p>
             <a:fld id="{C5EF2332-01BF-834F-8236-50238282D533}" type="slidenum">
               <a:rPr lang="en-US" smtClean="0"/>
-              <a:t>‹#›</a:t>
             </a:fld>
             <a:endParaRPr lang="en-US"/>
           </a:p>
         </p:txBody>
       </p:sp>
     </p:spTree>
-    <p:extLst>
-      <p:ext uri="{BB962C8B-B14F-4D97-AF65-F5344CB8AC3E}">
-        <p14:creationId xmlns:p14="http://schemas.microsoft.com/office/powerpoint/2010/main" val="2581529045"/>
-      </p:ext>
-    </p:extLst>
+  </p:cSld>
+  <p:clrMapOvr>
+    <a:masterClrMapping/>
+  </p:clrMapOvr>
+</p:sldLayout>
+</file>
+
+<file path=ppt/slideLayouts/slideLayout12.xml><?xml version="1.0" encoding="utf-8"?>
+<p:sldLayout xmlns:a="http://schemas.openxmlformats.org/drawingml/2006/main" xmlns:r="http://schemas.openxmlformats.org/officeDocument/2006/relationships" xmlns:p="http://schemas.openxmlformats.org/presentationml/2006/main" preserve="1" showMasterSp="0" userDrawn="1">
+  <p:cSld name="标题幻灯片">
+    <p:spTree>
+      <p:nvGrpSpPr>
+        <p:cNvPr id="1" name=""/>
+        <p:cNvGrpSpPr/>
+        <p:nvPr/>
+      </p:nvGrpSpPr>
+      <p:grpSpPr>
+        <a:xfrm>
+          <a:off x="0" y="0"/>
+          <a:ext cx="0" cy="0"/>
+          <a:chOff x="0" y="0"/>
+          <a:chExt cx="0" cy="0"/>
+        </a:xfrm>
+      </p:grpSpPr>
+      <p:sp>
+        <p:nvSpPr>
+          <p:cNvPr id="19" name="矩形 18"/>
+          <p:cNvSpPr/>
+          <p:nvPr userDrawn="1">
+            <p:custDataLst>
+              <p:tags r:id="rId2"/>
+            </p:custDataLst>
+          </p:nvPr>
+        </p:nvSpPr>
+        <p:spPr>
+          <a:xfrm>
+            <a:off x="1177766" y="230029"/>
+            <a:ext cx="7966710" cy="4481036"/>
+          </a:xfrm>
+          <a:prstGeom prst="rect">
+            <a:avLst/>
+          </a:prstGeom>
+          <a:gradFill>
+            <a:gsLst>
+              <a:gs pos="0">
+                <a:schemeClr val="bg2">
+                  <a:lumMod val="90000"/>
+                  <a:lumOff val="10000"/>
+                </a:schemeClr>
+              </a:gs>
+              <a:gs pos="100000">
+                <a:schemeClr val="bg2">
+                  <a:lumMod val="90000"/>
+                  <a:lumOff val="10000"/>
+                </a:schemeClr>
+              </a:gs>
+            </a:gsLst>
+            <a:lin ang="5400000" scaled="0"/>
+          </a:gradFill>
+        </p:spPr>
+        <p:style>
+          <a:lnRef idx="2">
+            <a:schemeClr val="accent1">
+              <a:lumMod val="75000"/>
+            </a:schemeClr>
+          </a:lnRef>
+          <a:fillRef idx="1">
+            <a:schemeClr val="accent1"/>
+          </a:fillRef>
+          <a:effectRef idx="0">
+            <a:srgbClr val="FFFFFF"/>
+          </a:effectRef>
+          <a:fontRef idx="minor">
+            <a:schemeClr val="lt1"/>
+          </a:fontRef>
+        </p:style>
+        <p:txBody>
+          <a:bodyPr rtlCol="0" anchor="ctr"/>
+          <a:lstStyle/>
+          <a:p>
+            <a:pPr algn="ctr"/>
+            <a:endParaRPr lang="zh-CN" altLang="en-US" sz="1350">
+              <a:cs typeface="微软雅黑" charset="-122"/>
+            </a:endParaRPr>
+          </a:p>
+        </p:txBody>
+      </p:sp>
+      <p:pic>
+        <p:nvPicPr>
+          <p:cNvPr id="7" name="图片 6" descr="生成蓝色调机械齿轮图片 (2)"/>
+          <p:cNvPicPr>
+            <a:picLocks noChangeAspect="1"/>
+          </p:cNvPicPr>
+          <p:nvPr userDrawn="1">
+            <p:custDataLst>
+              <p:tags r:id="rId3"/>
+            </p:custDataLst>
+          </p:nvPr>
+        </p:nvPicPr>
+        <p:blipFill>
+          <a:blip r:embed="rId4" cstate="screen"/>
+          <a:srcRect/>
+          <a:stretch>
+            <a:fillRect/>
+          </a:stretch>
+        </p:blipFill>
+        <p:spPr>
+          <a:xfrm>
+            <a:off x="0" y="-9049"/>
+            <a:ext cx="5678329" cy="5152073"/>
+          </a:xfrm>
+          <a:custGeom>
+            <a:avLst/>
+            <a:gdLst/>
+            <a:ahLst/>
+            <a:cxnLst>
+              <a:cxn ang="3">
+                <a:pos x="hc" y="t"/>
+              </a:cxn>
+              <a:cxn ang="cd2">
+                <a:pos x="l" y="vc"/>
+              </a:cxn>
+              <a:cxn ang="cd4">
+                <a:pos x="hc" y="b"/>
+              </a:cxn>
+              <a:cxn ang="0">
+                <a:pos x="r" y="vc"/>
+              </a:cxn>
+            </a:cxnLst>
+            <a:rect l="l" t="t" r="r" b="b"/>
+            <a:pathLst>
+              <a:path w="12896" h="10781">
+                <a:moveTo>
+                  <a:pt x="0" y="0"/>
+                </a:moveTo>
+                <a:lnTo>
+                  <a:pt x="12896" y="0"/>
+                </a:lnTo>
+                <a:lnTo>
+                  <a:pt x="5866" y="10781"/>
+                </a:lnTo>
+                <a:lnTo>
+                  <a:pt x="0" y="10781"/>
+                </a:lnTo>
+                <a:lnTo>
+                  <a:pt x="0" y="0"/>
+                </a:lnTo>
+                <a:close/>
+              </a:path>
+            </a:pathLst>
+          </a:custGeom>
+        </p:spPr>
+      </p:pic>
+      <p:sp>
+        <p:nvSpPr>
+          <p:cNvPr id="15" name="任意多边形: 形状 43"/>
+          <p:cNvSpPr/>
+          <p:nvPr userDrawn="1">
+            <p:custDataLst>
+              <p:tags r:id="rId5"/>
+            </p:custDataLst>
+          </p:nvPr>
+        </p:nvSpPr>
+        <p:spPr bwMode="auto">
+          <a:xfrm>
+            <a:off x="2398214" y="1682115"/>
+            <a:ext cx="2681469" cy="3461385"/>
+          </a:xfrm>
+          <a:custGeom>
+            <a:avLst/>
+            <a:gdLst>
+              <a:gd name="T0" fmla="*/ 775 w 3269"/>
+              <a:gd name="T1" fmla="*/ 3824 h 3824"/>
+              <a:gd name="T2" fmla="*/ 3269 w 3269"/>
+              <a:gd name="T3" fmla="*/ 0 h 3824"/>
+              <a:gd name="T4" fmla="*/ 2494 w 3269"/>
+              <a:gd name="T5" fmla="*/ 0 h 3824"/>
+              <a:gd name="T6" fmla="*/ 0 w 3269"/>
+              <a:gd name="T7" fmla="*/ 3824 h 3824"/>
+              <a:gd name="T8" fmla="*/ 775 w 3269"/>
+              <a:gd name="T9" fmla="*/ 3824 h 3824"/>
+            </a:gdLst>
+            <a:ahLst/>
+            <a:cxnLst>
+              <a:cxn ang="0">
+                <a:pos x="T0" y="T1"/>
+              </a:cxn>
+              <a:cxn ang="0">
+                <a:pos x="T2" y="T3"/>
+              </a:cxn>
+              <a:cxn ang="0">
+                <a:pos x="T4" y="T5"/>
+              </a:cxn>
+              <a:cxn ang="0">
+                <a:pos x="T6" y="T7"/>
+              </a:cxn>
+              <a:cxn ang="0">
+                <a:pos x="T8" y="T9"/>
+              </a:cxn>
+            </a:cxnLst>
+            <a:rect l="0" t="0" r="r" b="b"/>
+            <a:pathLst>
+              <a:path w="5630" h="7268">
+                <a:moveTo>
+                  <a:pt x="4740" y="0"/>
+                </a:moveTo>
+                <a:lnTo>
+                  <a:pt x="5630" y="0"/>
+                </a:lnTo>
+                <a:lnTo>
+                  <a:pt x="891" y="7268"/>
+                </a:lnTo>
+                <a:lnTo>
+                  <a:pt x="0" y="7268"/>
+                </a:lnTo>
+                <a:lnTo>
+                  <a:pt x="4740" y="0"/>
+                </a:lnTo>
+                <a:close/>
+              </a:path>
+            </a:pathLst>
+          </a:custGeom>
+          <a:gradFill flip="none" rotWithShape="1">
+            <a:gsLst>
+              <a:gs pos="0">
+                <a:schemeClr val="accent1">
+                  <a:lumMod val="60000"/>
+                  <a:lumOff val="40000"/>
+                </a:schemeClr>
+              </a:gs>
+              <a:gs pos="100000">
+                <a:schemeClr val="accent1">
+                  <a:lumMod val="60000"/>
+                  <a:lumOff val="40000"/>
+                  <a:alpha val="0"/>
+                </a:schemeClr>
+              </a:gs>
+            </a:gsLst>
+            <a:lin ang="16200000" scaled="1"/>
+            <a:tileRect/>
+          </a:gradFill>
+          <a:ln>
+            <a:noFill/>
+          </a:ln>
+        </p:spPr>
+        <p:txBody>
+          <a:bodyPr vert="horz" wrap="square" lIns="68580" tIns="34290" rIns="68580" bIns="34290" numCol="1" anchor="t" anchorCtr="0" compatLnSpc="1">
+            <a:noAutofit/>
+          </a:bodyPr>
+          <a:lstStyle/>
+          <a:p>
+            <a:endParaRPr lang="zh-CN" altLang="en-US" sz="1350">
+              <a:cs typeface="微软雅黑" charset="-122"/>
+            </a:endParaRPr>
+          </a:p>
+        </p:txBody>
+      </p:sp>
+      <p:sp>
+        <p:nvSpPr>
+          <p:cNvPr id="16" name="矩形 15"/>
+          <p:cNvSpPr/>
+          <p:nvPr userDrawn="1">
+            <p:custDataLst>
+              <p:tags r:id="rId6"/>
+            </p:custDataLst>
+          </p:nvPr>
+        </p:nvSpPr>
+        <p:spPr>
+          <a:xfrm>
+            <a:off x="0" y="-9049"/>
+            <a:ext cx="9153000" cy="623411"/>
+          </a:xfrm>
+          <a:prstGeom prst="rect">
+            <a:avLst/>
+          </a:prstGeom>
+          <a:gradFill>
+            <a:gsLst>
+              <a:gs pos="0">
+                <a:schemeClr val="accent1">
+                  <a:lumMod val="90000"/>
+                </a:schemeClr>
+              </a:gs>
+              <a:gs pos="100000">
+                <a:schemeClr val="accent1">
+                  <a:lumMod val="90000"/>
+                </a:schemeClr>
+              </a:gs>
+            </a:gsLst>
+            <a:lin ang="5400000" scaled="0"/>
+          </a:gradFill>
+          <a:ln>
+            <a:noFill/>
+          </a:ln>
+        </p:spPr>
+        <p:style>
+          <a:lnRef idx="2">
+            <a:schemeClr val="accent1">
+              <a:lumMod val="75000"/>
+            </a:schemeClr>
+          </a:lnRef>
+          <a:fillRef idx="1">
+            <a:schemeClr val="accent1"/>
+          </a:fillRef>
+          <a:effectRef idx="0">
+            <a:srgbClr val="FFFFFF"/>
+          </a:effectRef>
+          <a:fontRef idx="minor">
+            <a:schemeClr val="lt1"/>
+          </a:fontRef>
+        </p:style>
+        <p:txBody>
+          <a:bodyPr rtlCol="0" anchor="ctr"/>
+          <a:lstStyle/>
+          <a:p>
+            <a:pPr algn="ctr"/>
+            <a:endParaRPr lang="zh-CN" altLang="en-US" sz="1350">
+              <a:cs typeface="微软雅黑" charset="-122"/>
+            </a:endParaRPr>
+          </a:p>
+        </p:txBody>
+      </p:sp>
+      <p:sp>
+        <p:nvSpPr>
+          <p:cNvPr id="17" name="矩形 16"/>
+          <p:cNvSpPr/>
+          <p:nvPr userDrawn="1">
+            <p:custDataLst>
+              <p:tags r:id="rId7"/>
+            </p:custDataLst>
+          </p:nvPr>
+        </p:nvSpPr>
+        <p:spPr>
+          <a:xfrm>
+            <a:off x="0" y="4519613"/>
+            <a:ext cx="9153000" cy="623411"/>
+          </a:xfrm>
+          <a:prstGeom prst="rect">
+            <a:avLst/>
+          </a:prstGeom>
+          <a:gradFill>
+            <a:gsLst>
+              <a:gs pos="0">
+                <a:schemeClr val="accent1">
+                  <a:lumMod val="95000"/>
+                </a:schemeClr>
+              </a:gs>
+              <a:gs pos="100000">
+                <a:schemeClr val="accent1">
+                  <a:lumMod val="95000"/>
+                </a:schemeClr>
+              </a:gs>
+            </a:gsLst>
+            <a:lin ang="5400000" scaled="0"/>
+          </a:gradFill>
+          <a:ln>
+            <a:noFill/>
+          </a:ln>
+        </p:spPr>
+        <p:style>
+          <a:lnRef idx="2">
+            <a:schemeClr val="accent1">
+              <a:lumMod val="75000"/>
+            </a:schemeClr>
+          </a:lnRef>
+          <a:fillRef idx="1">
+            <a:schemeClr val="accent1"/>
+          </a:fillRef>
+          <a:effectRef idx="0">
+            <a:srgbClr val="FFFFFF"/>
+          </a:effectRef>
+          <a:fontRef idx="minor">
+            <a:schemeClr val="lt1"/>
+          </a:fontRef>
+        </p:style>
+        <p:txBody>
+          <a:bodyPr vertOverflow="overflow" horzOverflow="overflow" vert="horz" wrap="square" numCol="1" spcCol="0" rtlCol="0" fromWordArt="0" anchor="ctr" anchorCtr="0" forceAA="0" compatLnSpc="1">
+            <a:noAutofit/>
+          </a:bodyPr>
+          <a:lstStyle/>
+          <a:p>
+            <a:pPr lvl="0" algn="ctr">
+              <a:buClrTx/>
+              <a:buSzTx/>
+              <a:buFontTx/>
+            </a:pPr>
+            <a:endParaRPr lang="zh-CN" altLang="en-US" sz="1350">
+              <a:cs typeface="微软雅黑" charset="-122"/>
+              <a:sym typeface="+mn-ea"/>
+            </a:endParaRPr>
+          </a:p>
+        </p:txBody>
+      </p:sp>
+      <p:sp>
+        <p:nvSpPr>
+          <p:cNvPr id="13" name="任意多边形: 形状 12"/>
+          <p:cNvSpPr/>
+          <p:nvPr userDrawn="1">
+            <p:custDataLst>
+              <p:tags r:id="rId8"/>
+            </p:custDataLst>
+          </p:nvPr>
+        </p:nvSpPr>
+        <p:spPr bwMode="auto">
+          <a:xfrm flipH="1" flipV="1">
+            <a:off x="8244364" y="3763804"/>
+            <a:ext cx="899636" cy="1379696"/>
+          </a:xfrm>
+          <a:custGeom>
+            <a:avLst/>
+            <a:gdLst>
+              <a:gd name="connsiteX0" fmla="*/ 0 w 2974422"/>
+              <a:gd name="connsiteY0" fmla="*/ 4561506 h 4561506"/>
+              <a:gd name="connsiteX1" fmla="*/ 0 w 2974422"/>
+              <a:gd name="connsiteY1" fmla="*/ 0 h 4561506"/>
+              <a:gd name="connsiteX2" fmla="*/ 2974422 w 2974422"/>
+              <a:gd name="connsiteY2" fmla="*/ 0 h 4561506"/>
+            </a:gdLst>
+            <a:ahLst/>
+            <a:cxnLst>
+              <a:cxn ang="0">
+                <a:pos x="connsiteX0" y="connsiteY0"/>
+              </a:cxn>
+              <a:cxn ang="0">
+                <a:pos x="connsiteX1" y="connsiteY1"/>
+              </a:cxn>
+              <a:cxn ang="0">
+                <a:pos x="connsiteX2" y="connsiteY2"/>
+              </a:cxn>
+            </a:cxnLst>
+            <a:rect l="l" t="t" r="r" b="b"/>
+            <a:pathLst>
+              <a:path w="1889" h="2897">
+                <a:moveTo>
+                  <a:pt x="1091" y="0"/>
+                </a:moveTo>
+                <a:lnTo>
+                  <a:pt x="1889" y="0"/>
+                </a:lnTo>
+                <a:lnTo>
+                  <a:pt x="0" y="2897"/>
+                </a:lnTo>
+                <a:lnTo>
+                  <a:pt x="0" y="1673"/>
+                </a:lnTo>
+                <a:lnTo>
+                  <a:pt x="1091" y="0"/>
+                </a:lnTo>
+                <a:close/>
+              </a:path>
+            </a:pathLst>
+          </a:custGeom>
+          <a:gradFill flip="none" rotWithShape="1">
+            <a:gsLst>
+              <a:gs pos="0">
+                <a:schemeClr val="accent1">
+                  <a:lumMod val="60000"/>
+                  <a:lumOff val="40000"/>
+                  <a:alpha val="43000"/>
+                </a:schemeClr>
+              </a:gs>
+              <a:gs pos="100000">
+                <a:schemeClr val="accent1">
+                  <a:lumMod val="60000"/>
+                  <a:lumOff val="40000"/>
+                  <a:alpha val="0"/>
+                </a:schemeClr>
+              </a:gs>
+            </a:gsLst>
+            <a:lin ang="5400000" scaled="1"/>
+            <a:tileRect/>
+          </a:gradFill>
+          <a:ln>
+            <a:noFill/>
+          </a:ln>
+        </p:spPr>
+        <p:txBody>
+          <a:bodyPr vert="horz" wrap="square" lIns="68580" tIns="34290" rIns="68580" bIns="34290" numCol="1" anchor="t" anchorCtr="0" compatLnSpc="1">
+            <a:noAutofit/>
+          </a:bodyPr>
+          <a:lstStyle/>
+          <a:p>
+            <a:pPr lvl="0"/>
+            <a:endParaRPr lang="zh-CN" altLang="en-US" sz="1350">
+              <a:cs typeface="微软雅黑" charset="-122"/>
+            </a:endParaRPr>
+          </a:p>
+        </p:txBody>
+      </p:sp>
+      <p:sp>
+        <p:nvSpPr>
+          <p:cNvPr id="8" name="任意多边形: 形状 43"/>
+          <p:cNvSpPr/>
+          <p:nvPr userDrawn="1">
+            <p:custDataLst>
+              <p:tags r:id="rId9"/>
+            </p:custDataLst>
+          </p:nvPr>
+        </p:nvSpPr>
+        <p:spPr bwMode="auto">
+          <a:xfrm>
+            <a:off x="5321141" y="230029"/>
+            <a:ext cx="982928" cy="740569"/>
+          </a:xfrm>
+          <a:custGeom>
+            <a:avLst/>
+            <a:gdLst>
+              <a:gd name="T0" fmla="*/ 775 w 3269"/>
+              <a:gd name="T1" fmla="*/ 3824 h 3824"/>
+              <a:gd name="T2" fmla="*/ 3269 w 3269"/>
+              <a:gd name="T3" fmla="*/ 0 h 3824"/>
+              <a:gd name="T4" fmla="*/ 2494 w 3269"/>
+              <a:gd name="T5" fmla="*/ 0 h 3824"/>
+              <a:gd name="T6" fmla="*/ 0 w 3269"/>
+              <a:gd name="T7" fmla="*/ 3824 h 3824"/>
+              <a:gd name="T8" fmla="*/ 775 w 3269"/>
+              <a:gd name="T9" fmla="*/ 3824 h 3824"/>
+            </a:gdLst>
+            <a:ahLst/>
+            <a:cxnLst>
+              <a:cxn ang="0">
+                <a:pos x="T0" y="T1"/>
+              </a:cxn>
+              <a:cxn ang="0">
+                <a:pos x="T2" y="T3"/>
+              </a:cxn>
+              <a:cxn ang="0">
+                <a:pos x="T4" y="T5"/>
+              </a:cxn>
+              <a:cxn ang="0">
+                <a:pos x="T6" y="T7"/>
+              </a:cxn>
+              <a:cxn ang="0">
+                <a:pos x="T8" y="T9"/>
+              </a:cxn>
+            </a:cxnLst>
+            <a:rect l="0" t="0" r="r" b="b"/>
+            <a:pathLst>
+              <a:path w="2064" h="1555">
+                <a:moveTo>
+                  <a:pt x="1014" y="0"/>
+                </a:moveTo>
+                <a:lnTo>
+                  <a:pt x="2064" y="0"/>
+                </a:lnTo>
+                <a:lnTo>
+                  <a:pt x="1050" y="1555"/>
+                </a:lnTo>
+                <a:lnTo>
+                  <a:pt x="0" y="1555"/>
+                </a:lnTo>
+                <a:lnTo>
+                  <a:pt x="1014" y="0"/>
+                </a:lnTo>
+                <a:close/>
+              </a:path>
+            </a:pathLst>
+          </a:custGeom>
+          <a:gradFill flip="none" rotWithShape="1">
+            <a:gsLst>
+              <a:gs pos="0">
+                <a:schemeClr val="accent1">
+                  <a:lumMod val="60000"/>
+                  <a:lumOff val="40000"/>
+                  <a:alpha val="61000"/>
+                </a:schemeClr>
+              </a:gs>
+              <a:gs pos="100000">
+                <a:schemeClr val="accent1">
+                  <a:lumMod val="60000"/>
+                  <a:lumOff val="40000"/>
+                  <a:alpha val="0"/>
+                </a:schemeClr>
+              </a:gs>
+            </a:gsLst>
+            <a:lin ang="16200000" scaled="1"/>
+            <a:tileRect/>
+          </a:gradFill>
+          <a:ln>
+            <a:noFill/>
+          </a:ln>
+        </p:spPr>
+        <p:txBody>
+          <a:bodyPr vert="horz" wrap="square" lIns="68580" tIns="34290" rIns="68580" bIns="34290" numCol="1" anchor="t" anchorCtr="0" compatLnSpc="1">
+            <a:noAutofit/>
+          </a:bodyPr>
+          <a:lstStyle/>
+          <a:p>
+            <a:endParaRPr lang="zh-CN" altLang="en-US" sz="1350">
+              <a:cs typeface="微软雅黑" charset="-122"/>
+            </a:endParaRPr>
+          </a:p>
+        </p:txBody>
+      </p:sp>
+      <p:sp>
+        <p:nvSpPr>
+          <p:cNvPr id="9" name="任意多边形: 形状 7"/>
+          <p:cNvSpPr/>
+          <p:nvPr userDrawn="1">
+            <p:custDataLst>
+              <p:tags r:id="rId10"/>
+            </p:custDataLst>
+          </p:nvPr>
+        </p:nvSpPr>
+        <p:spPr bwMode="auto">
+          <a:xfrm>
+            <a:off x="0" y="0"/>
+            <a:ext cx="706279" cy="1083263"/>
+          </a:xfrm>
+          <a:custGeom>
+            <a:avLst/>
+            <a:gdLst>
+              <a:gd name="connsiteX0" fmla="*/ 0 w 1288621"/>
+              <a:gd name="connsiteY0" fmla="*/ 0 h 1975816"/>
+              <a:gd name="connsiteX1" fmla="*/ 1288621 w 1288621"/>
+              <a:gd name="connsiteY1" fmla="*/ 0 h 1975816"/>
+              <a:gd name="connsiteX2" fmla="*/ 0 w 1288621"/>
+              <a:gd name="connsiteY2" fmla="*/ 1975816 h 1975816"/>
+            </a:gdLst>
+            <a:ahLst/>
+            <a:cxnLst>
+              <a:cxn ang="0">
+                <a:pos x="connsiteX0" y="connsiteY0"/>
+              </a:cxn>
+              <a:cxn ang="0">
+                <a:pos x="connsiteX1" y="connsiteY1"/>
+              </a:cxn>
+              <a:cxn ang="0">
+                <a:pos x="connsiteX2" y="connsiteY2"/>
+              </a:cxn>
+            </a:cxnLst>
+            <a:rect l="l" t="t" r="r" b="b"/>
+            <a:pathLst>
+              <a:path w="1483" h="2275">
+                <a:moveTo>
+                  <a:pt x="0" y="0"/>
+                </a:moveTo>
+                <a:lnTo>
+                  <a:pt x="1483" y="0"/>
+                </a:lnTo>
+                <a:lnTo>
+                  <a:pt x="0" y="2275"/>
+                </a:lnTo>
+                <a:lnTo>
+                  <a:pt x="0" y="0"/>
+                </a:lnTo>
+                <a:close/>
+              </a:path>
+            </a:pathLst>
+          </a:custGeom>
+          <a:gradFill flip="none" rotWithShape="1">
+            <a:gsLst>
+              <a:gs pos="0">
+                <a:schemeClr val="accent1">
+                  <a:lumMod val="60000"/>
+                  <a:lumOff val="40000"/>
+                  <a:alpha val="100000"/>
+                </a:schemeClr>
+              </a:gs>
+              <a:gs pos="100000">
+                <a:schemeClr val="accent1">
+                  <a:lumMod val="60000"/>
+                  <a:lumOff val="40000"/>
+                  <a:alpha val="0"/>
+                </a:schemeClr>
+              </a:gs>
+            </a:gsLst>
+            <a:lin ang="16200000" scaled="1"/>
+            <a:tileRect/>
+          </a:gradFill>
+          <a:ln>
+            <a:noFill/>
+          </a:ln>
+        </p:spPr>
+        <p:txBody>
+          <a:bodyPr vert="horz" wrap="square" lIns="68580" tIns="34290" rIns="68580" bIns="34290" numCol="1" spcCol="0" rtlCol="0" fromWordArt="0" anchor="t" anchorCtr="0" forceAA="0" compatLnSpc="1">
+            <a:noAutofit/>
+          </a:bodyPr>
+          <a:lstStyle/>
+          <a:p>
+            <a:pPr lvl="0" algn="l">
+              <a:buClrTx/>
+              <a:buSzTx/>
+              <a:buFontTx/>
+            </a:pPr>
+            <a:endParaRPr lang="zh-CN" altLang="en-US" sz="1350">
+              <a:cs typeface="微软雅黑" charset="-122"/>
+              <a:sym typeface="+mn-ea"/>
+            </a:endParaRPr>
+          </a:p>
+        </p:txBody>
+      </p:sp>
+      <p:sp>
+        <p:nvSpPr>
+          <p:cNvPr id="21" name="任意多边形: 形状 43"/>
+          <p:cNvSpPr/>
+          <p:nvPr userDrawn="1">
+            <p:custDataLst>
+              <p:tags r:id="rId11"/>
+            </p:custDataLst>
+          </p:nvPr>
+        </p:nvSpPr>
+        <p:spPr bwMode="auto">
+          <a:xfrm>
+            <a:off x="0" y="0"/>
+            <a:ext cx="854869" cy="1310355"/>
+          </a:xfrm>
+          <a:custGeom>
+            <a:avLst/>
+            <a:gdLst>
+              <a:gd name="T0" fmla="*/ 775 w 3269"/>
+              <a:gd name="T1" fmla="*/ 3824 h 3824"/>
+              <a:gd name="T2" fmla="*/ 3269 w 3269"/>
+              <a:gd name="T3" fmla="*/ 0 h 3824"/>
+              <a:gd name="T4" fmla="*/ 2494 w 3269"/>
+              <a:gd name="T5" fmla="*/ 0 h 3824"/>
+              <a:gd name="T6" fmla="*/ 0 w 3269"/>
+              <a:gd name="T7" fmla="*/ 3824 h 3824"/>
+              <a:gd name="T8" fmla="*/ 775 w 3269"/>
+              <a:gd name="T9" fmla="*/ 3824 h 3824"/>
+            </a:gdLst>
+            <a:ahLst/>
+            <a:cxnLst>
+              <a:cxn ang="0">
+                <a:pos x="T0" y="T1"/>
+              </a:cxn>
+              <a:cxn ang="0">
+                <a:pos x="T2" y="T3"/>
+              </a:cxn>
+              <a:cxn ang="0">
+                <a:pos x="T4" y="T5"/>
+              </a:cxn>
+              <a:cxn ang="0">
+                <a:pos x="T6" y="T7"/>
+              </a:cxn>
+              <a:cxn ang="0">
+                <a:pos x="T8" y="T9"/>
+              </a:cxn>
+            </a:cxnLst>
+            <a:rect l="0" t="0" r="r" b="b"/>
+            <a:pathLst>
+              <a:path w="1795" h="2751">
+                <a:moveTo>
+                  <a:pt x="1580" y="0"/>
+                </a:moveTo>
+                <a:lnTo>
+                  <a:pt x="1795" y="0"/>
+                </a:lnTo>
+                <a:lnTo>
+                  <a:pt x="0" y="2751"/>
+                </a:lnTo>
+                <a:lnTo>
+                  <a:pt x="0" y="2422"/>
+                </a:lnTo>
+                <a:lnTo>
+                  <a:pt x="1580" y="0"/>
+                </a:lnTo>
+                <a:close/>
+              </a:path>
+            </a:pathLst>
+          </a:custGeom>
+          <a:gradFill flip="none" rotWithShape="1">
+            <a:gsLst>
+              <a:gs pos="0">
+                <a:schemeClr val="accent1">
+                  <a:lumMod val="60000"/>
+                  <a:lumOff val="40000"/>
+                </a:schemeClr>
+              </a:gs>
+              <a:gs pos="100000">
+                <a:schemeClr val="accent1">
+                  <a:lumMod val="60000"/>
+                  <a:lumOff val="40000"/>
+                  <a:alpha val="0"/>
+                </a:schemeClr>
+              </a:gs>
+            </a:gsLst>
+            <a:lin ang="16200000" scaled="1"/>
+            <a:tileRect/>
+          </a:gradFill>
+          <a:ln>
+            <a:noFill/>
+          </a:ln>
+        </p:spPr>
+        <p:txBody>
+          <a:bodyPr vert="horz" wrap="square" lIns="68580" tIns="34290" rIns="68580" bIns="34290" numCol="1" anchor="t" anchorCtr="0" compatLnSpc="1">
+            <a:noAutofit/>
+          </a:bodyPr>
+          <a:lstStyle/>
+          <a:p>
+            <a:endParaRPr lang="zh-CN" altLang="en-US" sz="1350">
+              <a:cs typeface="微软雅黑" charset="-122"/>
+            </a:endParaRPr>
+          </a:p>
+        </p:txBody>
+      </p:sp>
+      <p:sp>
+        <p:nvSpPr>
+          <p:cNvPr id="11" name="任意多边形: 形状 12"/>
+          <p:cNvSpPr/>
+          <p:nvPr userDrawn="1">
+            <p:custDataLst>
+              <p:tags r:id="rId12"/>
+            </p:custDataLst>
+          </p:nvPr>
+        </p:nvSpPr>
+        <p:spPr bwMode="auto">
+          <a:xfrm flipH="1" flipV="1">
+            <a:off x="5940542" y="230029"/>
+            <a:ext cx="3203459" cy="4913471"/>
+          </a:xfrm>
+          <a:custGeom>
+            <a:avLst/>
+            <a:gdLst>
+              <a:gd name="connsiteX0" fmla="*/ 0 w 2974422"/>
+              <a:gd name="connsiteY0" fmla="*/ 4561506 h 4561506"/>
+              <a:gd name="connsiteX1" fmla="*/ 0 w 2974422"/>
+              <a:gd name="connsiteY1" fmla="*/ 0 h 4561506"/>
+              <a:gd name="connsiteX2" fmla="*/ 2974422 w 2974422"/>
+              <a:gd name="connsiteY2" fmla="*/ 0 h 4561506"/>
+            </a:gdLst>
+            <a:ahLst/>
+            <a:cxnLst>
+              <a:cxn ang="0">
+                <a:pos x="connsiteX0" y="connsiteY0"/>
+              </a:cxn>
+              <a:cxn ang="0">
+                <a:pos x="connsiteX1" y="connsiteY1"/>
+              </a:cxn>
+              <a:cxn ang="0">
+                <a:pos x="connsiteX2" y="connsiteY2"/>
+              </a:cxn>
+            </a:cxnLst>
+            <a:rect l="l" t="t" r="r" b="b"/>
+            <a:pathLst>
+              <a:path w="6726" h="10317">
+                <a:moveTo>
+                  <a:pt x="2821" y="0"/>
+                </a:moveTo>
+                <a:lnTo>
+                  <a:pt x="6726" y="0"/>
+                </a:lnTo>
+                <a:lnTo>
+                  <a:pt x="0" y="10317"/>
+                </a:lnTo>
+                <a:lnTo>
+                  <a:pt x="0" y="4326"/>
+                </a:lnTo>
+                <a:lnTo>
+                  <a:pt x="2821" y="0"/>
+                </a:lnTo>
+                <a:close/>
+              </a:path>
+            </a:pathLst>
+          </a:custGeom>
+          <a:gradFill flip="none" rotWithShape="1">
+            <a:gsLst>
+              <a:gs pos="0">
+                <a:schemeClr val="accent1">
+                  <a:lumMod val="60000"/>
+                  <a:lumOff val="40000"/>
+                  <a:alpha val="19000"/>
+                </a:schemeClr>
+              </a:gs>
+              <a:gs pos="100000">
+                <a:schemeClr val="accent1">
+                  <a:lumMod val="60000"/>
+                  <a:lumOff val="40000"/>
+                  <a:alpha val="0"/>
+                </a:schemeClr>
+              </a:gs>
+            </a:gsLst>
+            <a:lin ang="5400000" scaled="1"/>
+            <a:tileRect/>
+          </a:gradFill>
+          <a:ln>
+            <a:noFill/>
+          </a:ln>
+        </p:spPr>
+        <p:txBody>
+          <a:bodyPr vert="horz" wrap="square" lIns="68580" tIns="34290" rIns="68580" bIns="34290" numCol="1" anchor="t" anchorCtr="0" compatLnSpc="1">
+            <a:noAutofit/>
+          </a:bodyPr>
+          <a:lstStyle/>
+          <a:p>
+            <a:pPr lvl="0"/>
+            <a:endParaRPr lang="zh-CN" altLang="en-US" sz="1350">
+              <a:cs typeface="微软雅黑" charset="-122"/>
+            </a:endParaRPr>
+          </a:p>
+        </p:txBody>
+      </p:sp>
+      <p:sp>
+        <p:nvSpPr>
+          <p:cNvPr id="44" name="任意多边形: 形状 43"/>
+          <p:cNvSpPr/>
+          <p:nvPr userDrawn="1">
+            <p:custDataLst>
+              <p:tags r:id="rId13"/>
+            </p:custDataLst>
+          </p:nvPr>
+        </p:nvSpPr>
+        <p:spPr bwMode="auto">
+          <a:xfrm>
+            <a:off x="2461260" y="3529489"/>
+            <a:ext cx="918686" cy="1226344"/>
+          </a:xfrm>
+          <a:custGeom>
+            <a:avLst/>
+            <a:gdLst>
+              <a:gd name="T0" fmla="*/ 775 w 3269"/>
+              <a:gd name="T1" fmla="*/ 3824 h 3824"/>
+              <a:gd name="T2" fmla="*/ 3269 w 3269"/>
+              <a:gd name="T3" fmla="*/ 0 h 3824"/>
+              <a:gd name="T4" fmla="*/ 2494 w 3269"/>
+              <a:gd name="T5" fmla="*/ 0 h 3824"/>
+              <a:gd name="T6" fmla="*/ 0 w 3269"/>
+              <a:gd name="T7" fmla="*/ 3824 h 3824"/>
+              <a:gd name="T8" fmla="*/ 775 w 3269"/>
+              <a:gd name="T9" fmla="*/ 3824 h 3824"/>
+            </a:gdLst>
+            <a:ahLst/>
+            <a:cxnLst>
+              <a:cxn ang="0">
+                <a:pos x="T0" y="T1"/>
+              </a:cxn>
+              <a:cxn ang="0">
+                <a:pos x="T2" y="T3"/>
+              </a:cxn>
+              <a:cxn ang="0">
+                <a:pos x="T4" y="T5"/>
+              </a:cxn>
+              <a:cxn ang="0">
+                <a:pos x="T6" y="T7"/>
+              </a:cxn>
+              <a:cxn ang="0">
+                <a:pos x="T8" y="T9"/>
+              </a:cxn>
+            </a:cxnLst>
+            <a:rect l="0" t="0" r="r" b="b"/>
+            <a:pathLst>
+              <a:path w="8109" h="10819">
+                <a:moveTo>
+                  <a:pt x="7056" y="0"/>
+                </a:moveTo>
+                <a:lnTo>
+                  <a:pt x="8109" y="0"/>
+                </a:lnTo>
+                <a:lnTo>
+                  <a:pt x="1053" y="10819"/>
+                </a:lnTo>
+                <a:lnTo>
+                  <a:pt x="0" y="10819"/>
+                </a:lnTo>
+                <a:lnTo>
+                  <a:pt x="7056" y="0"/>
+                </a:lnTo>
+                <a:close/>
+              </a:path>
+            </a:pathLst>
+          </a:custGeom>
+          <a:gradFill flip="none" rotWithShape="1">
+            <a:gsLst>
+              <a:gs pos="0">
+                <a:schemeClr val="accent1">
+                  <a:lumMod val="60000"/>
+                  <a:lumOff val="40000"/>
+                </a:schemeClr>
+              </a:gs>
+              <a:gs pos="100000">
+                <a:schemeClr val="accent1">
+                  <a:lumMod val="60000"/>
+                  <a:lumOff val="40000"/>
+                  <a:alpha val="0"/>
+                </a:schemeClr>
+              </a:gs>
+            </a:gsLst>
+            <a:lin ang="16200000" scaled="1"/>
+            <a:tileRect/>
+          </a:gradFill>
+          <a:ln>
+            <a:noFill/>
+          </a:ln>
+        </p:spPr>
+        <p:txBody>
+          <a:bodyPr vert="horz" wrap="square" lIns="68580" tIns="34290" rIns="68580" bIns="34290" numCol="1" anchor="t" anchorCtr="0" compatLnSpc="1">
+            <a:noAutofit/>
+          </a:bodyPr>
+          <a:lstStyle/>
+          <a:p>
+            <a:endParaRPr lang="zh-CN" altLang="en-US" sz="1350">
+              <a:cs typeface="微软雅黑" charset="-122"/>
+            </a:endParaRPr>
+          </a:p>
+        </p:txBody>
+      </p:sp>
+      <p:sp>
+        <p:nvSpPr>
+          <p:cNvPr id="2" name="标题 1"/>
+          <p:cNvSpPr>
+            <a:spLocks noGrp="1"/>
+          </p:cNvSpPr>
+          <p:nvPr>
+            <p:ph type="ctrTitle"/>
+            <p:custDataLst>
+              <p:tags r:id="rId14"/>
+            </p:custDataLst>
+          </p:nvPr>
+        </p:nvSpPr>
+        <p:spPr>
+          <a:xfrm>
+            <a:off x="4772025" y="890588"/>
+            <a:ext cx="3943350" cy="1944529"/>
+          </a:xfrm>
+        </p:spPr>
+        <p:txBody>
+          <a:bodyPr wrap="square" anchor="b">
+            <a:normAutofit/>
+          </a:bodyPr>
+          <a:lstStyle>
+            <a:lvl1pPr algn="r">
+              <a:lnSpc>
+                <a:spcPct val="100000"/>
+              </a:lnSpc>
+              <a:defRPr sz="4500">
+                <a:solidFill>
+                  <a:schemeClr val="tx1"/>
+                </a:solidFill>
+              </a:defRPr>
+            </a:lvl1pPr>
+          </a:lstStyle>
+          <a:p>
+            <a:r>
+              <a:rPr lang="zh-CN" altLang="en-US" dirty="0"/>
+              <a:t>单击此处编辑母版标题样式</a:t>
+            </a:r>
+            <a:endParaRPr lang="zh-CN" altLang="en-US" dirty="0"/>
+          </a:p>
+        </p:txBody>
+      </p:sp>
+      <p:sp>
+        <p:nvSpPr>
+          <p:cNvPr id="3" name="副标题 2"/>
+          <p:cNvSpPr>
+            <a:spLocks noGrp="1"/>
+          </p:cNvSpPr>
+          <p:nvPr>
+            <p:ph type="subTitle" idx="1" hasCustomPrompt="1"/>
+            <p:custDataLst>
+              <p:tags r:id="rId15"/>
+            </p:custDataLst>
+          </p:nvPr>
+        </p:nvSpPr>
+        <p:spPr>
+          <a:xfrm>
+            <a:off x="4772025" y="3128486"/>
+            <a:ext cx="3943350" cy="729139"/>
+          </a:xfrm>
+        </p:spPr>
+        <p:txBody>
+          <a:bodyPr wrap="square" anchor="t" anchorCtr="0">
+            <a:normAutofit/>
+          </a:bodyPr>
+          <a:lstStyle>
+            <a:lvl1pPr marL="0" indent="0" algn="r">
+              <a:lnSpc>
+                <a:spcPct val="100000"/>
+              </a:lnSpc>
+              <a:buNone/>
+              <a:defRPr sz="1800">
+                <a:solidFill>
+                  <a:schemeClr val="tx1"/>
+                </a:solidFill>
+              </a:defRPr>
+            </a:lvl1pPr>
+            <a:lvl2pPr marL="342900" indent="0" algn="ctr">
+              <a:buNone/>
+              <a:defRPr sz="1500"/>
+            </a:lvl2pPr>
+            <a:lvl3pPr marL="685800" indent="0" algn="ctr">
+              <a:buNone/>
+              <a:defRPr sz="1350"/>
+            </a:lvl3pPr>
+            <a:lvl4pPr marL="1028700" indent="0" algn="ctr">
+              <a:buNone/>
+              <a:defRPr sz="1200"/>
+            </a:lvl4pPr>
+            <a:lvl5pPr marL="1371600" indent="0" algn="ctr">
+              <a:buNone/>
+              <a:defRPr sz="1200"/>
+            </a:lvl5pPr>
+            <a:lvl6pPr marL="1714500" indent="0" algn="ctr">
+              <a:buNone/>
+              <a:defRPr sz="1200"/>
+            </a:lvl6pPr>
+            <a:lvl7pPr marL="2057400" indent="0" algn="ctr">
+              <a:buNone/>
+              <a:defRPr sz="1200"/>
+            </a:lvl7pPr>
+            <a:lvl8pPr marL="2400300" indent="0" algn="ctr">
+              <a:buNone/>
+              <a:defRPr sz="1200"/>
+            </a:lvl8pPr>
+            <a:lvl9pPr marL="2743200" indent="0" algn="ctr">
+              <a:buNone/>
+              <a:defRPr sz="1200"/>
+            </a:lvl9pPr>
+          </a:lstStyle>
+          <a:p>
+            <a:r>
+              <a:rPr lang="zh-CN" altLang="en-US" dirty="0"/>
+              <a:t>单击此处编辑副标题</a:t>
+            </a:r>
+            <a:endParaRPr lang="zh-CN" altLang="en-US" dirty="0"/>
+          </a:p>
+        </p:txBody>
+      </p:sp>
+      <p:sp>
+        <p:nvSpPr>
+          <p:cNvPr id="4" name="日期占位符 3"/>
+          <p:cNvSpPr>
+            <a:spLocks noGrp="1"/>
+          </p:cNvSpPr>
+          <p:nvPr>
+            <p:ph type="dt" sz="half" idx="10"/>
+            <p:custDataLst>
+              <p:tags r:id="rId16"/>
+            </p:custDataLst>
+          </p:nvPr>
+        </p:nvSpPr>
+        <p:spPr/>
+        <p:txBody>
+          <a:bodyPr wrap="square">
+            <a:normAutofit/>
+          </a:bodyPr>
+          <a:lstStyle/>
+          <a:p>
+            <a:fld id="{5592522B-0F24-4480-B9DD-A9474A6880D6}" type="datetimeFigureOut">
+              <a:rPr lang="zh-CN" altLang="en-US" smtClean="0"/>
+            </a:fld>
+            <a:endParaRPr lang="zh-CN" altLang="en-US"/>
+          </a:p>
+        </p:txBody>
+      </p:sp>
+      <p:sp>
+        <p:nvSpPr>
+          <p:cNvPr id="5" name="页脚占位符 4"/>
+          <p:cNvSpPr>
+            <a:spLocks noGrp="1"/>
+          </p:cNvSpPr>
+          <p:nvPr>
+            <p:ph type="ftr" sz="quarter" idx="11"/>
+            <p:custDataLst>
+              <p:tags r:id="rId17"/>
+            </p:custDataLst>
+          </p:nvPr>
+        </p:nvSpPr>
+        <p:spPr/>
+        <p:txBody>
+          <a:bodyPr>
+            <a:normAutofit/>
+          </a:bodyPr>
+          <a:lstStyle/>
+          <a:p>
+            <a:endParaRPr lang="zh-CN" altLang="en-US" dirty="0"/>
+          </a:p>
+        </p:txBody>
+      </p:sp>
+      <p:sp>
+        <p:nvSpPr>
+          <p:cNvPr id="6" name="灯片编号占位符 5"/>
+          <p:cNvSpPr>
+            <a:spLocks noGrp="1"/>
+          </p:cNvSpPr>
+          <p:nvPr>
+            <p:ph type="sldNum" sz="quarter" idx="12"/>
+            <p:custDataLst>
+              <p:tags r:id="rId18"/>
+            </p:custDataLst>
+          </p:nvPr>
+        </p:nvSpPr>
+        <p:spPr>
+          <a:xfrm>
+            <a:off x="6457950" y="4767263"/>
+            <a:ext cx="2057400" cy="273844"/>
+          </a:xfrm>
+        </p:spPr>
+        <p:txBody>
+          <a:bodyPr wrap="square">
+            <a:normAutofit/>
+          </a:bodyPr>
+          <a:lstStyle/>
+          <a:p>
+            <a:fld id="{BE5F26B5-172A-4DC2-B0B7-181CFC56B87C}" type="slidenum">
+              <a:rPr lang="zh-CN" altLang="en-US" smtClean="0"/>
+            </a:fld>
+            <a:endParaRPr lang="zh-CN" altLang="en-US"/>
+          </a:p>
+        </p:txBody>
+      </p:sp>
+    </p:spTree>
   </p:cSld>
   <p:clrMapOvr>
     <a:masterClrMapping/>
@@ -754,6 +1954,7 @@
               <a:rPr lang="en-US"/>
               <a:t>Click to edit Master title style</a:t>
             </a:r>
+            <a:endParaRPr lang="en-US"/>
           </a:p>
         </p:txBody>
       </p:sp>
@@ -777,6 +1978,7 @@
               <a:rPr lang="en-US"/>
               <a:t>Click to edit Master text styles</a:t>
             </a:r>
+            <a:endParaRPr lang="en-US"/>
           </a:p>
           <a:p>
             <a:pPr lvl="1"/>
@@ -784,6 +1986,7 @@
               <a:rPr lang="en-US"/>
               <a:t>Second level</a:t>
             </a:r>
+            <a:endParaRPr lang="en-US"/>
           </a:p>
           <a:p>
             <a:pPr lvl="2"/>
@@ -791,6 +1994,7 @@
               <a:rPr lang="en-US"/>
               <a:t>Third level</a:t>
             </a:r>
+            <a:endParaRPr lang="en-US"/>
           </a:p>
           <a:p>
             <a:pPr lvl="3"/>
@@ -798,6 +2002,7 @@
               <a:rPr lang="en-US"/>
               <a:t>Fourth level</a:t>
             </a:r>
+            <a:endParaRPr lang="en-US"/>
           </a:p>
           <a:p>
             <a:pPr lvl="4"/>
@@ -805,6 +2010,7 @@
               <a:rPr lang="en-US"/>
               <a:t>Fifth level</a:t>
             </a:r>
+            <a:endParaRPr lang="en-US"/>
           </a:p>
         </p:txBody>
       </p:sp>
@@ -825,7 +2031,6 @@
           <a:p>
             <a:fld id="{241EB5C9-1307-BA42-ABA2-0BC069CD8E7F}" type="datetimeFigureOut">
               <a:rPr lang="en-US" smtClean="0"/>
-              <a:t>1/2/22</a:t>
             </a:fld>
             <a:endParaRPr lang="en-US"/>
           </a:p>
@@ -867,18 +2072,12 @@
           <a:p>
             <a:fld id="{C5EF2332-01BF-834F-8236-50238282D533}" type="slidenum">
               <a:rPr lang="en-US" smtClean="0"/>
-              <a:t>‹#›</a:t>
             </a:fld>
             <a:endParaRPr lang="en-US"/>
           </a:p>
         </p:txBody>
       </p:sp>
     </p:spTree>
-    <p:extLst>
-      <p:ext uri="{BB962C8B-B14F-4D97-AF65-F5344CB8AC3E}">
-        <p14:creationId xmlns:p14="http://schemas.microsoft.com/office/powerpoint/2010/main" val="338346009"/>
-      </p:ext>
-    </p:extLst>
   </p:cSld>
   <p:clrMapOvr>
     <a:masterClrMapping/>
@@ -931,6 +2130,7 @@
               <a:rPr lang="en-US"/>
               <a:t>Click to edit Master title style</a:t>
             </a:r>
+            <a:endParaRPr lang="en-US"/>
           </a:p>
         </p:txBody>
       </p:sp>
@@ -1050,6 +2250,7 @@
               <a:rPr lang="en-US"/>
               <a:t>Click to edit Master text styles</a:t>
             </a:r>
+            <a:endParaRPr lang="en-US"/>
           </a:p>
         </p:txBody>
       </p:sp>
@@ -1070,7 +2271,6 @@
           <a:p>
             <a:fld id="{241EB5C9-1307-BA42-ABA2-0BC069CD8E7F}" type="datetimeFigureOut">
               <a:rPr lang="en-US" smtClean="0"/>
-              <a:t>1/2/22</a:t>
             </a:fld>
             <a:endParaRPr lang="en-US"/>
           </a:p>
@@ -1112,18 +2312,12 @@
           <a:p>
             <a:fld id="{C5EF2332-01BF-834F-8236-50238282D533}" type="slidenum">
               <a:rPr lang="en-US" smtClean="0"/>
-              <a:t>‹#›</a:t>
             </a:fld>
             <a:endParaRPr lang="en-US"/>
           </a:p>
         </p:txBody>
       </p:sp>
     </p:spTree>
-    <p:extLst>
-      <p:ext uri="{BB962C8B-B14F-4D97-AF65-F5344CB8AC3E}">
-        <p14:creationId xmlns:p14="http://schemas.microsoft.com/office/powerpoint/2010/main" val="1073069076"/>
-      </p:ext>
-    </p:extLst>
   </p:cSld>
   <p:clrMapOvr>
     <a:masterClrMapping/>
@@ -1167,6 +2361,7 @@
               <a:rPr lang="en-US"/>
               <a:t>Click to edit Master title style</a:t>
             </a:r>
+            <a:endParaRPr lang="en-US"/>
           </a:p>
         </p:txBody>
       </p:sp>
@@ -1223,6 +2418,7 @@
               <a:rPr lang="en-US"/>
               <a:t>Click to edit Master text styles</a:t>
             </a:r>
+            <a:endParaRPr lang="en-US"/>
           </a:p>
           <a:p>
             <a:pPr lvl="1"/>
@@ -1230,6 +2426,7 @@
               <a:rPr lang="en-US"/>
               <a:t>Second level</a:t>
             </a:r>
+            <a:endParaRPr lang="en-US"/>
           </a:p>
           <a:p>
             <a:pPr lvl="2"/>
@@ -1237,6 +2434,7 @@
               <a:rPr lang="en-US"/>
               <a:t>Third level</a:t>
             </a:r>
+            <a:endParaRPr lang="en-US"/>
           </a:p>
           <a:p>
             <a:pPr lvl="3"/>
@@ -1244,6 +2442,7 @@
               <a:rPr lang="en-US"/>
               <a:t>Fourth level</a:t>
             </a:r>
+            <a:endParaRPr lang="en-US"/>
           </a:p>
           <a:p>
             <a:pPr lvl="4"/>
@@ -1251,6 +2450,7 @@
               <a:rPr lang="en-US"/>
               <a:t>Fifth level</a:t>
             </a:r>
+            <a:endParaRPr lang="en-US"/>
           </a:p>
         </p:txBody>
       </p:sp>
@@ -1307,6 +2507,7 @@
               <a:rPr lang="en-US"/>
               <a:t>Click to edit Master text styles</a:t>
             </a:r>
+            <a:endParaRPr lang="en-US"/>
           </a:p>
           <a:p>
             <a:pPr lvl="1"/>
@@ -1314,6 +2515,7 @@
               <a:rPr lang="en-US"/>
               <a:t>Second level</a:t>
             </a:r>
+            <a:endParaRPr lang="en-US"/>
           </a:p>
           <a:p>
             <a:pPr lvl="2"/>
@@ -1321,6 +2523,7 @@
               <a:rPr lang="en-US"/>
               <a:t>Third level</a:t>
             </a:r>
+            <a:endParaRPr lang="en-US"/>
           </a:p>
           <a:p>
             <a:pPr lvl="3"/>
@@ -1328,6 +2531,7 @@
               <a:rPr lang="en-US"/>
               <a:t>Fourth level</a:t>
             </a:r>
+            <a:endParaRPr lang="en-US"/>
           </a:p>
           <a:p>
             <a:pPr lvl="4"/>
@@ -1335,6 +2539,7 @@
               <a:rPr lang="en-US"/>
               <a:t>Fifth level</a:t>
             </a:r>
+            <a:endParaRPr lang="en-US"/>
           </a:p>
         </p:txBody>
       </p:sp>
@@ -1355,7 +2560,6 @@
           <a:p>
             <a:fld id="{241EB5C9-1307-BA42-ABA2-0BC069CD8E7F}" type="datetimeFigureOut">
               <a:rPr lang="en-US" smtClean="0"/>
-              <a:t>1/2/22</a:t>
             </a:fld>
             <a:endParaRPr lang="en-US"/>
           </a:p>
@@ -1397,18 +2601,12 @@
           <a:p>
             <a:fld id="{C5EF2332-01BF-834F-8236-50238282D533}" type="slidenum">
               <a:rPr lang="en-US" smtClean="0"/>
-              <a:t>‹#›</a:t>
             </a:fld>
             <a:endParaRPr lang="en-US"/>
           </a:p>
         </p:txBody>
       </p:sp>
     </p:spTree>
-    <p:extLst>
-      <p:ext uri="{BB962C8B-B14F-4D97-AF65-F5344CB8AC3E}">
-        <p14:creationId xmlns:p14="http://schemas.microsoft.com/office/powerpoint/2010/main" val="2619886245"/>
-      </p:ext>
-    </p:extLst>
   </p:cSld>
   <p:clrMapOvr>
     <a:masterClrMapping/>
@@ -1456,6 +2654,7 @@
               <a:rPr lang="en-US"/>
               <a:t>Click to edit Master title style</a:t>
             </a:r>
+            <a:endParaRPr lang="en-US"/>
           </a:p>
         </p:txBody>
       </p:sp>
@@ -1521,6 +2720,7 @@
               <a:rPr lang="en-US"/>
               <a:t>Click to edit Master text styles</a:t>
             </a:r>
+            <a:endParaRPr lang="en-US"/>
           </a:p>
         </p:txBody>
       </p:sp>
@@ -1577,6 +2777,7 @@
               <a:rPr lang="en-US"/>
               <a:t>Click to edit Master text styles</a:t>
             </a:r>
+            <a:endParaRPr lang="en-US"/>
           </a:p>
           <a:p>
             <a:pPr lvl="1"/>
@@ -1584,6 +2785,7 @@
               <a:rPr lang="en-US"/>
               <a:t>Second level</a:t>
             </a:r>
+            <a:endParaRPr lang="en-US"/>
           </a:p>
           <a:p>
             <a:pPr lvl="2"/>
@@ -1591,6 +2793,7 @@
               <a:rPr lang="en-US"/>
               <a:t>Third level</a:t>
             </a:r>
+            <a:endParaRPr lang="en-US"/>
           </a:p>
           <a:p>
             <a:pPr lvl="3"/>
@@ -1598,6 +2801,7 @@
               <a:rPr lang="en-US"/>
               <a:t>Fourth level</a:t>
             </a:r>
+            <a:endParaRPr lang="en-US"/>
           </a:p>
           <a:p>
             <a:pPr lvl="4"/>
@@ -1605,6 +2809,7 @@
               <a:rPr lang="en-US"/>
               <a:t>Fifth level</a:t>
             </a:r>
+            <a:endParaRPr lang="en-US"/>
           </a:p>
         </p:txBody>
       </p:sp>
@@ -1670,6 +2875,7 @@
               <a:rPr lang="en-US"/>
               <a:t>Click to edit Master text styles</a:t>
             </a:r>
+            <a:endParaRPr lang="en-US"/>
           </a:p>
         </p:txBody>
       </p:sp>
@@ -1726,6 +2932,7 @@
               <a:rPr lang="en-US"/>
               <a:t>Click to edit Master text styles</a:t>
             </a:r>
+            <a:endParaRPr lang="en-US"/>
           </a:p>
           <a:p>
             <a:pPr lvl="1"/>
@@ -1733,6 +2940,7 @@
               <a:rPr lang="en-US"/>
               <a:t>Second level</a:t>
             </a:r>
+            <a:endParaRPr lang="en-US"/>
           </a:p>
           <a:p>
             <a:pPr lvl="2"/>
@@ -1740,6 +2948,7 @@
               <a:rPr lang="en-US"/>
               <a:t>Third level</a:t>
             </a:r>
+            <a:endParaRPr lang="en-US"/>
           </a:p>
           <a:p>
             <a:pPr lvl="3"/>
@@ -1747,6 +2956,7 @@
               <a:rPr lang="en-US"/>
               <a:t>Fourth level</a:t>
             </a:r>
+            <a:endParaRPr lang="en-US"/>
           </a:p>
           <a:p>
             <a:pPr lvl="4"/>
@@ -1754,6 +2964,7 @@
               <a:rPr lang="en-US"/>
               <a:t>Fifth level</a:t>
             </a:r>
+            <a:endParaRPr lang="en-US"/>
           </a:p>
         </p:txBody>
       </p:sp>
@@ -1774,7 +2985,6 @@
           <a:p>
             <a:fld id="{241EB5C9-1307-BA42-ABA2-0BC069CD8E7F}" type="datetimeFigureOut">
               <a:rPr lang="en-US" smtClean="0"/>
-              <a:t>1/2/22</a:t>
             </a:fld>
             <a:endParaRPr lang="en-US"/>
           </a:p>
@@ -1816,18 +3026,12 @@
           <a:p>
             <a:fld id="{C5EF2332-01BF-834F-8236-50238282D533}" type="slidenum">
               <a:rPr lang="en-US" smtClean="0"/>
-              <a:t>‹#›</a:t>
             </a:fld>
             <a:endParaRPr lang="en-US"/>
           </a:p>
         </p:txBody>
       </p:sp>
     </p:spTree>
-    <p:extLst>
-      <p:ext uri="{BB962C8B-B14F-4D97-AF65-F5344CB8AC3E}">
-        <p14:creationId xmlns:p14="http://schemas.microsoft.com/office/powerpoint/2010/main" val="2535793967"/>
-      </p:ext>
-    </p:extLst>
   </p:cSld>
   <p:clrMapOvr>
     <a:masterClrMapping/>
@@ -1871,6 +3075,7 @@
               <a:rPr lang="en-US"/>
               <a:t>Click to edit Master title style</a:t>
             </a:r>
+            <a:endParaRPr lang="en-US"/>
           </a:p>
         </p:txBody>
       </p:sp>
@@ -1891,7 +3096,6 @@
           <a:p>
             <a:fld id="{241EB5C9-1307-BA42-ABA2-0BC069CD8E7F}" type="datetimeFigureOut">
               <a:rPr lang="en-US" smtClean="0"/>
-              <a:t>1/2/22</a:t>
             </a:fld>
             <a:endParaRPr lang="en-US"/>
           </a:p>
@@ -1933,18 +3137,12 @@
           <a:p>
             <a:fld id="{C5EF2332-01BF-834F-8236-50238282D533}" type="slidenum">
               <a:rPr lang="en-US" smtClean="0"/>
-              <a:t>‹#›</a:t>
             </a:fld>
             <a:endParaRPr lang="en-US"/>
           </a:p>
         </p:txBody>
       </p:sp>
     </p:spTree>
-    <p:extLst>
-      <p:ext uri="{BB962C8B-B14F-4D97-AF65-F5344CB8AC3E}">
-        <p14:creationId xmlns:p14="http://schemas.microsoft.com/office/powerpoint/2010/main" val="3472721253"/>
-      </p:ext>
-    </p:extLst>
   </p:cSld>
   <p:clrMapOvr>
     <a:masterClrMapping/>
@@ -1986,7 +3184,6 @@
           <a:p>
             <a:fld id="{241EB5C9-1307-BA42-ABA2-0BC069CD8E7F}" type="datetimeFigureOut">
               <a:rPr lang="en-US" smtClean="0"/>
-              <a:t>1/2/22</a:t>
             </a:fld>
             <a:endParaRPr lang="en-US"/>
           </a:p>
@@ -2028,18 +3225,12 @@
           <a:p>
             <a:fld id="{C5EF2332-01BF-834F-8236-50238282D533}" type="slidenum">
               <a:rPr lang="en-US" smtClean="0"/>
-              <a:t>‹#›</a:t>
             </a:fld>
             <a:endParaRPr lang="en-US"/>
           </a:p>
         </p:txBody>
       </p:sp>
     </p:spTree>
-    <p:extLst>
-      <p:ext uri="{BB962C8B-B14F-4D97-AF65-F5344CB8AC3E}">
-        <p14:creationId xmlns:p14="http://schemas.microsoft.com/office/powerpoint/2010/main" val="2130901097"/>
-      </p:ext>
-    </p:extLst>
   </p:cSld>
   <p:clrMapOvr>
     <a:masterClrMapping/>
@@ -2092,6 +3283,7 @@
               <a:rPr lang="en-US"/>
               <a:t>Click to edit Master title style</a:t>
             </a:r>
+            <a:endParaRPr lang="en-US"/>
           </a:p>
         </p:txBody>
       </p:sp>
@@ -2148,6 +3340,7 @@
               <a:rPr lang="en-US"/>
               <a:t>Click to edit Master text styles</a:t>
             </a:r>
+            <a:endParaRPr lang="en-US"/>
           </a:p>
           <a:p>
             <a:pPr lvl="1"/>
@@ -2155,6 +3348,7 @@
               <a:rPr lang="en-US"/>
               <a:t>Second level</a:t>
             </a:r>
+            <a:endParaRPr lang="en-US"/>
           </a:p>
           <a:p>
             <a:pPr lvl="2"/>
@@ -2162,6 +3356,7 @@
               <a:rPr lang="en-US"/>
               <a:t>Third level</a:t>
             </a:r>
+            <a:endParaRPr lang="en-US"/>
           </a:p>
           <a:p>
             <a:pPr lvl="3"/>
@@ -2169,6 +3364,7 @@
               <a:rPr lang="en-US"/>
               <a:t>Fourth level</a:t>
             </a:r>
+            <a:endParaRPr lang="en-US"/>
           </a:p>
           <a:p>
             <a:pPr lvl="4"/>
@@ -2176,6 +3372,7 @@
               <a:rPr lang="en-US"/>
               <a:t>Fifth level</a:t>
             </a:r>
+            <a:endParaRPr lang="en-US"/>
           </a:p>
         </p:txBody>
       </p:sp>
@@ -2241,6 +3438,7 @@
               <a:rPr lang="en-US"/>
               <a:t>Click to edit Master text styles</a:t>
             </a:r>
+            <a:endParaRPr lang="en-US"/>
           </a:p>
         </p:txBody>
       </p:sp>
@@ -2261,7 +3459,6 @@
           <a:p>
             <a:fld id="{241EB5C9-1307-BA42-ABA2-0BC069CD8E7F}" type="datetimeFigureOut">
               <a:rPr lang="en-US" smtClean="0"/>
-              <a:t>1/2/22</a:t>
             </a:fld>
             <a:endParaRPr lang="en-US"/>
           </a:p>
@@ -2303,18 +3500,12 @@
           <a:p>
             <a:fld id="{C5EF2332-01BF-834F-8236-50238282D533}" type="slidenum">
               <a:rPr lang="en-US" smtClean="0"/>
-              <a:t>‹#›</a:t>
             </a:fld>
             <a:endParaRPr lang="en-US"/>
           </a:p>
         </p:txBody>
       </p:sp>
     </p:spTree>
-    <p:extLst>
-      <p:ext uri="{BB962C8B-B14F-4D97-AF65-F5344CB8AC3E}">
-        <p14:creationId xmlns:p14="http://schemas.microsoft.com/office/powerpoint/2010/main" val="3540895647"/>
-      </p:ext>
-    </p:extLst>
   </p:cSld>
   <p:clrMapOvr>
     <a:masterClrMapping/>
@@ -2367,6 +3558,7 @@
               <a:rPr lang="en-US"/>
               <a:t>Click to edit Master title style</a:t>
             </a:r>
+            <a:endParaRPr lang="en-US"/>
           </a:p>
         </p:txBody>
       </p:sp>
@@ -2493,6 +3685,7 @@
               <a:rPr lang="en-US"/>
               <a:t>Click to edit Master text styles</a:t>
             </a:r>
+            <a:endParaRPr lang="en-US"/>
           </a:p>
         </p:txBody>
       </p:sp>
@@ -2513,7 +3706,6 @@
           <a:p>
             <a:fld id="{241EB5C9-1307-BA42-ABA2-0BC069CD8E7F}" type="datetimeFigureOut">
               <a:rPr lang="en-US" smtClean="0"/>
-              <a:t>1/2/22</a:t>
             </a:fld>
             <a:endParaRPr lang="en-US"/>
           </a:p>
@@ -2555,18 +3747,12 @@
           <a:p>
             <a:fld id="{C5EF2332-01BF-834F-8236-50238282D533}" type="slidenum">
               <a:rPr lang="en-US" smtClean="0"/>
-              <a:t>‹#›</a:t>
             </a:fld>
             <a:endParaRPr lang="en-US"/>
           </a:p>
         </p:txBody>
       </p:sp>
     </p:spTree>
-    <p:extLst>
-      <p:ext uri="{BB962C8B-B14F-4D97-AF65-F5344CB8AC3E}">
-        <p14:creationId xmlns:p14="http://schemas.microsoft.com/office/powerpoint/2010/main" val="3566899855"/>
-      </p:ext>
-    </p:extLst>
   </p:cSld>
   <p:clrMapOvr>
     <a:masterClrMapping/>
@@ -2575,7 +3761,7 @@
 </file>
 
 <file path=ppt/slideMasters/slideMaster1.xml><?xml version="1.0" encoding="utf-8"?>
-<p:sldMaster xmlns:a="http://schemas.openxmlformats.org/drawingml/2006/main" xmlns:p="http://schemas.openxmlformats.org/presentationml/2006/main" xmlns:r="http://schemas.openxmlformats.org/officeDocument/2006/relationships">
+<p:sldMaster xmlns:a="http://schemas.openxmlformats.org/drawingml/2006/main" xmlns:r="http://schemas.openxmlformats.org/officeDocument/2006/relationships" xmlns:p="http://schemas.openxmlformats.org/presentationml/2006/main">
   <p:cSld>
     <p:bg>
       <p:bgRef idx="1001">
@@ -2616,7 +3802,7 @@
           </a:prstGeom>
         </p:spPr>
         <p:txBody>
-          <a:bodyPr anchor="ctr" bIns="45720" lIns="91440" rIns="91440" rtlCol="0" tIns="45720" vert="horz">
+          <a:bodyPr vert="horz" lIns="91440" tIns="45720" rIns="91440" bIns="45720" rtlCol="0" anchor="ctr">
             <a:normAutofit/>
           </a:bodyPr>
           <a:lstStyle/>
@@ -2625,6 +3811,7 @@
               <a:rPr lang="en-US"/>
               <a:t>Click to edit Master title style</a:t>
             </a:r>
+            <a:endParaRPr lang="en-US"/>
           </a:p>
         </p:txBody>
       </p:sp>
@@ -2635,7 +3822,7 @@
             <a:spLocks noGrp="1"/>
           </p:cNvSpPr>
           <p:nvPr>
-            <p:ph idx="1" type="body"/>
+            <p:ph type="body" idx="1"/>
           </p:nvPr>
         </p:nvSpPr>
         <p:spPr>
@@ -2648,7 +3835,7 @@
           </a:prstGeom>
         </p:spPr>
         <p:txBody>
-          <a:bodyPr bIns="45720" lIns="91440" rIns="91440" rtlCol="0" tIns="45720" vert="horz">
+          <a:bodyPr vert="horz" lIns="91440" tIns="45720" rIns="91440" bIns="45720" rtlCol="0">
             <a:normAutofit/>
           </a:bodyPr>
           <a:lstStyle/>
@@ -2658,6 +3845,7 @@
               <a:rPr lang="en-US"/>
               <a:t>Click to edit Master text styles</a:t>
             </a:r>
+            <a:endParaRPr lang="en-US"/>
           </a:p>
           <a:p>
             <a:pPr lvl="1"/>
@@ -2665,6 +3853,7 @@
               <a:rPr lang="en-US"/>
               <a:t>Second level</a:t>
             </a:r>
+            <a:endParaRPr lang="en-US"/>
           </a:p>
           <a:p>
             <a:pPr lvl="2"/>
@@ -2672,6 +3861,7 @@
               <a:rPr lang="en-US"/>
               <a:t>Third level</a:t>
             </a:r>
+            <a:endParaRPr lang="en-US"/>
           </a:p>
           <a:p>
             <a:pPr lvl="3"/>
@@ -2679,6 +3869,7 @@
               <a:rPr lang="en-US"/>
               <a:t>Fourth level</a:t>
             </a:r>
+            <a:endParaRPr lang="en-US"/>
           </a:p>
           <a:p>
             <a:pPr lvl="4"/>
@@ -2686,6 +3877,7 @@
               <a:rPr lang="en-US"/>
               <a:t>Fifth level</a:t>
             </a:r>
+            <a:endParaRPr lang="en-US"/>
           </a:p>
         </p:txBody>
       </p:sp>
@@ -2696,7 +3888,7 @@
             <a:spLocks noGrp="1"/>
           </p:cNvSpPr>
           <p:nvPr>
-            <p:ph idx="2" sz="half" type="dt"/>
+            <p:ph type="dt" sz="half" idx="2"/>
           </p:nvPr>
         </p:nvSpPr>
         <p:spPr>
@@ -2709,7 +3901,7 @@
           </a:prstGeom>
         </p:spPr>
         <p:txBody>
-          <a:bodyPr anchor="ctr" bIns="45720" lIns="91440" rIns="91440" rtlCol="0" tIns="45720" vert="horz"/>
+          <a:bodyPr vert="horz" lIns="91440" tIns="45720" rIns="91440" bIns="45720" rtlCol="0" anchor="ctr"/>
           <a:lstStyle>
             <a:lvl1pPr algn="l">
               <a:defRPr sz="900">
@@ -2724,7 +3916,6 @@
           <a:p>
             <a:fld id="{241EB5C9-1307-BA42-ABA2-0BC069CD8E7F}" type="datetimeFigureOut">
               <a:rPr lang="en-US" smtClean="0"/>
-              <a:t>1/2/22</a:t>
             </a:fld>
             <a:endParaRPr lang="en-US"/>
           </a:p>
@@ -2737,7 +3928,7 @@
             <a:spLocks noGrp="1"/>
           </p:cNvSpPr>
           <p:nvPr>
-            <p:ph idx="3" sz="quarter" type="ftr"/>
+            <p:ph type="ftr" sz="quarter" idx="3"/>
           </p:nvPr>
         </p:nvSpPr>
         <p:spPr>
@@ -2750,7 +3941,7 @@
           </a:prstGeom>
         </p:spPr>
         <p:txBody>
-          <a:bodyPr anchor="ctr" bIns="45720" lIns="91440" rIns="91440" rtlCol="0" tIns="45720" vert="horz"/>
+          <a:bodyPr vert="horz" lIns="91440" tIns="45720" rIns="91440" bIns="45720" rtlCol="0" anchor="ctr"/>
           <a:lstStyle>
             <a:lvl1pPr algn="ctr">
               <a:defRPr sz="900">
@@ -2774,7 +3965,7 @@
             <a:spLocks noGrp="1"/>
           </p:cNvSpPr>
           <p:nvPr>
-            <p:ph idx="4" sz="quarter" type="sldNum"/>
+            <p:ph type="sldNum" sz="quarter" idx="4"/>
           </p:nvPr>
         </p:nvSpPr>
         <p:spPr>
@@ -2787,7 +3978,7 @@
           </a:prstGeom>
         </p:spPr>
         <p:txBody>
-          <a:bodyPr anchor="ctr" bIns="45720" lIns="91440" rIns="91440" rtlCol="0" tIns="45720" vert="horz"/>
+          <a:bodyPr vert="horz" lIns="91440" tIns="45720" rIns="91440" bIns="45720" rtlCol="0" anchor="ctr"/>
           <a:lstStyle>
             <a:lvl1pPr algn="r">
               <a:defRPr sz="900">
@@ -2802,20 +3993,14 @@
           <a:p>
             <a:fld id="{C5EF2332-01BF-834F-8236-50238282D533}" type="slidenum">
               <a:rPr lang="en-US" smtClean="0"/>
-              <a:t>‹#›</a:t>
             </a:fld>
             <a:endParaRPr lang="en-US"/>
           </a:p>
         </p:txBody>
       </p:sp>
     </p:spTree>
-    <p:extLst>
-      <p:ext uri="{BB962C8B-B14F-4D97-AF65-F5344CB8AC3E}">
-        <p14:creationId xmlns:p14="http://schemas.microsoft.com/office/powerpoint/2010/main" val="3676200875"/>
-      </p:ext>
-    </p:extLst>
   </p:cSld>
-  <p:clrMap accent1="accent1" accent2="accent2" accent3="accent3" accent4="accent4" accent5="accent5" accent6="accent6" bg1="lt1" bg2="lt2" folHlink="folHlink" hlink="hlink" tx1="dk1" tx2="dk2"/>
+  <p:clrMap bg1="lt1" tx1="dk1" bg2="lt2" tx2="dk2" accent1="accent1" accent2="accent2" accent3="accent3" accent4="accent4" accent5="accent5" accent6="accent6" hlink="hlink" folHlink="folHlink"/>
   <p:sldLayoutIdLst>
     <p:sldLayoutId id="2147483649" r:id="rId1"/>
     <p:sldLayoutId id="2147483650" r:id="rId2"/>
@@ -2831,12 +4016,12 @@
   </p:sldLayoutIdLst>
   <p:txStyles>
     <p:titleStyle>
-      <a:lvl1pPr algn="ctr" defTabSz="342900" eaLnBrk="1" hangingPunct="1" latinLnBrk="0" rtl="0">
+      <a:lvl1pPr algn="ctr" defTabSz="342900" rtl="0" eaLnBrk="1" latinLnBrk="0" hangingPunct="1">
         <a:spcBef>
           <a:spcPct val="0"/>
         </a:spcBef>
         <a:buNone/>
-        <a:defRPr kern="1200" sz="3300">
+        <a:defRPr sz="3300" kern="1200">
           <a:solidFill>
             <a:schemeClr val="tx1"/>
           </a:solidFill>
@@ -2847,13 +4032,13 @@
       </a:lvl1pPr>
     </p:titleStyle>
     <p:bodyStyle>
-      <a:lvl1pPr algn="l" defTabSz="342900" eaLnBrk="1" hangingPunct="1" indent="-342900" latinLnBrk="0" marL="342900" rtl="0">
+      <a:lvl1pPr marL="342900" indent="-342900" algn="l" defTabSz="342900" rtl="0" eaLnBrk="1" latinLnBrk="0" hangingPunct="1">
         <a:spcBef>
           <a:spcPct val="20000"/>
         </a:spcBef>
-        <a:buFont typeface="Arial"/>
+        <a:buFont typeface="Arial" panose="020B0604020202090204"/>
         <a:buChar char="•"/>
-        <a:defRPr kern="1200" sz="2400">
+        <a:defRPr sz="2400" kern="1200">
           <a:solidFill>
             <a:schemeClr val="tx1"/>
           </a:solidFill>
@@ -2862,13 +4047,13 @@
           <a:cs typeface="+mn-cs"/>
         </a:defRPr>
       </a:lvl1pPr>
-      <a:lvl2pPr algn="l" defTabSz="342900" eaLnBrk="1" hangingPunct="1" indent="-342900" latinLnBrk="0" marL="685800" rtl="0">
+      <a:lvl2pPr marL="685800" indent="-342900" algn="l" defTabSz="342900" rtl="0" eaLnBrk="1" latinLnBrk="0" hangingPunct="1">
         <a:spcBef>
           <a:spcPct val="20000"/>
         </a:spcBef>
-        <a:buFont typeface="Arial"/>
+        <a:buFont typeface="Arial" panose="020B0604020202090204"/>
         <a:buChar char="–"/>
-        <a:defRPr kern="1200" sz="2100">
+        <a:defRPr sz="2100" kern="1200">
           <a:solidFill>
             <a:schemeClr val="tx1"/>
           </a:solidFill>
@@ -2877,13 +4062,13 @@
           <a:cs typeface="+mn-cs"/>
         </a:defRPr>
       </a:lvl2pPr>
-      <a:lvl3pPr algn="l" defTabSz="342900" eaLnBrk="1" hangingPunct="1" indent="-342900" latinLnBrk="0" marL="1028700" rtl="0">
+      <a:lvl3pPr marL="1028700" indent="-342900" algn="l" defTabSz="342900" rtl="0" eaLnBrk="1" latinLnBrk="0" hangingPunct="1">
         <a:spcBef>
           <a:spcPct val="20000"/>
         </a:spcBef>
-        <a:buFont typeface="Arial"/>
+        <a:buFont typeface="Arial" panose="020B0604020202090204"/>
         <a:buChar char="•"/>
-        <a:defRPr kern="1200" sz="1800">
+        <a:defRPr sz="1800" kern="1200">
           <a:solidFill>
             <a:schemeClr val="tx1"/>
           </a:solidFill>
@@ -2892,13 +4077,13 @@
           <a:cs typeface="+mn-cs"/>
         </a:defRPr>
       </a:lvl3pPr>
-      <a:lvl4pPr algn="l" defTabSz="342900" eaLnBrk="1" hangingPunct="1" indent="-342900" latinLnBrk="0" marL="1371600" rtl="0">
+      <a:lvl4pPr marL="1371600" indent="-342900" algn="l" defTabSz="342900" rtl="0" eaLnBrk="1" latinLnBrk="0" hangingPunct="1">
         <a:spcBef>
           <a:spcPct val="20000"/>
         </a:spcBef>
-        <a:buFont typeface="Arial"/>
+        <a:buFont typeface="Arial" panose="020B0604020202090204"/>
         <a:buChar char="–"/>
-        <a:defRPr kern="1200" sz="1500">
+        <a:defRPr sz="1500" kern="1200">
           <a:solidFill>
             <a:schemeClr val="tx1"/>
           </a:solidFill>
@@ -2907,13 +4092,13 @@
           <a:cs typeface="+mn-cs"/>
         </a:defRPr>
       </a:lvl4pPr>
-      <a:lvl5pPr algn="l" defTabSz="342900" eaLnBrk="1" hangingPunct="1" indent="-342900" latinLnBrk="0" marL="1714500" rtl="0">
+      <a:lvl5pPr marL="1714500" indent="-342900" algn="l" defTabSz="342900" rtl="0" eaLnBrk="1" latinLnBrk="0" hangingPunct="1">
         <a:spcBef>
           <a:spcPct val="20000"/>
         </a:spcBef>
-        <a:buFont typeface="Arial"/>
+        <a:buFont typeface="Arial" panose="020B0604020202090204"/>
         <a:buChar char="»"/>
-        <a:defRPr kern="1200" sz="1500">
+        <a:defRPr sz="1500" kern="1200">
           <a:solidFill>
             <a:schemeClr val="tx1"/>
           </a:solidFill>
@@ -2922,13 +4107,13 @@
           <a:cs typeface="+mn-cs"/>
         </a:defRPr>
       </a:lvl5pPr>
-      <a:lvl6pPr algn="l" defTabSz="342900" eaLnBrk="1" hangingPunct="1" indent="-342900" latinLnBrk="0" marL="2057400" rtl="0">
+      <a:lvl6pPr marL="2057400" indent="-342900" algn="l" defTabSz="342900" rtl="0" eaLnBrk="1" latinLnBrk="0" hangingPunct="1">
         <a:spcBef>
           <a:spcPct val="20000"/>
         </a:spcBef>
-        <a:buFont typeface="Arial"/>
+        <a:buFont typeface="Arial" panose="020B0604020202090204"/>
         <a:buChar char="•"/>
-        <a:defRPr kern="1200" sz="1500">
+        <a:defRPr sz="1500" kern="1200">
           <a:solidFill>
             <a:schemeClr val="tx1"/>
           </a:solidFill>
@@ -2937,13 +4122,13 @@
           <a:cs typeface="+mn-cs"/>
         </a:defRPr>
       </a:lvl6pPr>
-      <a:lvl7pPr algn="l" defTabSz="342900" eaLnBrk="1" hangingPunct="1" indent="-342900" latinLnBrk="0" marL="2400300" rtl="0">
+      <a:lvl7pPr marL="2400300" indent="-342900" algn="l" defTabSz="342900" rtl="0" eaLnBrk="1" latinLnBrk="0" hangingPunct="1">
         <a:spcBef>
           <a:spcPct val="20000"/>
         </a:spcBef>
-        <a:buFont typeface="Arial"/>
+        <a:buFont typeface="Arial" panose="020B0604020202090204"/>
         <a:buChar char="•"/>
-        <a:defRPr kern="1200" sz="1500">
+        <a:defRPr sz="1500" kern="1200">
           <a:solidFill>
             <a:schemeClr val="tx1"/>
           </a:solidFill>
@@ -2952,13 +4137,13 @@
           <a:cs typeface="+mn-cs"/>
         </a:defRPr>
       </a:lvl7pPr>
-      <a:lvl8pPr algn="l" defTabSz="342900" eaLnBrk="1" hangingPunct="1" indent="-342900" latinLnBrk="0" marL="2743200" rtl="0">
+      <a:lvl8pPr marL="2743200" indent="-342900" algn="l" defTabSz="342900" rtl="0" eaLnBrk="1" latinLnBrk="0" hangingPunct="1">
         <a:spcBef>
           <a:spcPct val="20000"/>
         </a:spcBef>
-        <a:buFont typeface="Arial"/>
+        <a:buFont typeface="Arial" panose="020B0604020202090204"/>
         <a:buChar char="•"/>
-        <a:defRPr kern="1200" sz="1500">
+        <a:defRPr sz="1500" kern="1200">
           <a:solidFill>
             <a:schemeClr val="tx1"/>
           </a:solidFill>
@@ -2967,13 +4152,13 @@
           <a:cs typeface="+mn-cs"/>
         </a:defRPr>
       </a:lvl8pPr>
-      <a:lvl9pPr algn="l" defTabSz="342900" eaLnBrk="1" hangingPunct="1" indent="-342900" latinLnBrk="0" marL="3086100" rtl="0">
+      <a:lvl9pPr marL="3086100" indent="-342900" algn="l" defTabSz="342900" rtl="0" eaLnBrk="1" latinLnBrk="0" hangingPunct="1">
         <a:spcBef>
           <a:spcPct val="20000"/>
         </a:spcBef>
-        <a:buFont typeface="Arial"/>
+        <a:buFont typeface="Arial" panose="020B0604020202090204"/>
         <a:buChar char="•"/>
-        <a:defRPr kern="1200" sz="1500">
+        <a:defRPr sz="1500" kern="1200">
           <a:solidFill>
             <a:schemeClr val="tx1"/>
           </a:solidFill>
@@ -2987,8 +4172,8 @@
       <a:defPPr>
         <a:defRPr lang="en-US"/>
       </a:defPPr>
-      <a:lvl1pPr algn="l" defTabSz="342900" eaLnBrk="1" hangingPunct="1" latinLnBrk="0" marL="0" rtl="0">
-        <a:defRPr kern="1200" sz="1350">
+      <a:lvl1pPr marL="0" algn="l" defTabSz="342900" rtl="0" eaLnBrk="1" latinLnBrk="0" hangingPunct="1">
+        <a:defRPr sz="1350" kern="1200">
           <a:solidFill>
             <a:schemeClr val="tx1"/>
           </a:solidFill>
@@ -2997,8 +4182,8 @@
           <a:cs typeface="+mn-cs"/>
         </a:defRPr>
       </a:lvl1pPr>
-      <a:lvl2pPr algn="l" defTabSz="342900" eaLnBrk="1" hangingPunct="1" latinLnBrk="0" marL="342900" rtl="0">
-        <a:defRPr kern="1200" sz="1350">
+      <a:lvl2pPr marL="342900" algn="l" defTabSz="342900" rtl="0" eaLnBrk="1" latinLnBrk="0" hangingPunct="1">
+        <a:defRPr sz="1350" kern="1200">
           <a:solidFill>
             <a:schemeClr val="tx1"/>
           </a:solidFill>
@@ -3007,8 +4192,8 @@
           <a:cs typeface="+mn-cs"/>
         </a:defRPr>
       </a:lvl2pPr>
-      <a:lvl3pPr algn="l" defTabSz="342900" eaLnBrk="1" hangingPunct="1" latinLnBrk="0" marL="685800" rtl="0">
-        <a:defRPr kern="1200" sz="1350">
+      <a:lvl3pPr marL="685800" algn="l" defTabSz="342900" rtl="0" eaLnBrk="1" latinLnBrk="0" hangingPunct="1">
+        <a:defRPr sz="1350" kern="1200">
           <a:solidFill>
             <a:schemeClr val="tx1"/>
           </a:solidFill>
@@ -3017,8 +4202,8 @@
           <a:cs typeface="+mn-cs"/>
         </a:defRPr>
       </a:lvl3pPr>
-      <a:lvl4pPr algn="l" defTabSz="342900" eaLnBrk="1" hangingPunct="1" latinLnBrk="0" marL="1028700" rtl="0">
-        <a:defRPr kern="1200" sz="1350">
+      <a:lvl4pPr marL="1028700" algn="l" defTabSz="342900" rtl="0" eaLnBrk="1" latinLnBrk="0" hangingPunct="1">
+        <a:defRPr sz="1350" kern="1200">
           <a:solidFill>
             <a:schemeClr val="tx1"/>
           </a:solidFill>
@@ -3027,8 +4212,8 @@
           <a:cs typeface="+mn-cs"/>
         </a:defRPr>
       </a:lvl4pPr>
-      <a:lvl5pPr algn="l" defTabSz="342900" eaLnBrk="1" hangingPunct="1" latinLnBrk="0" marL="1371600" rtl="0">
-        <a:defRPr kern="1200" sz="1350">
+      <a:lvl5pPr marL="1371600" algn="l" defTabSz="342900" rtl="0" eaLnBrk="1" latinLnBrk="0" hangingPunct="1">
+        <a:defRPr sz="1350" kern="1200">
           <a:solidFill>
             <a:schemeClr val="tx1"/>
           </a:solidFill>
@@ -3037,8 +4222,8 @@
           <a:cs typeface="+mn-cs"/>
         </a:defRPr>
       </a:lvl5pPr>
-      <a:lvl6pPr algn="l" defTabSz="342900" eaLnBrk="1" hangingPunct="1" latinLnBrk="0" marL="1714500" rtl="0">
-        <a:defRPr kern="1200" sz="1350">
+      <a:lvl6pPr marL="1714500" algn="l" defTabSz="342900" rtl="0" eaLnBrk="1" latinLnBrk="0" hangingPunct="1">
+        <a:defRPr sz="1350" kern="1200">
           <a:solidFill>
             <a:schemeClr val="tx1"/>
           </a:solidFill>
@@ -3047,8 +4232,8 @@
           <a:cs typeface="+mn-cs"/>
         </a:defRPr>
       </a:lvl6pPr>
-      <a:lvl7pPr algn="l" defTabSz="342900" eaLnBrk="1" hangingPunct="1" latinLnBrk="0" marL="2057400" rtl="0">
-        <a:defRPr kern="1200" sz="1350">
+      <a:lvl7pPr marL="2057400" algn="l" defTabSz="342900" rtl="0" eaLnBrk="1" latinLnBrk="0" hangingPunct="1">
+        <a:defRPr sz="1350" kern="1200">
           <a:solidFill>
             <a:schemeClr val="tx1"/>
           </a:solidFill>
@@ -3057,8 +4242,8 @@
           <a:cs typeface="+mn-cs"/>
         </a:defRPr>
       </a:lvl7pPr>
-      <a:lvl8pPr algn="l" defTabSz="342900" eaLnBrk="1" hangingPunct="1" latinLnBrk="0" marL="2400300" rtl="0">
-        <a:defRPr kern="1200" sz="1350">
+      <a:lvl8pPr marL="2400300" algn="l" defTabSz="342900" rtl="0" eaLnBrk="1" latinLnBrk="0" hangingPunct="1">
+        <a:defRPr sz="1350" kern="1200">
           <a:solidFill>
             <a:schemeClr val="tx1"/>
           </a:solidFill>
@@ -3067,8 +4252,968 @@
           <a:cs typeface="+mn-cs"/>
         </a:defRPr>
       </a:lvl8pPr>
-      <a:lvl9pPr algn="l" defTabSz="342900" eaLnBrk="1" hangingPunct="1" latinLnBrk="0" marL="2743200" rtl="0">
-        <a:defRPr kern="1200" sz="1350">
+      <a:lvl9pPr marL="2743200" algn="l" defTabSz="342900" rtl="0" eaLnBrk="1" latinLnBrk="0" hangingPunct="1">
+        <a:defRPr sz="1350" kern="1200">
+          <a:solidFill>
+            <a:schemeClr val="tx1"/>
+          </a:solidFill>
+          <a:latin typeface="+mn-lt"/>
+          <a:ea typeface="+mn-ea"/>
+          <a:cs typeface="+mn-cs"/>
+        </a:defRPr>
+      </a:lvl9pPr>
+    </p:otherStyle>
+  </p:txStyles>
+</p:sldMaster>
+</file>
+
+<file path=ppt/slideMasters/slideMaster2.xml><?xml version="1.0" encoding="utf-8"?>
+<p:sldMaster xmlns:a="http://schemas.openxmlformats.org/drawingml/2006/main" xmlns:r="http://schemas.openxmlformats.org/officeDocument/2006/relationships" xmlns:p="http://schemas.openxmlformats.org/presentationml/2006/main">
+  <p:cSld>
+    <p:bg>
+      <p:bgRef idx="1001">
+        <a:schemeClr val="bg2"/>
+      </p:bgRef>
+    </p:bg>
+    <p:spTree>
+      <p:nvGrpSpPr>
+        <p:cNvPr id="1" name=""/>
+        <p:cNvGrpSpPr/>
+        <p:nvPr/>
+      </p:nvGrpSpPr>
+      <p:grpSpPr>
+        <a:xfrm>
+          <a:off x="0" y="0"/>
+          <a:ext cx="0" cy="0"/>
+          <a:chOff x="0" y="0"/>
+          <a:chExt cx="0" cy="0"/>
+        </a:xfrm>
+      </p:grpSpPr>
+      <p:sp>
+        <p:nvSpPr>
+          <p:cNvPr id="11" name="矩形 10"/>
+          <p:cNvSpPr/>
+          <p:nvPr userDrawn="1">
+            <p:custDataLst>
+              <p:tags r:id="rId2"/>
+            </p:custDataLst>
+          </p:nvPr>
+        </p:nvSpPr>
+        <p:spPr>
+          <a:xfrm>
+            <a:off x="0" y="-1905"/>
+            <a:ext cx="9144000" cy="185261"/>
+          </a:xfrm>
+          <a:prstGeom prst="rect">
+            <a:avLst/>
+          </a:prstGeom>
+          <a:gradFill>
+            <a:gsLst>
+              <a:gs pos="0">
+                <a:schemeClr val="accent1">
+                  <a:lumMod val="90000"/>
+                </a:schemeClr>
+              </a:gs>
+              <a:gs pos="100000">
+                <a:schemeClr val="accent1">
+                  <a:lumMod val="90000"/>
+                </a:schemeClr>
+              </a:gs>
+            </a:gsLst>
+            <a:lin ang="5400000" scaled="0"/>
+          </a:gradFill>
+          <a:ln>
+            <a:noFill/>
+          </a:ln>
+        </p:spPr>
+        <p:style>
+          <a:lnRef idx="2">
+            <a:schemeClr val="accent1">
+              <a:lumMod val="75000"/>
+            </a:schemeClr>
+          </a:lnRef>
+          <a:fillRef idx="1">
+            <a:schemeClr val="accent1"/>
+          </a:fillRef>
+          <a:effectRef idx="0">
+            <a:srgbClr val="FFFFFF"/>
+          </a:effectRef>
+          <a:fontRef idx="minor">
+            <a:schemeClr val="lt1"/>
+          </a:fontRef>
+        </p:style>
+        <p:txBody>
+          <a:bodyPr rtlCol="0" anchor="ctr"/>
+          <a:lstStyle/>
+          <a:p>
+            <a:pPr algn="ctr"/>
+            <a:endParaRPr lang="zh-CN" altLang="en-US" sz="1350">
+              <a:latin typeface="微软雅黑" charset="-122"/>
+              <a:cs typeface="微软雅黑" charset="-122"/>
+            </a:endParaRPr>
+          </a:p>
+        </p:txBody>
+      </p:sp>
+      <p:sp>
+        <p:nvSpPr>
+          <p:cNvPr id="13" name="矩形 12"/>
+          <p:cNvSpPr/>
+          <p:nvPr userDrawn="1">
+            <p:custDataLst>
+              <p:tags r:id="rId3"/>
+            </p:custDataLst>
+          </p:nvPr>
+        </p:nvSpPr>
+        <p:spPr>
+          <a:xfrm>
+            <a:off x="0" y="4902994"/>
+            <a:ext cx="9144000" cy="240506"/>
+          </a:xfrm>
+          <a:prstGeom prst="rect">
+            <a:avLst/>
+          </a:prstGeom>
+          <a:gradFill>
+            <a:gsLst>
+              <a:gs pos="0">
+                <a:schemeClr val="accent1">
+                  <a:lumMod val="90000"/>
+                </a:schemeClr>
+              </a:gs>
+              <a:gs pos="100000">
+                <a:schemeClr val="accent1">
+                  <a:lumMod val="90000"/>
+                </a:schemeClr>
+              </a:gs>
+            </a:gsLst>
+            <a:lin ang="5400000" scaled="0"/>
+          </a:gradFill>
+          <a:ln>
+            <a:noFill/>
+          </a:ln>
+        </p:spPr>
+        <p:style>
+          <a:lnRef idx="2">
+            <a:schemeClr val="accent1">
+              <a:lumMod val="75000"/>
+            </a:schemeClr>
+          </a:lnRef>
+          <a:fillRef idx="1">
+            <a:schemeClr val="accent1"/>
+          </a:fillRef>
+          <a:effectRef idx="0">
+            <a:srgbClr val="FFFFFF"/>
+          </a:effectRef>
+          <a:fontRef idx="minor">
+            <a:schemeClr val="lt1"/>
+          </a:fontRef>
+        </p:style>
+        <p:txBody>
+          <a:bodyPr rtlCol="0" anchor="ctr"/>
+          <a:lstStyle/>
+          <a:p>
+            <a:pPr algn="ctr"/>
+            <a:endParaRPr lang="zh-CN" altLang="en-US" sz="1350">
+              <a:latin typeface="微软雅黑" charset="-122"/>
+              <a:cs typeface="微软雅黑" charset="-122"/>
+            </a:endParaRPr>
+          </a:p>
+        </p:txBody>
+      </p:sp>
+      <p:sp>
+        <p:nvSpPr>
+          <p:cNvPr id="14" name="任意多边形: 形状 8"/>
+          <p:cNvSpPr/>
+          <p:nvPr userDrawn="1">
+            <p:custDataLst>
+              <p:tags r:id="rId4"/>
+            </p:custDataLst>
+          </p:nvPr>
+        </p:nvSpPr>
+        <p:spPr bwMode="auto">
+          <a:xfrm>
+            <a:off x="8526304" y="-5715"/>
+            <a:ext cx="316706" cy="370999"/>
+          </a:xfrm>
+          <a:custGeom>
+            <a:avLst/>
+            <a:gdLst>
+              <a:gd name="T0" fmla="*/ 775 w 3269"/>
+              <a:gd name="T1" fmla="*/ 3824 h 3824"/>
+              <a:gd name="T2" fmla="*/ 3269 w 3269"/>
+              <a:gd name="T3" fmla="*/ 0 h 3824"/>
+              <a:gd name="T4" fmla="*/ 2494 w 3269"/>
+              <a:gd name="T5" fmla="*/ 0 h 3824"/>
+              <a:gd name="T6" fmla="*/ 0 w 3269"/>
+              <a:gd name="T7" fmla="*/ 3824 h 3824"/>
+              <a:gd name="T8" fmla="*/ 775 w 3269"/>
+              <a:gd name="T9" fmla="*/ 3824 h 3824"/>
+            </a:gdLst>
+            <a:ahLst/>
+            <a:cxnLst>
+              <a:cxn ang="0">
+                <a:pos x="T0" y="T1"/>
+              </a:cxn>
+              <a:cxn ang="0">
+                <a:pos x="T2" y="T3"/>
+              </a:cxn>
+              <a:cxn ang="0">
+                <a:pos x="T4" y="T5"/>
+              </a:cxn>
+              <a:cxn ang="0">
+                <a:pos x="T6" y="T7"/>
+              </a:cxn>
+              <a:cxn ang="0">
+                <a:pos x="T8" y="T9"/>
+              </a:cxn>
+            </a:cxnLst>
+            <a:rect l="0" t="0" r="r" b="b"/>
+            <a:pathLst>
+              <a:path w="3269" h="3824">
+                <a:moveTo>
+                  <a:pt x="775" y="3824"/>
+                </a:moveTo>
+                <a:lnTo>
+                  <a:pt x="3269" y="0"/>
+                </a:lnTo>
+                <a:lnTo>
+                  <a:pt x="2494" y="0"/>
+                </a:lnTo>
+                <a:lnTo>
+                  <a:pt x="0" y="3824"/>
+                </a:lnTo>
+                <a:lnTo>
+                  <a:pt x="775" y="3824"/>
+                </a:lnTo>
+                <a:close/>
+              </a:path>
+            </a:pathLst>
+          </a:custGeom>
+          <a:gradFill flip="none" rotWithShape="1">
+            <a:gsLst>
+              <a:gs pos="0">
+                <a:schemeClr val="accent1">
+                  <a:lumMod val="60000"/>
+                  <a:lumOff val="40000"/>
+                </a:schemeClr>
+              </a:gs>
+              <a:gs pos="100000">
+                <a:schemeClr val="accent1">
+                  <a:lumMod val="60000"/>
+                  <a:lumOff val="40000"/>
+                  <a:alpha val="0"/>
+                </a:schemeClr>
+              </a:gs>
+            </a:gsLst>
+            <a:lin ang="16200000" scaled="1"/>
+            <a:tileRect/>
+          </a:gradFill>
+          <a:ln>
+            <a:noFill/>
+          </a:ln>
+        </p:spPr>
+        <p:txBody>
+          <a:bodyPr vert="horz" wrap="square" lIns="68580" tIns="34290" rIns="68580" bIns="34290" numCol="1" anchor="t" anchorCtr="0" compatLnSpc="1"/>
+          <a:lstStyle/>
+          <a:p>
+            <a:endParaRPr lang="zh-CN" altLang="en-US" sz="1350">
+              <a:latin typeface="微软雅黑" charset="-122"/>
+              <a:cs typeface="微软雅黑" charset="-122"/>
+            </a:endParaRPr>
+          </a:p>
+        </p:txBody>
+      </p:sp>
+      <p:sp>
+        <p:nvSpPr>
+          <p:cNvPr id="15" name="任意多边形: 形状 10"/>
+          <p:cNvSpPr/>
+          <p:nvPr userDrawn="1">
+            <p:custDataLst>
+              <p:tags r:id="rId5"/>
+            </p:custDataLst>
+          </p:nvPr>
+        </p:nvSpPr>
+        <p:spPr bwMode="auto">
+          <a:xfrm flipH="1" flipV="1">
+            <a:off x="8526304" y="0"/>
+            <a:ext cx="617696" cy="704374"/>
+          </a:xfrm>
+          <a:custGeom>
+            <a:avLst/>
+            <a:gdLst>
+              <a:gd name="T0" fmla="*/ 0 w 1151"/>
+              <a:gd name="T1" fmla="*/ 576 h 1312"/>
+              <a:gd name="T2" fmla="*/ 0 w 1151"/>
+              <a:gd name="T3" fmla="*/ 1312 h 1312"/>
+              <a:gd name="T4" fmla="*/ 296 w 1151"/>
+              <a:gd name="T5" fmla="*/ 1312 h 1312"/>
+              <a:gd name="T6" fmla="*/ 1151 w 1151"/>
+              <a:gd name="T7" fmla="*/ 0 h 1312"/>
+              <a:gd name="T8" fmla="*/ 376 w 1151"/>
+              <a:gd name="T9" fmla="*/ 0 h 1312"/>
+              <a:gd name="T10" fmla="*/ 0 w 1151"/>
+              <a:gd name="T11" fmla="*/ 576 h 1312"/>
+            </a:gdLst>
+            <a:ahLst/>
+            <a:cxnLst>
+              <a:cxn ang="0">
+                <a:pos x="T0" y="T1"/>
+              </a:cxn>
+              <a:cxn ang="0">
+                <a:pos x="T2" y="T3"/>
+              </a:cxn>
+              <a:cxn ang="0">
+                <a:pos x="T4" y="T5"/>
+              </a:cxn>
+              <a:cxn ang="0">
+                <a:pos x="T6" y="T7"/>
+              </a:cxn>
+              <a:cxn ang="0">
+                <a:pos x="T8" y="T9"/>
+              </a:cxn>
+              <a:cxn ang="0">
+                <a:pos x="T10" y="T11"/>
+              </a:cxn>
+            </a:cxnLst>
+            <a:rect l="0" t="0" r="r" b="b"/>
+            <a:pathLst>
+              <a:path w="1151" h="1312">
+                <a:moveTo>
+                  <a:pt x="0" y="576"/>
+                </a:moveTo>
+                <a:lnTo>
+                  <a:pt x="0" y="1312"/>
+                </a:lnTo>
+                <a:lnTo>
+                  <a:pt x="296" y="1312"/>
+                </a:lnTo>
+                <a:lnTo>
+                  <a:pt x="1151" y="0"/>
+                </a:lnTo>
+                <a:lnTo>
+                  <a:pt x="376" y="0"/>
+                </a:lnTo>
+                <a:lnTo>
+                  <a:pt x="0" y="576"/>
+                </a:lnTo>
+                <a:close/>
+              </a:path>
+            </a:pathLst>
+          </a:custGeom>
+          <a:gradFill flip="none" rotWithShape="1">
+            <a:gsLst>
+              <a:gs pos="0">
+                <a:schemeClr val="accent1">
+                  <a:lumMod val="60000"/>
+                  <a:lumOff val="40000"/>
+                </a:schemeClr>
+              </a:gs>
+              <a:gs pos="100000">
+                <a:schemeClr val="accent1">
+                  <a:lumMod val="60000"/>
+                  <a:lumOff val="40000"/>
+                  <a:alpha val="0"/>
+                </a:schemeClr>
+              </a:gs>
+            </a:gsLst>
+            <a:lin ang="5400000" scaled="1"/>
+            <a:tileRect/>
+          </a:gradFill>
+          <a:ln>
+            <a:noFill/>
+          </a:ln>
+        </p:spPr>
+        <p:txBody>
+          <a:bodyPr vert="horz" wrap="square" lIns="68580" tIns="34290" rIns="68580" bIns="34290" numCol="1" anchor="t" anchorCtr="0" compatLnSpc="1"/>
+          <a:lstStyle/>
+          <a:p>
+            <a:pPr lvl="0"/>
+            <a:endParaRPr lang="zh-CN" altLang="en-US" sz="1350">
+              <a:latin typeface="微软雅黑" charset="-122"/>
+              <a:cs typeface="微软雅黑" charset="-122"/>
+            </a:endParaRPr>
+          </a:p>
+        </p:txBody>
+      </p:sp>
+      <p:sp>
+        <p:nvSpPr>
+          <p:cNvPr id="2" name="标题占位符 1"/>
+          <p:cNvSpPr>
+            <a:spLocks noGrp="1"/>
+          </p:cNvSpPr>
+          <p:nvPr>
+            <p:ph type="title"/>
+            <p:custDataLst>
+              <p:tags r:id="rId6"/>
+            </p:custDataLst>
+          </p:nvPr>
+        </p:nvSpPr>
+        <p:spPr>
+          <a:xfrm>
+            <a:off x="521970" y="270000"/>
+            <a:ext cx="8100000" cy="540000"/>
+          </a:xfrm>
+          <a:prstGeom prst="rect">
+            <a:avLst/>
+          </a:prstGeom>
+        </p:spPr>
+        <p:txBody>
+          <a:bodyPr vert="horz" wrap="square" lIns="0" tIns="0" rIns="0" bIns="0" rtlCol="0" anchor="b">
+            <a:normAutofit/>
+          </a:bodyPr>
+          <a:lstStyle/>
+          <a:p>
+            <a:r>
+              <a:rPr lang="zh-CN" altLang="en-US" dirty="0"/>
+              <a:t>单击此处编辑母版标题样式</a:t>
+            </a:r>
+            <a:endParaRPr lang="zh-CN" altLang="en-US" dirty="0"/>
+          </a:p>
+        </p:txBody>
+      </p:sp>
+      <p:sp>
+        <p:nvSpPr>
+          <p:cNvPr id="3" name="文本占位符 2"/>
+          <p:cNvSpPr>
+            <a:spLocks noGrp="1"/>
+          </p:cNvSpPr>
+          <p:nvPr>
+            <p:ph type="body" idx="1"/>
+            <p:custDataLst>
+              <p:tags r:id="rId7"/>
+            </p:custDataLst>
+          </p:nvPr>
+        </p:nvSpPr>
+        <p:spPr>
+          <a:xfrm>
+            <a:off x="521970" y="976312"/>
+            <a:ext cx="8100000" cy="3655219"/>
+          </a:xfrm>
+          <a:prstGeom prst="rect">
+            <a:avLst/>
+          </a:prstGeom>
+        </p:spPr>
+        <p:txBody>
+          <a:bodyPr vert="horz" wrap="square" lIns="0" tIns="0" rIns="0" bIns="0" rtlCol="0">
+            <a:normAutofit/>
+          </a:bodyPr>
+          <a:lstStyle/>
+          <a:p>
+            <a:pPr lvl="0"/>
+            <a:r>
+              <a:rPr lang="zh-CN" altLang="en-US" dirty="0"/>
+              <a:t>单击此处编辑母版文本样式</a:t>
+            </a:r>
+            <a:endParaRPr lang="zh-CN" altLang="en-US" dirty="0"/>
+          </a:p>
+          <a:p>
+            <a:pPr lvl="1"/>
+            <a:r>
+              <a:rPr lang="zh-CN" altLang="en-US" dirty="0"/>
+              <a:t>第二级</a:t>
+            </a:r>
+            <a:endParaRPr lang="zh-CN" altLang="en-US" dirty="0"/>
+          </a:p>
+          <a:p>
+            <a:pPr lvl="2"/>
+            <a:r>
+              <a:rPr lang="zh-CN" altLang="en-US" dirty="0">
+                <a:sym typeface="+mn-ea"/>
+              </a:rPr>
+              <a:t>第</a:t>
+            </a:r>
+            <a:r>
+              <a:rPr lang="zh-CN" altLang="en-US" dirty="0"/>
+              <a:t>三级</a:t>
+            </a:r>
+            <a:endParaRPr lang="zh-CN" altLang="en-US" dirty="0"/>
+          </a:p>
+          <a:p>
+            <a:pPr lvl="3"/>
+            <a:r>
+              <a:rPr lang="zh-CN" altLang="en-US" dirty="0">
+                <a:sym typeface="+mn-ea"/>
+              </a:rPr>
+              <a:t>第</a:t>
+            </a:r>
+            <a:r>
+              <a:rPr lang="zh-CN" altLang="en-US" dirty="0"/>
+              <a:t>四级</a:t>
+            </a:r>
+            <a:endParaRPr lang="zh-CN" altLang="en-US" dirty="0"/>
+          </a:p>
+          <a:p>
+            <a:pPr lvl="4"/>
+            <a:r>
+              <a:rPr lang="zh-CN" altLang="en-US" dirty="0">
+                <a:sym typeface="+mn-ea"/>
+              </a:rPr>
+              <a:t>第</a:t>
+            </a:r>
+            <a:r>
+              <a:rPr lang="zh-CN" altLang="en-US" dirty="0"/>
+              <a:t>五级</a:t>
+            </a:r>
+            <a:endParaRPr lang="zh-CN" altLang="en-US" dirty="0"/>
+          </a:p>
+        </p:txBody>
+      </p:sp>
+      <p:sp>
+        <p:nvSpPr>
+          <p:cNvPr id="4" name="日期占位符 3"/>
+          <p:cNvSpPr>
+            <a:spLocks noGrp="1"/>
+          </p:cNvSpPr>
+          <p:nvPr>
+            <p:ph type="dt" sz="half" idx="2"/>
+            <p:custDataLst>
+              <p:tags r:id="rId8"/>
+            </p:custDataLst>
+          </p:nvPr>
+        </p:nvSpPr>
+        <p:spPr>
+          <a:xfrm>
+            <a:off x="521970" y="4767263"/>
+            <a:ext cx="2057400" cy="273844"/>
+          </a:xfrm>
+          <a:prstGeom prst="rect">
+            <a:avLst/>
+          </a:prstGeom>
+        </p:spPr>
+        <p:txBody>
+          <a:bodyPr vert="horz" wrap="square" lIns="91440" tIns="45720" rIns="91440" bIns="45720" rtlCol="0" anchor="ctr">
+            <a:normAutofit/>
+          </a:bodyPr>
+          <a:lstStyle>
+            <a:lvl1pPr algn="l">
+              <a:defRPr sz="900">
+                <a:solidFill>
+                  <a:schemeClr val="tx1">
+                    <a:tint val="75000"/>
+                  </a:schemeClr>
+                </a:solidFill>
+                <a:latin typeface="微软雅黑" charset="-122"/>
+                <a:cs typeface="微软雅黑" charset="-122"/>
+              </a:defRPr>
+            </a:lvl1pPr>
+          </a:lstStyle>
+          <a:p>
+            <a:fld id="{5592522B-0F24-4480-B9DD-A9474A6880D6}" type="datetimeFigureOut">
+              <a:rPr lang="zh-CN" altLang="en-US" smtClean="0"/>
+            </a:fld>
+            <a:endParaRPr lang="zh-CN" altLang="en-US"/>
+          </a:p>
+        </p:txBody>
+      </p:sp>
+      <p:sp>
+        <p:nvSpPr>
+          <p:cNvPr id="5" name="页脚占位符 4"/>
+          <p:cNvSpPr>
+            <a:spLocks noGrp="1"/>
+          </p:cNvSpPr>
+          <p:nvPr>
+            <p:ph type="ftr" sz="quarter" idx="3"/>
+            <p:custDataLst>
+              <p:tags r:id="rId9"/>
+            </p:custDataLst>
+          </p:nvPr>
+        </p:nvSpPr>
+        <p:spPr>
+          <a:xfrm>
+            <a:off x="3028950" y="4767263"/>
+            <a:ext cx="3086100" cy="273844"/>
+          </a:xfrm>
+          <a:prstGeom prst="rect">
+            <a:avLst/>
+          </a:prstGeom>
+        </p:spPr>
+        <p:txBody>
+          <a:bodyPr vert="horz" lIns="91440" tIns="45720" rIns="91440" bIns="45720" rtlCol="0" anchor="ctr">
+            <a:normAutofit/>
+          </a:bodyPr>
+          <a:lstStyle>
+            <a:lvl1pPr algn="ctr">
+              <a:defRPr sz="900">
+                <a:solidFill>
+                  <a:schemeClr val="tx1">
+                    <a:tint val="75000"/>
+                  </a:schemeClr>
+                </a:solidFill>
+                <a:latin typeface="微软雅黑" charset="-122"/>
+                <a:cs typeface="微软雅黑" charset="-122"/>
+              </a:defRPr>
+            </a:lvl1pPr>
+          </a:lstStyle>
+          <a:p>
+            <a:endParaRPr lang="zh-CN" altLang="en-US" dirty="0"/>
+          </a:p>
+        </p:txBody>
+      </p:sp>
+      <p:sp>
+        <p:nvSpPr>
+          <p:cNvPr id="6" name="灯片编号占位符 5"/>
+          <p:cNvSpPr>
+            <a:spLocks noGrp="1"/>
+          </p:cNvSpPr>
+          <p:nvPr>
+            <p:ph type="sldNum" sz="quarter" idx="4"/>
+            <p:custDataLst>
+              <p:tags r:id="rId10"/>
+            </p:custDataLst>
+          </p:nvPr>
+        </p:nvSpPr>
+        <p:spPr>
+          <a:xfrm>
+            <a:off x="6565487" y="4767263"/>
+            <a:ext cx="2057400" cy="273844"/>
+          </a:xfrm>
+          <a:prstGeom prst="rect">
+            <a:avLst/>
+          </a:prstGeom>
+        </p:spPr>
+        <p:txBody>
+          <a:bodyPr vert="horz" wrap="square" lIns="91440" tIns="45720" rIns="91440" bIns="45720" rtlCol="0" anchor="ctr">
+            <a:normAutofit/>
+          </a:bodyPr>
+          <a:lstStyle>
+            <a:lvl1pPr algn="r">
+              <a:defRPr sz="900">
+                <a:solidFill>
+                  <a:schemeClr val="tx1">
+                    <a:tint val="75000"/>
+                  </a:schemeClr>
+                </a:solidFill>
+                <a:latin typeface="微软雅黑" charset="-122"/>
+                <a:cs typeface="微软雅黑" charset="-122"/>
+              </a:defRPr>
+            </a:lvl1pPr>
+          </a:lstStyle>
+          <a:p>
+            <a:fld id="{BE5F26B5-172A-4DC2-B0B7-181CFC56B87C}" type="slidenum">
+              <a:rPr lang="zh-CN" altLang="en-US" smtClean="0"/>
+            </a:fld>
+            <a:endParaRPr lang="zh-CN" altLang="en-US"/>
+          </a:p>
+        </p:txBody>
+      </p:sp>
+      <p:sp>
+        <p:nvSpPr>
+          <p:cNvPr id="8" name="KSO_TEMPLATE" hidden="1"/>
+          <p:cNvSpPr/>
+          <p:nvPr userDrawn="1">
+            <p:custDataLst>
+              <p:tags r:id="rId11"/>
+            </p:custDataLst>
+          </p:nvPr>
+        </p:nvSpPr>
+        <p:spPr>
+          <a:xfrm>
+            <a:off x="0" y="0"/>
+            <a:ext cx="0" cy="0"/>
+          </a:xfrm>
+          <a:prstGeom prst="rect">
+            <a:avLst/>
+          </a:prstGeom>
+        </p:spPr>
+        <p:style>
+          <a:lnRef idx="2">
+            <a:schemeClr val="accent1">
+              <a:shade val="50000"/>
+            </a:schemeClr>
+          </a:lnRef>
+          <a:fillRef idx="1">
+            <a:schemeClr val="accent1"/>
+          </a:fillRef>
+          <a:effectRef idx="0">
+            <a:schemeClr val="accent1"/>
+          </a:effectRef>
+          <a:fontRef idx="minor">
+            <a:schemeClr val="lt1"/>
+          </a:fontRef>
+        </p:style>
+        <p:txBody>
+          <a:bodyPr rtlCol="0" anchor="ctr"/>
+          <a:p>
+            <a:pPr algn="ctr"/>
+            <a:endParaRPr lang="zh-CN" altLang="en-US" sz="1350"/>
+          </a:p>
+        </p:txBody>
+      </p:sp>
+    </p:spTree>
+  </p:cSld>
+  <p:clrMap bg1="dk1" tx1="lt1" bg2="dk2" tx2="lt2" accent1="accent1" accent2="accent2" accent3="accent3" accent4="accent4" accent5="accent5" accent6="accent6" hlink="hlink" folHlink="folHlink"/>
+  <p:sldLayoutIdLst>
+    <p:sldLayoutId id="2147483661" r:id="rId1"/>
+  </p:sldLayoutIdLst>
+  <p:txStyles>
+    <p:titleStyle>
+      <a:lvl1pPr algn="l" defTabSz="685800" rtl="0" eaLnBrk="1" latinLnBrk="0" hangingPunct="1">
+        <a:lnSpc>
+          <a:spcPct val="100000"/>
+        </a:lnSpc>
+        <a:spcBef>
+          <a:spcPct val="0"/>
+        </a:spcBef>
+        <a:buNone/>
+        <a:defRPr sz="2400" b="1" kern="1200">
+          <a:solidFill>
+            <a:schemeClr val="tx1"/>
+          </a:solidFill>
+          <a:latin typeface="微软雅黑" charset="-122"/>
+          <a:ea typeface="+mj-ea"/>
+          <a:cs typeface="微软雅黑" charset="-122"/>
+        </a:defRPr>
+      </a:lvl1pPr>
+    </p:titleStyle>
+    <p:bodyStyle>
+      <a:lvl1pPr marL="171450" indent="-171450" algn="l" defTabSz="685800" rtl="0" eaLnBrk="1" latinLnBrk="0" hangingPunct="1">
+        <a:lnSpc>
+          <a:spcPct val="130000"/>
+        </a:lnSpc>
+        <a:spcBef>
+          <a:spcPts val="750"/>
+        </a:spcBef>
+        <a:buFont typeface="Arial" panose="020B0604020202090204" pitchFamily="34" charset="0"/>
+        <a:buChar char="•"/>
+        <a:defRPr sz="1800" kern="1200">
+          <a:solidFill>
+            <a:schemeClr val="tx1"/>
+          </a:solidFill>
+          <a:latin typeface="微软雅黑" charset="-122"/>
+          <a:ea typeface="+mn-ea"/>
+          <a:cs typeface="微软雅黑" charset="-122"/>
+        </a:defRPr>
+      </a:lvl1pPr>
+      <a:lvl2pPr marL="403860" indent="-154940" algn="l" defTabSz="685800" rtl="0" eaLnBrk="1" latinLnBrk="0" hangingPunct="1">
+        <a:lnSpc>
+          <a:spcPct val="130000"/>
+        </a:lnSpc>
+        <a:spcBef>
+          <a:spcPts val="0"/>
+        </a:spcBef>
+        <a:buFont typeface="Arial" panose="020B0604020202090204" pitchFamily="34" charset="0"/>
+        <a:buChar char="•"/>
+        <a:defRPr sz="1500" kern="1200">
+          <a:solidFill>
+            <a:schemeClr val="tx1"/>
+          </a:solidFill>
+          <a:latin typeface="微软雅黑" charset="-122"/>
+          <a:ea typeface="+mn-ea"/>
+          <a:cs typeface="微软雅黑" charset="-122"/>
+        </a:defRPr>
+      </a:lvl2pPr>
+      <a:lvl3pPr marL="599440" indent="-121285" algn="l" defTabSz="685800" rtl="0" eaLnBrk="1" latinLnBrk="0" hangingPunct="1">
+        <a:lnSpc>
+          <a:spcPct val="130000"/>
+        </a:lnSpc>
+        <a:spcBef>
+          <a:spcPts val="0"/>
+        </a:spcBef>
+        <a:buFont typeface="Arial" panose="020B0604020202090204" pitchFamily="34" charset="0"/>
+        <a:buChar char="•"/>
+        <a:defRPr sz="1350" kern="1200">
+          <a:solidFill>
+            <a:schemeClr val="tx1"/>
+          </a:solidFill>
+          <a:latin typeface="微软雅黑" charset="-122"/>
+          <a:ea typeface="+mn-ea"/>
+          <a:cs typeface="微软雅黑" charset="-122"/>
+        </a:defRPr>
+      </a:lvl3pPr>
+      <a:lvl4pPr marL="772795" indent="-111760" algn="l" defTabSz="685800" rtl="0" eaLnBrk="1" latinLnBrk="0" hangingPunct="1">
+        <a:lnSpc>
+          <a:spcPct val="130000"/>
+        </a:lnSpc>
+        <a:spcBef>
+          <a:spcPts val="0"/>
+        </a:spcBef>
+        <a:buFont typeface="Arial" panose="020B0604020202090204" pitchFamily="34" charset="0"/>
+        <a:buChar char="•"/>
+        <a:defRPr sz="1200" kern="1200">
+          <a:solidFill>
+            <a:schemeClr val="tx1"/>
+          </a:solidFill>
+          <a:latin typeface="微软雅黑" charset="-122"/>
+          <a:ea typeface="+mn-ea"/>
+          <a:cs typeface="微软雅黑" charset="-122"/>
+        </a:defRPr>
+      </a:lvl4pPr>
+      <a:lvl5pPr marL="926465" indent="-95250" algn="l" defTabSz="685800" rtl="0" eaLnBrk="1" latinLnBrk="0" hangingPunct="1">
+        <a:lnSpc>
+          <a:spcPct val="130000"/>
+        </a:lnSpc>
+        <a:spcBef>
+          <a:spcPts val="0"/>
+        </a:spcBef>
+        <a:buFont typeface="Arial" panose="020B0604020202090204" pitchFamily="34" charset="0"/>
+        <a:buChar char="•"/>
+        <a:defRPr sz="1050" kern="1200">
+          <a:solidFill>
+            <a:schemeClr val="tx1"/>
+          </a:solidFill>
+          <a:latin typeface="微软雅黑" charset="-122"/>
+          <a:ea typeface="+mn-ea"/>
+          <a:cs typeface="微软雅黑" charset="-122"/>
+        </a:defRPr>
+      </a:lvl5pPr>
+      <a:lvl6pPr marL="1885950" indent="-171450" algn="l" defTabSz="685800" rtl="0" eaLnBrk="1" latinLnBrk="0" hangingPunct="1">
+        <a:lnSpc>
+          <a:spcPct val="90000"/>
+        </a:lnSpc>
+        <a:spcBef>
+          <a:spcPts val="375"/>
+        </a:spcBef>
+        <a:buFont typeface="Arial" panose="020B0604020202090204" pitchFamily="34" charset="0"/>
+        <a:buChar char="•"/>
+        <a:defRPr sz="1350" kern="1200">
+          <a:solidFill>
+            <a:schemeClr val="tx1"/>
+          </a:solidFill>
+          <a:latin typeface="+mn-lt"/>
+          <a:ea typeface="+mn-ea"/>
+          <a:cs typeface="+mn-cs"/>
+        </a:defRPr>
+      </a:lvl6pPr>
+      <a:lvl7pPr marL="2228850" indent="-171450" algn="l" defTabSz="685800" rtl="0" eaLnBrk="1" latinLnBrk="0" hangingPunct="1">
+        <a:lnSpc>
+          <a:spcPct val="90000"/>
+        </a:lnSpc>
+        <a:spcBef>
+          <a:spcPts val="375"/>
+        </a:spcBef>
+        <a:buFont typeface="Arial" panose="020B0604020202090204" pitchFamily="34" charset="0"/>
+        <a:buChar char="•"/>
+        <a:defRPr sz="1350" kern="1200">
+          <a:solidFill>
+            <a:schemeClr val="tx1"/>
+          </a:solidFill>
+          <a:latin typeface="+mn-lt"/>
+          <a:ea typeface="+mn-ea"/>
+          <a:cs typeface="+mn-cs"/>
+        </a:defRPr>
+      </a:lvl7pPr>
+      <a:lvl8pPr marL="2571750" indent="-171450" algn="l" defTabSz="685800" rtl="0" eaLnBrk="1" latinLnBrk="0" hangingPunct="1">
+        <a:lnSpc>
+          <a:spcPct val="90000"/>
+        </a:lnSpc>
+        <a:spcBef>
+          <a:spcPts val="375"/>
+        </a:spcBef>
+        <a:buFont typeface="Arial" panose="020B0604020202090204" pitchFamily="34" charset="0"/>
+        <a:buChar char="•"/>
+        <a:defRPr sz="1350" kern="1200">
+          <a:solidFill>
+            <a:schemeClr val="tx1"/>
+          </a:solidFill>
+          <a:latin typeface="+mn-lt"/>
+          <a:ea typeface="+mn-ea"/>
+          <a:cs typeface="+mn-cs"/>
+        </a:defRPr>
+      </a:lvl8pPr>
+      <a:lvl9pPr marL="2914650" indent="-171450" algn="l" defTabSz="685800" rtl="0" eaLnBrk="1" latinLnBrk="0" hangingPunct="1">
+        <a:lnSpc>
+          <a:spcPct val="90000"/>
+        </a:lnSpc>
+        <a:spcBef>
+          <a:spcPts val="375"/>
+        </a:spcBef>
+        <a:buFont typeface="Arial" panose="020B0604020202090204" pitchFamily="34" charset="0"/>
+        <a:buChar char="•"/>
+        <a:defRPr sz="1350" kern="1200">
+          <a:solidFill>
+            <a:schemeClr val="tx1"/>
+          </a:solidFill>
+          <a:latin typeface="+mn-lt"/>
+          <a:ea typeface="+mn-ea"/>
+          <a:cs typeface="+mn-cs"/>
+        </a:defRPr>
+      </a:lvl9pPr>
+    </p:bodyStyle>
+    <p:otherStyle>
+      <a:defPPr>
+        <a:defRPr lang="zh-CN"/>
+      </a:defPPr>
+      <a:lvl1pPr marL="0" algn="l" defTabSz="685800" rtl="0" eaLnBrk="1" latinLnBrk="0" hangingPunct="1">
+        <a:defRPr sz="1350" kern="1200">
+          <a:solidFill>
+            <a:schemeClr val="tx1"/>
+          </a:solidFill>
+          <a:latin typeface="+mn-lt"/>
+          <a:ea typeface="+mn-ea"/>
+          <a:cs typeface="+mn-cs"/>
+        </a:defRPr>
+      </a:lvl1pPr>
+      <a:lvl2pPr marL="342900" algn="l" defTabSz="685800" rtl="0" eaLnBrk="1" latinLnBrk="0" hangingPunct="1">
+        <a:defRPr sz="1350" kern="1200">
+          <a:solidFill>
+            <a:schemeClr val="tx1"/>
+          </a:solidFill>
+          <a:latin typeface="+mn-lt"/>
+          <a:ea typeface="+mn-ea"/>
+          <a:cs typeface="+mn-cs"/>
+        </a:defRPr>
+      </a:lvl2pPr>
+      <a:lvl3pPr marL="685800" algn="l" defTabSz="685800" rtl="0" eaLnBrk="1" latinLnBrk="0" hangingPunct="1">
+        <a:defRPr sz="1350" kern="1200">
+          <a:solidFill>
+            <a:schemeClr val="tx1"/>
+          </a:solidFill>
+          <a:latin typeface="+mn-lt"/>
+          <a:ea typeface="+mn-ea"/>
+          <a:cs typeface="+mn-cs"/>
+        </a:defRPr>
+      </a:lvl3pPr>
+      <a:lvl4pPr marL="1028700" algn="l" defTabSz="685800" rtl="0" eaLnBrk="1" latinLnBrk="0" hangingPunct="1">
+        <a:defRPr sz="1350" kern="1200">
+          <a:solidFill>
+            <a:schemeClr val="tx1"/>
+          </a:solidFill>
+          <a:latin typeface="+mn-lt"/>
+          <a:ea typeface="+mn-ea"/>
+          <a:cs typeface="+mn-cs"/>
+        </a:defRPr>
+      </a:lvl4pPr>
+      <a:lvl5pPr marL="1371600" algn="l" defTabSz="685800" rtl="0" eaLnBrk="1" latinLnBrk="0" hangingPunct="1">
+        <a:defRPr sz="1350" kern="1200">
+          <a:solidFill>
+            <a:schemeClr val="tx1"/>
+          </a:solidFill>
+          <a:latin typeface="+mn-lt"/>
+          <a:ea typeface="+mn-ea"/>
+          <a:cs typeface="+mn-cs"/>
+        </a:defRPr>
+      </a:lvl5pPr>
+      <a:lvl6pPr marL="1714500" algn="l" defTabSz="685800" rtl="0" eaLnBrk="1" latinLnBrk="0" hangingPunct="1">
+        <a:defRPr sz="1350" kern="1200">
+          <a:solidFill>
+            <a:schemeClr val="tx1"/>
+          </a:solidFill>
+          <a:latin typeface="+mn-lt"/>
+          <a:ea typeface="+mn-ea"/>
+          <a:cs typeface="+mn-cs"/>
+        </a:defRPr>
+      </a:lvl6pPr>
+      <a:lvl7pPr marL="2057400" algn="l" defTabSz="685800" rtl="0" eaLnBrk="1" latinLnBrk="0" hangingPunct="1">
+        <a:defRPr sz="1350" kern="1200">
+          <a:solidFill>
+            <a:schemeClr val="tx1"/>
+          </a:solidFill>
+          <a:latin typeface="+mn-lt"/>
+          <a:ea typeface="+mn-ea"/>
+          <a:cs typeface="+mn-cs"/>
+        </a:defRPr>
+      </a:lvl7pPr>
+      <a:lvl8pPr marL="2400300" algn="l" defTabSz="685800" rtl="0" eaLnBrk="1" latinLnBrk="0" hangingPunct="1">
+        <a:defRPr sz="1350" kern="1200">
+          <a:solidFill>
+            <a:schemeClr val="tx1"/>
+          </a:solidFill>
+          <a:latin typeface="+mn-lt"/>
+          <a:ea typeface="+mn-ea"/>
+          <a:cs typeface="+mn-cs"/>
+        </a:defRPr>
+      </a:lvl8pPr>
+      <a:lvl9pPr marL="2743200" algn="l" defTabSz="685800" rtl="0" eaLnBrk="1" latinLnBrk="0" hangingPunct="1">
+        <a:defRPr sz="1350" kern="1200">
           <a:solidFill>
             <a:schemeClr val="tx1"/>
           </a:solidFill>
@@ -3101,66 +5246,254 @@
       </p:grpSpPr>
       <p:sp>
         <p:nvSpPr>
-          <p:cNvPr id="2" name="Title 1"/>
-          <p:cNvSpPr>
-            <a:spLocks noGrp="1"/>
-          </p:cNvSpPr>
-          <p:nvPr>
-            <p:ph type="ctrTitle"/>
-          </p:nvPr>
-        </p:nvSpPr>
-        <p:spPr>
-          <a:xfrm>
-            <a:off x="685800" y="1597819"/>
-            <a:ext cx="7772400" cy="1102519"/>
-          </a:xfrm>
-        </p:spPr>
-        <p:txBody>
-          <a:bodyPr/>
-          <a:lstStyle/>
-          <a:p>
-            <a:pPr lvl="0" indent="0" marL="0">
-              <a:buNone/>
-            </a:pPr>
-            <a:r>
-              <a:rPr/>
-              <a:t>高速路高清摄像头蓝光检测</a:t>
-            </a:r>
-          </a:p>
-        </p:txBody>
-      </p:sp>
-      <p:sp>
-        <p:nvSpPr>
           <p:cNvPr id="3" name="Subtitle 2"/>
           <p:cNvSpPr>
             <a:spLocks noGrp="1"/>
           </p:cNvSpPr>
-          <p:nvPr>
-            <p:ph idx="1" type="subTitle"/>
-          </p:nvPr>
+          <p:nvPr/>
         </p:nvSpPr>
         <p:spPr>
           <a:xfrm>
             <a:off x="1371600" y="2914650"/>
             <a:ext cx="6400800" cy="1314450"/>
           </a:xfrm>
+          <a:prstGeom prst="rect">
+            <a:avLst/>
+          </a:prstGeom>
         </p:spPr>
         <p:txBody>
+          <a:bodyPr vert="horz" lIns="91440" tIns="45720" rIns="91440" bIns="45720" rtlCol="0">
+            <a:normAutofit/>
+          </a:bodyPr>
+          <a:lstStyle>
+            <a:lvl1pPr marL="0" indent="0" algn="ctr" defTabSz="342900" rtl="0" eaLnBrk="1" latinLnBrk="0" hangingPunct="1">
+              <a:spcBef>
+                <a:spcPct val="20000"/>
+              </a:spcBef>
+              <a:buFont typeface="Arial" panose="020B0604020202090204"/>
+              <a:buNone/>
+              <a:defRPr sz="2400" kern="1200">
+                <a:solidFill>
+                  <a:schemeClr val="tx1">
+                    <a:tint val="75000"/>
+                  </a:schemeClr>
+                </a:solidFill>
+                <a:latin typeface="+mn-lt"/>
+                <a:ea typeface="+mn-ea"/>
+                <a:cs typeface="+mn-cs"/>
+              </a:defRPr>
+            </a:lvl1pPr>
+            <a:lvl2pPr marL="342900" indent="0" algn="ctr" defTabSz="342900" rtl="0" eaLnBrk="1" latinLnBrk="0" hangingPunct="1">
+              <a:spcBef>
+                <a:spcPct val="20000"/>
+              </a:spcBef>
+              <a:buFont typeface="Arial" panose="020B0604020202090204"/>
+              <a:buNone/>
+              <a:defRPr sz="2100" kern="1200">
+                <a:solidFill>
+                  <a:schemeClr val="tx1">
+                    <a:tint val="75000"/>
+                  </a:schemeClr>
+                </a:solidFill>
+                <a:latin typeface="+mn-lt"/>
+                <a:ea typeface="+mn-ea"/>
+                <a:cs typeface="+mn-cs"/>
+              </a:defRPr>
+            </a:lvl2pPr>
+            <a:lvl3pPr marL="685800" indent="0" algn="ctr" defTabSz="342900" rtl="0" eaLnBrk="1" latinLnBrk="0" hangingPunct="1">
+              <a:spcBef>
+                <a:spcPct val="20000"/>
+              </a:spcBef>
+              <a:buFont typeface="Arial" panose="020B0604020202090204"/>
+              <a:buNone/>
+              <a:defRPr sz="1800" kern="1200">
+                <a:solidFill>
+                  <a:schemeClr val="tx1">
+                    <a:tint val="75000"/>
+                  </a:schemeClr>
+                </a:solidFill>
+                <a:latin typeface="+mn-lt"/>
+                <a:ea typeface="+mn-ea"/>
+                <a:cs typeface="+mn-cs"/>
+              </a:defRPr>
+            </a:lvl3pPr>
+            <a:lvl4pPr marL="1028700" indent="0" algn="ctr" defTabSz="342900" rtl="0" eaLnBrk="1" latinLnBrk="0" hangingPunct="1">
+              <a:spcBef>
+                <a:spcPct val="20000"/>
+              </a:spcBef>
+              <a:buFont typeface="Arial" panose="020B0604020202090204"/>
+              <a:buNone/>
+              <a:defRPr sz="1500" kern="1200">
+                <a:solidFill>
+                  <a:schemeClr val="tx1">
+                    <a:tint val="75000"/>
+                  </a:schemeClr>
+                </a:solidFill>
+                <a:latin typeface="+mn-lt"/>
+                <a:ea typeface="+mn-ea"/>
+                <a:cs typeface="+mn-cs"/>
+              </a:defRPr>
+            </a:lvl4pPr>
+            <a:lvl5pPr marL="1371600" indent="0" algn="ctr" defTabSz="342900" rtl="0" eaLnBrk="1" latinLnBrk="0" hangingPunct="1">
+              <a:spcBef>
+                <a:spcPct val="20000"/>
+              </a:spcBef>
+              <a:buFont typeface="Arial" panose="020B0604020202090204"/>
+              <a:buNone/>
+              <a:defRPr sz="1500" kern="1200">
+                <a:solidFill>
+                  <a:schemeClr val="tx1">
+                    <a:tint val="75000"/>
+                  </a:schemeClr>
+                </a:solidFill>
+                <a:latin typeface="+mn-lt"/>
+                <a:ea typeface="+mn-ea"/>
+                <a:cs typeface="+mn-cs"/>
+              </a:defRPr>
+            </a:lvl5pPr>
+            <a:lvl6pPr marL="1714500" indent="0" algn="ctr" defTabSz="342900" rtl="0" eaLnBrk="1" latinLnBrk="0" hangingPunct="1">
+              <a:spcBef>
+                <a:spcPct val="20000"/>
+              </a:spcBef>
+              <a:buFont typeface="Arial" panose="020B0604020202090204"/>
+              <a:buNone/>
+              <a:defRPr sz="1500" kern="1200">
+                <a:solidFill>
+                  <a:schemeClr val="tx1">
+                    <a:tint val="75000"/>
+                  </a:schemeClr>
+                </a:solidFill>
+                <a:latin typeface="+mn-lt"/>
+                <a:ea typeface="+mn-ea"/>
+                <a:cs typeface="+mn-cs"/>
+              </a:defRPr>
+            </a:lvl6pPr>
+            <a:lvl7pPr marL="2057400" indent="0" algn="ctr" defTabSz="342900" rtl="0" eaLnBrk="1" latinLnBrk="0" hangingPunct="1">
+              <a:spcBef>
+                <a:spcPct val="20000"/>
+              </a:spcBef>
+              <a:buFont typeface="Arial" panose="020B0604020202090204"/>
+              <a:buNone/>
+              <a:defRPr sz="1500" kern="1200">
+                <a:solidFill>
+                  <a:schemeClr val="tx1">
+                    <a:tint val="75000"/>
+                  </a:schemeClr>
+                </a:solidFill>
+                <a:latin typeface="+mn-lt"/>
+                <a:ea typeface="+mn-ea"/>
+                <a:cs typeface="+mn-cs"/>
+              </a:defRPr>
+            </a:lvl7pPr>
+            <a:lvl8pPr marL="2400300" indent="0" algn="ctr" defTabSz="342900" rtl="0" eaLnBrk="1" latinLnBrk="0" hangingPunct="1">
+              <a:spcBef>
+                <a:spcPct val="20000"/>
+              </a:spcBef>
+              <a:buFont typeface="Arial" panose="020B0604020202090204"/>
+              <a:buNone/>
+              <a:defRPr sz="1500" kern="1200">
+                <a:solidFill>
+                  <a:schemeClr val="tx1">
+                    <a:tint val="75000"/>
+                  </a:schemeClr>
+                </a:solidFill>
+                <a:latin typeface="+mn-lt"/>
+                <a:ea typeface="+mn-ea"/>
+                <a:cs typeface="+mn-cs"/>
+              </a:defRPr>
+            </a:lvl8pPr>
+            <a:lvl9pPr marL="2743200" indent="0" algn="ctr" defTabSz="342900" rtl="0" eaLnBrk="1" latinLnBrk="0" hangingPunct="1">
+              <a:spcBef>
+                <a:spcPct val="20000"/>
+              </a:spcBef>
+              <a:buFont typeface="Arial" panose="020B0604020202090204"/>
+              <a:buNone/>
+              <a:defRPr sz="1500" kern="1200">
+                <a:solidFill>
+                  <a:schemeClr val="tx1">
+                    <a:tint val="75000"/>
+                  </a:schemeClr>
+                </a:solidFill>
+                <a:latin typeface="+mn-lt"/>
+                <a:ea typeface="+mn-ea"/>
+                <a:cs typeface="+mn-cs"/>
+              </a:defRPr>
+            </a:lvl9pPr>
+          </a:lstStyle>
+          <a:p>
+            <a:pPr marL="0" lvl="0" indent="0">
+              <a:buNone/>
+            </a:pPr>
+            <a:endParaRPr>
+              <a:solidFill>
+                <a:schemeClr val="tx1"/>
+              </a:solidFill>
+            </a:endParaRPr>
+          </a:p>
+        </p:txBody>
+      </p:sp>
+      <p:sp>
+        <p:nvSpPr>
+          <p:cNvPr id="4" name="标题"/>
+          <p:cNvSpPr>
+            <a:spLocks noGrp="1"/>
+          </p:cNvSpPr>
+          <p:nvPr>
+            <p:ph type="ctrTitle"/>
+            <p:custDataLst>
+              <p:tags r:id="rId1"/>
+            </p:custDataLst>
+          </p:nvPr>
+        </p:nvSpPr>
+        <p:spPr/>
+        <p:txBody>
           <a:bodyPr/>
           <a:lstStyle/>
           <a:p>
-            <a:pPr lvl="0" indent="0" marL="0">
-              <a:buNone/>
-            </a:pPr>
-            <a:r>
-              <a:rPr/>
+            <a:r>
+              <a:rPr lang="zh-CN" altLang="zh-CN"/>
+              <a:t>高速路高清摄像头蓝光检测</a:t>
+            </a:r>
+            <a:endParaRPr lang="zh-CN" altLang="zh-CN"/>
+          </a:p>
+        </p:txBody>
+      </p:sp>
+      <p:sp>
+        <p:nvSpPr>
+          <p:cNvPr id="5" name="副标题"/>
+          <p:cNvSpPr>
+            <a:spLocks noGrp="1"/>
+          </p:cNvSpPr>
+          <p:nvPr>
+            <p:ph type="subTitle" idx="1"/>
+            <p:custDataLst>
+              <p:tags r:id="rId2"/>
+            </p:custDataLst>
+          </p:nvPr>
+        </p:nvSpPr>
+        <p:spPr/>
+        <p:txBody>
+          <a:bodyPr/>
+          <a:lstStyle/>
+          <a:p>
+            <a:r>
+              <a:rPr>
+                <a:sym typeface="+mn-ea"/>
+              </a:rPr>
               <a:t>问题理解与算法实现</a:t>
             </a:r>
+            <a:endParaRPr lang="zh-CN" altLang="en-US"/>
           </a:p>
         </p:txBody>
       </p:sp>
     </p:spTree>
+    <p:custDataLst>
+      <p:tags r:id="rId3"/>
+    </p:custDataLst>
   </p:cSld>
+  <p:clrMapOvr>
+    <a:masterClrMapping/>
+  </p:clrMapOvr>
 </p:sld>
 </file>
 
@@ -3196,11 +5529,10 @@
           <a:bodyPr/>
           <a:lstStyle/>
           <a:p>
-            <a:pPr lvl="0" indent="0" marL="0">
+            <a:pPr marL="0" lvl="0" indent="0">
               <a:buNone/>
             </a:pPr>
             <a:r>
-              <a:rPr/>
               <a:t>方案特点</a:t>
             </a:r>
           </a:p>
@@ -3223,35 +5555,30 @@
           <a:p>
             <a:pPr lvl="0"/>
             <a:r>
-              <a:rPr/>
               <a:t>车辆优先，避免全图亮点误检</a:t>
             </a:r>
           </a:p>
           <a:p>
             <a:pPr lvl="0"/>
             <a:r>
-              <a:rPr/>
               <a:t>同时识别车灯蓝光和车辆反光蓝光</a:t>
             </a:r>
           </a:p>
           <a:p>
             <a:pPr lvl="0"/>
             <a:r>
-              <a:rPr/>
               <a:t>能补足远处车灯明显但车身较暗的小车</a:t>
             </a:r>
           </a:p>
           <a:p>
             <a:pPr lvl="0"/>
             <a:r>
-              <a:rPr/>
               <a:t>通过车身结构验证过滤地面、路牌、灯箱等干扰</a:t>
             </a:r>
           </a:p>
           <a:p>
             <a:pPr lvl="0"/>
             <a:r>
-              <a:rPr/>
               <a:t>算法轻量，适合课程作业演示和本地图片检测</a:t>
             </a:r>
           </a:p>
@@ -3259,6 +5586,9 @@
       </p:sp>
     </p:spTree>
   </p:cSld>
+  <p:clrMapOvr>
+    <a:masterClrMapping/>
+  </p:clrMapOvr>
 </p:sld>
 </file>
 
@@ -3294,11 +5624,10 @@
           <a:bodyPr/>
           <a:lstStyle/>
           <a:p>
-            <a:pPr lvl="0" indent="0" marL="0">
+            <a:pPr marL="0" lvl="0" indent="0">
               <a:buNone/>
             </a:pPr>
             <a:r>
-              <a:rPr/>
               <a:t>题目背景</a:t>
             </a:r>
           </a:p>
@@ -3321,28 +5650,24 @@
           <a:p>
             <a:pPr lvl="0"/>
             <a:r>
-              <a:rPr/>
               <a:t>高速卡口、龙门架、隧道等场景会采集车辆图像或视频帧</a:t>
             </a:r>
           </a:p>
           <a:p>
             <a:pPr lvl="0"/>
             <a:r>
-              <a:rPr/>
               <a:t>夜间、逆光、雨雾条件下，车辆灯光和反光更明显</a:t>
             </a:r>
           </a:p>
           <a:p>
             <a:pPr lvl="0"/>
             <a:r>
-              <a:rPr/>
               <a:t>画面中同时存在车灯蓝光、车身反光蓝光、号牌补光蓝光</a:t>
             </a:r>
           </a:p>
           <a:p>
             <a:pPr lvl="0"/>
             <a:r>
-              <a:rPr/>
               <a:t>路牌、路灯、屏幕、地面反射也会形成虚假蓝光干扰</a:t>
             </a:r>
           </a:p>
@@ -3350,6 +5675,9 @@
       </p:sp>
     </p:spTree>
   </p:cSld>
+  <p:clrMapOvr>
+    <a:masterClrMapping/>
+  </p:clrMapOvr>
 </p:sld>
 </file>
 
@@ -3385,11 +5713,10 @@
           <a:bodyPr/>
           <a:lstStyle/>
           <a:p>
-            <a:pPr lvl="0" indent="0" marL="0">
+            <a:pPr marL="0" lvl="0" indent="0">
               <a:buNone/>
             </a:pPr>
             <a:r>
-              <a:rPr/>
               <a:t>核心任务</a:t>
             </a:r>
           </a:p>
@@ -3412,35 +5739,30 @@
           <a:p>
             <a:pPr lvl="0"/>
             <a:r>
-              <a:rPr/>
               <a:t>检测画面中的车辆目标</a:t>
             </a:r>
           </a:p>
           <a:p>
             <a:pPr lvl="0"/>
             <a:r>
-              <a:rPr/>
               <a:t>找到车辆相关的蓝光区域</a:t>
             </a:r>
           </a:p>
           <a:p>
             <a:pPr lvl="0"/>
             <a:r>
-              <a:rPr/>
               <a:t>区分两类车辆蓝光：车灯蓝光、反光蓝光</a:t>
             </a:r>
           </a:p>
           <a:p>
             <a:pPr lvl="0"/>
             <a:r>
-              <a:rPr/>
               <a:t>过滤非车辆产生的环境干扰蓝光</a:t>
             </a:r>
           </a:p>
           <a:p>
             <a:pPr lvl="0"/>
             <a:r>
-              <a:rPr/>
               <a:t>输出车辆框、蓝光区域框、来源分类和统计信息</a:t>
             </a:r>
           </a:p>
@@ -3448,6 +5770,9 @@
       </p:sp>
     </p:spTree>
   </p:cSld>
+  <p:clrMapOvr>
+    <a:masterClrMapping/>
+  </p:clrMapOvr>
 </p:sld>
 </file>
 
@@ -3483,11 +5808,10 @@
           <a:bodyPr/>
           <a:lstStyle/>
           <a:p>
-            <a:pPr lvl="0" indent="0" marL="0">
+            <a:pPr marL="0" lvl="0" indent="0">
               <a:buNone/>
             </a:pPr>
             <a:r>
-              <a:rPr/>
               <a:t>主要难点</a:t>
             </a:r>
           </a:p>
@@ -3510,28 +5834,24 @@
           <a:p>
             <a:pPr lvl="0"/>
             <a:r>
-              <a:rPr/>
               <a:t>远处车辆车身很暗，YOLO 可能漏检</a:t>
             </a:r>
           </a:p>
           <a:p>
             <a:pPr lvl="0"/>
             <a:r>
-              <a:rPr/>
               <a:t>单纯找亮点会把路灯、路牌、地面标线全部检出</a:t>
             </a:r>
           </a:p>
           <a:p>
             <a:pPr lvl="0"/>
             <a:r>
-              <a:rPr/>
               <a:t>车身反光属于车辆蓝光，但不能和车灯蓝光混为一类</a:t>
             </a:r>
           </a:p>
           <a:p>
             <a:pPr lvl="0"/>
             <a:r>
-              <a:rPr/>
               <a:t>路面、柱体、屏幕反光虽然很亮，但不属于车辆蓝光</a:t>
             </a:r>
           </a:p>
@@ -3539,6 +5859,9 @@
       </p:sp>
     </p:spTree>
   </p:cSld>
+  <p:clrMapOvr>
+    <a:masterClrMapping/>
+  </p:clrMapOvr>
 </p:sld>
 </file>
 
@@ -3574,11 +5897,10 @@
           <a:bodyPr/>
           <a:lstStyle/>
           <a:p>
-            <a:pPr lvl="0" indent="0" marL="0">
+            <a:pPr marL="0" lvl="0" indent="0">
               <a:buNone/>
             </a:pPr>
             <a:r>
-              <a:rPr/>
               <a:t>总体算法流程</a:t>
             </a:r>
           </a:p>
@@ -3601,35 +5923,30 @@
           <a:p>
             <a:pPr lvl="0"/>
             <a:r>
-              <a:rPr/>
               <a:t>图像预处理：去噪、亮度增强、提升夜间局部对比度</a:t>
             </a:r>
           </a:p>
           <a:p>
             <a:pPr lvl="0"/>
             <a:r>
-              <a:rPr/>
               <a:t>车辆检测：使用 YOLOv8n 检测明显车辆</a:t>
             </a:r>
           </a:p>
           <a:p>
             <a:pPr lvl="0"/>
             <a:r>
-              <a:rPr/>
               <a:t>蓝光候选提取：从亮度和局部对比度中提取高亮光斑</a:t>
             </a:r>
           </a:p>
           <a:p>
             <a:pPr lvl="0"/>
             <a:r>
-              <a:rPr/>
               <a:t>车辆补检：用成对车灯反推远处小车候选</a:t>
             </a:r>
           </a:p>
           <a:p>
             <a:pPr lvl="0"/>
             <a:r>
-              <a:rPr/>
               <a:t>来源分类：判断车灯蓝光、反光蓝光或环境干扰</a:t>
             </a:r>
           </a:p>
@@ -3637,6 +5954,9 @@
       </p:sp>
     </p:spTree>
   </p:cSld>
+  <p:clrMapOvr>
+    <a:masterClrMapping/>
+  </p:clrMapOvr>
 </p:sld>
 </file>
 
@@ -3672,11 +5992,10 @@
           <a:bodyPr/>
           <a:lstStyle/>
           <a:p>
-            <a:pPr lvl="0" indent="0" marL="0">
+            <a:pPr marL="0" lvl="0" indent="0">
               <a:buNone/>
             </a:pPr>
             <a:r>
-              <a:rPr/>
               <a:t>图像预处理与蓝光候选</a:t>
             </a:r>
           </a:p>
@@ -3699,35 +6018,30 @@
           <a:p>
             <a:pPr lvl="0"/>
             <a:r>
-              <a:rPr/>
               <a:t>对输入图像进行高斯滤波，降低噪声</a:t>
             </a:r>
           </a:p>
           <a:p>
             <a:pPr lvl="0"/>
             <a:r>
-              <a:rPr/>
               <a:t>在 LAB 空间对亮度通道做 CLAHE 增强</a:t>
             </a:r>
           </a:p>
           <a:p>
             <a:pPr lvl="0"/>
             <a:r>
-              <a:rPr/>
               <a:t>根据灰度亮度分位数提取高亮区域</a:t>
             </a:r>
           </a:p>
           <a:p>
             <a:pPr lvl="0"/>
             <a:r>
-              <a:rPr/>
               <a:t>使用局部背景差分保留相对周围突出的光斑</a:t>
             </a:r>
           </a:p>
           <a:p>
             <a:pPr lvl="0"/>
             <a:r>
-              <a:rPr/>
               <a:t>通过面积、宽高比、填充率过滤异常亮块</a:t>
             </a:r>
           </a:p>
@@ -3735,6 +6049,9 @@
       </p:sp>
     </p:spTree>
   </p:cSld>
+  <p:clrMapOvr>
+    <a:masterClrMapping/>
+  </p:clrMapOvr>
 </p:sld>
 </file>
 
@@ -3770,11 +6087,10 @@
           <a:bodyPr/>
           <a:lstStyle/>
           <a:p>
-            <a:pPr lvl="0" indent="0" marL="0">
+            <a:pPr marL="0" lvl="0" indent="0">
               <a:buNone/>
             </a:pPr>
             <a:r>
-              <a:rPr/>
               <a:t>车辆检测与补检</a:t>
             </a:r>
           </a:p>
@@ -3797,35 +6113,30 @@
           <a:p>
             <a:pPr lvl="0"/>
             <a:r>
-              <a:rPr/>
               <a:t>YOLOv8n 检测 car、bus、truck、motorcycle 等车辆类别</a:t>
             </a:r>
           </a:p>
           <a:p>
             <a:pPr lvl="0"/>
             <a:r>
-              <a:rPr/>
               <a:t>对远处小车，利用左右成对车灯补充车辆候选</a:t>
             </a:r>
           </a:p>
           <a:p>
             <a:pPr lvl="0"/>
             <a:r>
-              <a:rPr/>
               <a:t>成对车灯需满足水平接近、尺寸相近、间距合理</a:t>
             </a:r>
           </a:p>
           <a:p>
             <a:pPr lvl="0"/>
             <a:r>
-              <a:rPr/>
               <a:t>反推车辆框后检查暗部比例和边缘结构</a:t>
             </a:r>
           </a:p>
           <a:p>
             <a:pPr lvl="0"/>
             <a:r>
-              <a:rPr/>
               <a:t>缺少车身结构的地面反光、路牌亮点会被过滤</a:t>
             </a:r>
           </a:p>
@@ -3833,6 +6144,9 @@
       </p:sp>
     </p:spTree>
   </p:cSld>
+  <p:clrMapOvr>
+    <a:masterClrMapping/>
+  </p:clrMapOvr>
 </p:sld>
 </file>
 
@@ -3868,11 +6182,10 @@
           <a:bodyPr/>
           <a:lstStyle/>
           <a:p>
-            <a:pPr lvl="0" indent="0" marL="0">
+            <a:pPr marL="0" lvl="0" indent="0">
               <a:buNone/>
             </a:pPr>
             <a:r>
-              <a:rPr/>
               <a:t>蓝光来源分类</a:t>
             </a:r>
           </a:p>
@@ -3895,42 +6208,36 @@
           <a:p>
             <a:pPr lvl="0"/>
             <a:r>
-              <a:rPr/>
               <a:t>蓝光候选必须与车辆存在可靠空间关系</a:t>
             </a:r>
           </a:p>
           <a:p>
             <a:pPr lvl="0"/>
             <a:r>
-              <a:rPr/>
               <a:t>位于前灯/尾灯区域的小型强光核心：车灯蓝光</a:t>
             </a:r>
           </a:p>
           <a:p>
             <a:pPr lvl="0"/>
             <a:r>
-              <a:rPr/>
               <a:t>根据横向位置识别左侧/右侧车灯</a:t>
             </a:r>
           </a:p>
           <a:p>
             <a:pPr lvl="0"/>
             <a:r>
-              <a:rPr/>
               <a:t>位于车身、挡风玻璃、号牌附近：车辆反光蓝光</a:t>
             </a:r>
           </a:p>
           <a:p>
             <a:pPr lvl="0"/>
             <a:r>
-              <a:rPr/>
               <a:t>位于路牌、路灯、屏幕、柱体、地面：环境干扰蓝光</a:t>
             </a:r>
           </a:p>
           <a:p>
             <a:pPr lvl="0"/>
             <a:r>
-              <a:rPr/>
               <a:t>环境干扰不计入车辆蓝光统计</a:t>
             </a:r>
           </a:p>
@@ -3938,6 +6245,9 @@
       </p:sp>
     </p:spTree>
   </p:cSld>
+  <p:clrMapOvr>
+    <a:masterClrMapping/>
+  </p:clrMapOvr>
 </p:sld>
 </file>
 
@@ -3973,11 +6283,10 @@
           <a:bodyPr/>
           <a:lstStyle/>
           <a:p>
-            <a:pPr lvl="0" indent="0" marL="0">
+            <a:pPr marL="0" lvl="0" indent="0">
               <a:buNone/>
             </a:pPr>
             <a:r>
-              <a:rPr/>
               <a:t>可视化与统计</a:t>
             </a:r>
           </a:p>
@@ -4000,35 +6309,30 @@
           <a:p>
             <a:pPr lvl="0"/>
             <a:r>
-              <a:rPr/>
               <a:t>绿色框：普通车辆</a:t>
             </a:r>
           </a:p>
           <a:p>
             <a:pPr lvl="0"/>
             <a:r>
-              <a:rPr/>
               <a:t>红色框：蓝光车灯车辆</a:t>
             </a:r>
           </a:p>
           <a:p>
             <a:pPr lvl="0"/>
             <a:r>
-              <a:rPr/>
               <a:t>黄色框：蓝光反光车辆</a:t>
             </a:r>
           </a:p>
           <a:p>
             <a:pPr lvl="0"/>
             <a:r>
-              <a:rPr/>
               <a:t>蓝色小框：车辆蓝光区域</a:t>
             </a:r>
           </a:p>
           <a:p>
             <a:pPr lvl="0"/>
             <a:r>
-              <a:rPr/>
               <a:t>统计字段：vehicles、lamp_blue、reflect_blue、blue_regions</a:t>
             </a:r>
           </a:p>
@@ -4036,7 +6340,514 @@
       </p:sp>
     </p:spTree>
   </p:cSld>
+  <p:clrMapOvr>
+    <a:masterClrMapping/>
+  </p:clrMapOvr>
 </p:sld>
+</file>
+
+<file path=ppt/tags/tag1.xml><?xml version="1.0" encoding="utf-8"?>
+<p:tagLst xmlns:p="http://schemas.openxmlformats.org/presentationml/2006/main">
+  <p:tag name="KSO_WM_UNIT_TYPE" val="i"/>
+  <p:tag name="KSO_WM_UNIT_INDEX" val="6"/>
+  <p:tag name="KSO_WM_BEAUTIFY_FLAG" val="#wm#"/>
+  <p:tag name="KSO_WM_TAG_VERSION" val="3.0"/>
+  <p:tag name="KSO_WM_UNIT_ID" val="_1*i*6"/>
+  <p:tag name="KSO_WM_UNIT_ISNUMDGMTITLE" val="0"/>
+  <p:tag name="KSO_WM_UNIT_NOCLEAR" val="0"/>
+  <p:tag name="KSO_WM_UNIT_HIGHLIGHT" val="0"/>
+  <p:tag name="KSO_WM_UNIT_COMPATIBLE" val="0"/>
+  <p:tag name="KSO_WM_UNIT_DIAGRAM_ISNUMVISUAL" val="0"/>
+  <p:tag name="KSO_WM_UNIT_DIAGRAM_ISREFERUNIT" val="0"/>
+  <p:tag name="KSO_WM_UNIT_LAYERLEVEL" val="1"/>
+</p:tagLst>
+</file>
+
+<file path=ppt/tags/tag10.xml><?xml version="1.0" encoding="utf-8"?>
+<p:tagLst xmlns:p="http://schemas.openxmlformats.org/presentationml/2006/main">
+  <p:tag name="KSO_WM_UNIT_TYPE" val="i"/>
+  <p:tag name="KSO_WM_UNIT_INDEX" val="10"/>
+  <p:tag name="KSO_WM_BEAUTIFY_FLAG" val="#wm#"/>
+  <p:tag name="KSO_WM_TAG_VERSION" val="3.0"/>
+  <p:tag name="KSO_WM_UNIT_ID" val="_1*i*10"/>
+  <p:tag name="KSO_WM_UNIT_ISNUMDGMTITLE" val="0"/>
+  <p:tag name="KSO_WM_UNIT_NOCLEAR" val="0"/>
+  <p:tag name="KSO_WM_UNIT_HIGHLIGHT" val="0"/>
+  <p:tag name="KSO_WM_UNIT_COMPATIBLE" val="0"/>
+  <p:tag name="KSO_WM_UNIT_DIAGRAM_ISNUMVISUAL" val="0"/>
+  <p:tag name="KSO_WM_UNIT_DIAGRAM_ISREFERUNIT" val="0"/>
+  <p:tag name="KSO_WM_UNIT_LAYERLEVEL" val="1"/>
+</p:tagLst>
+</file>
+
+<file path=ppt/tags/tag11.xml><?xml version="1.0" encoding="utf-8"?>
+<p:tagLst xmlns:p="http://schemas.openxmlformats.org/presentationml/2006/main">
+  <p:tag name="KSO_WM_UNIT_TYPE" val="i"/>
+  <p:tag name="KSO_WM_UNIT_INDEX" val="8"/>
+  <p:tag name="KSO_WM_BEAUTIFY_FLAG" val="#wm#"/>
+  <p:tag name="KSO_WM_TAG_VERSION" val="3.0"/>
+  <p:tag name="KSO_WM_UNIT_ID" val="_1*i*8"/>
+  <p:tag name="KSO_WM_UNIT_ISNUMDGMTITLE" val="0"/>
+  <p:tag name="KSO_WM_UNIT_NOCLEAR" val="0"/>
+  <p:tag name="KSO_WM_UNIT_HIGHLIGHT" val="0"/>
+  <p:tag name="KSO_WM_UNIT_COMPATIBLE" val="0"/>
+  <p:tag name="KSO_WM_UNIT_DIAGRAM_ISNUMVISUAL" val="0"/>
+  <p:tag name="KSO_WM_UNIT_DIAGRAM_ISREFERUNIT" val="0"/>
+  <p:tag name="KSO_WM_UNIT_LAYERLEVEL" val="1"/>
+</p:tagLst>
+</file>
+
+<file path=ppt/tags/tag12.xml><?xml version="1.0" encoding="utf-8"?>
+<p:tagLst xmlns:p="http://schemas.openxmlformats.org/presentationml/2006/main">
+  <p:tag name="KSO_WM_UNIT_TYPE" val="a"/>
+  <p:tag name="KSO_WM_UNIT_INDEX" val="1"/>
+  <p:tag name="KSO_WM_BEAUTIFY_FLAG" val="#wm#"/>
+  <p:tag name="KSO_WM_TAG_VERSION" val="3.0"/>
+  <p:tag name="KSO_WM_UNIT_PRESET_TEXT" val="单击此处编辑母版标题样式"/>
+  <p:tag name="KSO_WM_UNIT_ID" val="_1*a*1"/>
+  <p:tag name="KSO_WM_UNIT_ISNUMDGMTITLE" val="0"/>
+  <p:tag name="KSO_WM_UNIT_NOCLEAR" val="0"/>
+  <p:tag name="KSO_WM_UNIT_HIGHLIGHT" val="0"/>
+  <p:tag name="KSO_WM_UNIT_COMPATIBLE" val="0"/>
+  <p:tag name="KSO_WM_UNIT_DIAGRAM_ISNUMVISUAL" val="0"/>
+  <p:tag name="KSO_WM_UNIT_DIAGRAM_ISREFERUNIT" val="0"/>
+  <p:tag name="KSO_WM_UNIT_LAYERLEVEL" val="1"/>
+  <p:tag name="KSO_WM_UNIT_ISCONTENTSTITLE" val="0"/>
+  <p:tag name="KSO_WM_UNIT_VALUE" val="14"/>
+</p:tagLst>
+</file>
+
+<file path=ppt/tags/tag13.xml><?xml version="1.0" encoding="utf-8"?>
+<p:tagLst xmlns:p="http://schemas.openxmlformats.org/presentationml/2006/main">
+  <p:tag name="KSO_WM_UNIT_TYPE" val="b"/>
+  <p:tag name="KSO_WM_UNIT_INDEX" val="1"/>
+  <p:tag name="KSO_WM_BEAUTIFY_FLAG" val="#wm#"/>
+  <p:tag name="KSO_WM_TAG_VERSION" val="3.0"/>
+  <p:tag name="KSO_WM_UNIT_PRESET_TEXT" val="单击此处编辑副标题"/>
+  <p:tag name="KSO_WM_UNIT_ID" val="_1*b*1"/>
+  <p:tag name="KSO_WM_UNIT_ISNUMDGMTITLE" val="0"/>
+  <p:tag name="KSO_WM_UNIT_NOCLEAR" val="0"/>
+  <p:tag name="KSO_WM_UNIT_HIGHLIGHT" val="0"/>
+  <p:tag name="KSO_WM_UNIT_COMPATIBLE" val="0"/>
+  <p:tag name="KSO_WM_UNIT_DIAGRAM_ISNUMVISUAL" val="0"/>
+  <p:tag name="KSO_WM_UNIT_DIAGRAM_ISREFERUNIT" val="0"/>
+  <p:tag name="KSO_WM_UNIT_LAYERLEVEL" val="1"/>
+  <p:tag name="KSO_WM_UNIT_ISCONTENTSTITLE" val="0"/>
+  <p:tag name="KSO_WM_UNIT_VALUE" val="38"/>
+</p:tagLst>
+</file>
+
+<file path=ppt/tags/tag14.xml><?xml version="1.0" encoding="utf-8"?>
+<p:tagLst xmlns:p="http://schemas.openxmlformats.org/presentationml/2006/main">
+  <p:tag name="KSO_WM_UNIT_ID" val="_1**"/>
+  <p:tag name="KSO_WM_BEAUTIFY_FLAG" val="#wm#"/>
+  <p:tag name="KSO_WM_TAG_VERSION" val="3.0"/>
+  <p:tag name="KSO_WM_UNIT_ISNUMDGMTITLE" val="0"/>
+  <p:tag name="KSO_WM_UNIT_NOCLEAR" val="0"/>
+  <p:tag name="KSO_WM_UNIT_HIGHLIGHT" val="0"/>
+  <p:tag name="KSO_WM_UNIT_COMPATIBLE" val="0"/>
+  <p:tag name="KSO_WM_UNIT_DIAGRAM_ISNUMVISUAL" val="0"/>
+  <p:tag name="KSO_WM_UNIT_DIAGRAM_ISREFERUNIT" val="0"/>
+  <p:tag name="KSO_WM_UNIT_LAYERLEVEL" val="1"/>
+</p:tagLst>
+</file>
+
+<file path=ppt/tags/tag15.xml><?xml version="1.0" encoding="utf-8"?>
+<p:tagLst xmlns:p="http://schemas.openxmlformats.org/presentationml/2006/main">
+  <p:tag name="KSO_WM_UNIT_ID" val="_1**"/>
+  <p:tag name="KSO_WM_BEAUTIFY_FLAG" val="#wm#"/>
+  <p:tag name="KSO_WM_TAG_VERSION" val="3.0"/>
+  <p:tag name="KSO_WM_UNIT_ISNUMDGMTITLE" val="0"/>
+  <p:tag name="KSO_WM_UNIT_NOCLEAR" val="0"/>
+  <p:tag name="KSO_WM_UNIT_HIGHLIGHT" val="0"/>
+  <p:tag name="KSO_WM_UNIT_COMPATIBLE" val="0"/>
+  <p:tag name="KSO_WM_UNIT_DIAGRAM_ISNUMVISUAL" val="0"/>
+  <p:tag name="KSO_WM_UNIT_DIAGRAM_ISREFERUNIT" val="0"/>
+  <p:tag name="KSO_WM_UNIT_LAYERLEVEL" val="1"/>
+</p:tagLst>
+</file>
+
+<file path=ppt/tags/tag16.xml><?xml version="1.0" encoding="utf-8"?>
+<p:tagLst xmlns:p="http://schemas.openxmlformats.org/presentationml/2006/main">
+  <p:tag name="KSO_WM_UNIT_ID" val="_1**"/>
+  <p:tag name="KSO_WM_BEAUTIFY_FLAG" val="#wm#"/>
+  <p:tag name="KSO_WM_TAG_VERSION" val="3.0"/>
+  <p:tag name="KSO_WM_UNIT_ISNUMDGMTITLE" val="0"/>
+  <p:tag name="KSO_WM_UNIT_NOCLEAR" val="0"/>
+  <p:tag name="KSO_WM_UNIT_HIGHLIGHT" val="0"/>
+  <p:tag name="KSO_WM_UNIT_COMPATIBLE" val="0"/>
+  <p:tag name="KSO_WM_UNIT_DIAGRAM_ISNUMVISUAL" val="0"/>
+  <p:tag name="KSO_WM_UNIT_DIAGRAM_ISREFERUNIT" val="0"/>
+  <p:tag name="KSO_WM_UNIT_LAYERLEVEL" val="1"/>
+</p:tagLst>
+</file>
+
+<file path=ppt/tags/tag17.xml><?xml version="1.0" encoding="utf-8"?>
+<p:tagLst xmlns:p="http://schemas.openxmlformats.org/presentationml/2006/main">
+  <p:tag name="KSO_WM_UNIT_TYPE" val="i"/>
+  <p:tag name="KSO_WM_UNIT_INDEX" val="1"/>
+  <p:tag name="KSO_WM_BEAUTIFY_FLAG" val="#wm#"/>
+  <p:tag name="KSO_WM_TAG_VERSION" val="3.0"/>
+  <p:tag name="KSO_WM_UNIT_ID" val="_0*i*1"/>
+  <p:tag name="KSO_WM_UNIT_ISNUMDGMTITLE" val="0"/>
+  <p:tag name="KSO_WM_UNIT_NOCLEAR" val="0"/>
+  <p:tag name="KSO_WM_UNIT_HIGHLIGHT" val="0"/>
+  <p:tag name="KSO_WM_UNIT_COMPATIBLE" val="0"/>
+  <p:tag name="KSO_WM_UNIT_DIAGRAM_ISNUMVISUAL" val="0"/>
+  <p:tag name="KSO_WM_UNIT_DIAGRAM_ISREFERUNIT" val="0"/>
+  <p:tag name="KSO_WM_UNIT_LAYERLEVEL" val="1"/>
+</p:tagLst>
+</file>
+
+<file path=ppt/tags/tag18.xml><?xml version="1.0" encoding="utf-8"?>
+<p:tagLst xmlns:p="http://schemas.openxmlformats.org/presentationml/2006/main">
+  <p:tag name="KSO_WM_UNIT_TYPE" val="i"/>
+  <p:tag name="KSO_WM_UNIT_INDEX" val="2"/>
+  <p:tag name="KSO_WM_BEAUTIFY_FLAG" val="#wm#"/>
+  <p:tag name="KSO_WM_TAG_VERSION" val="3.0"/>
+  <p:tag name="KSO_WM_UNIT_ID" val="_0*i*2"/>
+  <p:tag name="KSO_WM_UNIT_ISNUMDGMTITLE" val="0"/>
+  <p:tag name="KSO_WM_UNIT_NOCLEAR" val="0"/>
+  <p:tag name="KSO_WM_UNIT_HIGHLIGHT" val="0"/>
+  <p:tag name="KSO_WM_UNIT_COMPATIBLE" val="0"/>
+  <p:tag name="KSO_WM_UNIT_DIAGRAM_ISNUMVISUAL" val="0"/>
+  <p:tag name="KSO_WM_UNIT_DIAGRAM_ISREFERUNIT" val="0"/>
+  <p:tag name="KSO_WM_UNIT_LAYERLEVEL" val="1"/>
+</p:tagLst>
+</file>
+
+<file path=ppt/tags/tag19.xml><?xml version="1.0" encoding="utf-8"?>
+<p:tagLst xmlns:p="http://schemas.openxmlformats.org/presentationml/2006/main">
+  <p:tag name="KSO_WM_UNIT_TYPE" val="i"/>
+  <p:tag name="KSO_WM_UNIT_INDEX" val="3"/>
+  <p:tag name="KSO_WM_BEAUTIFY_FLAG" val="#wm#"/>
+  <p:tag name="KSO_WM_TAG_VERSION" val="3.0"/>
+  <p:tag name="KSO_WM_UNIT_ID" val="_0*i*3"/>
+  <p:tag name="KSO_WM_UNIT_ISNUMDGMTITLE" val="0"/>
+  <p:tag name="KSO_WM_UNIT_NOCLEAR" val="0"/>
+  <p:tag name="KSO_WM_UNIT_HIGHLIGHT" val="0"/>
+  <p:tag name="KSO_WM_UNIT_COMPATIBLE" val="0"/>
+  <p:tag name="KSO_WM_UNIT_DIAGRAM_ISNUMVISUAL" val="0"/>
+  <p:tag name="KSO_WM_UNIT_DIAGRAM_ISREFERUNIT" val="0"/>
+  <p:tag name="KSO_WM_UNIT_LAYERLEVEL" val="1"/>
+</p:tagLst>
+</file>
+
+<file path=ppt/tags/tag2.xml><?xml version="1.0" encoding="utf-8"?>
+<p:tagLst xmlns:p="http://schemas.openxmlformats.org/presentationml/2006/main">
+  <p:tag name="KSO_WM_UNIT_TYPE" val="i"/>
+  <p:tag name="KSO_WM_UNIT_INDEX" val="1"/>
+  <p:tag name="KSO_WM_BEAUTIFY_FLAG" val="#wm#"/>
+  <p:tag name="KSO_WM_TAG_VERSION" val="3.0"/>
+  <p:tag name="KSO_WM_UNIT_ID" val="_1*i*1"/>
+  <p:tag name="KSO_WM_UNIT_ISNUMDGMTITLE" val="0"/>
+  <p:tag name="KSO_WM_UNIT_NOCLEAR" val="0"/>
+  <p:tag name="KSO_WM_UNIT_HIGHLIGHT" val="0"/>
+  <p:tag name="KSO_WM_UNIT_COMPATIBLE" val="0"/>
+  <p:tag name="KSO_WM_UNIT_DIAGRAM_ISNUMVISUAL" val="0"/>
+  <p:tag name="KSO_WM_UNIT_DIAGRAM_ISREFERUNIT" val="0"/>
+  <p:tag name="KSO_WM_UNIT_LAYERLEVEL" val="1"/>
+</p:tagLst>
+</file>
+
+<file path=ppt/tags/tag20.xml><?xml version="1.0" encoding="utf-8"?>
+<p:tagLst xmlns:p="http://schemas.openxmlformats.org/presentationml/2006/main">
+  <p:tag name="KSO_WM_UNIT_TYPE" val="i"/>
+  <p:tag name="KSO_WM_UNIT_INDEX" val="4"/>
+  <p:tag name="KSO_WM_BEAUTIFY_FLAG" val="#wm#"/>
+  <p:tag name="KSO_WM_TAG_VERSION" val="3.0"/>
+  <p:tag name="KSO_WM_UNIT_ID" val="_0*i*4"/>
+  <p:tag name="KSO_WM_UNIT_ISNUMDGMTITLE" val="0"/>
+  <p:tag name="KSO_WM_UNIT_NOCLEAR" val="0"/>
+  <p:tag name="KSO_WM_UNIT_HIGHLIGHT" val="0"/>
+  <p:tag name="KSO_WM_UNIT_COMPATIBLE" val="0"/>
+  <p:tag name="KSO_WM_UNIT_DIAGRAM_ISNUMVISUAL" val="0"/>
+  <p:tag name="KSO_WM_UNIT_DIAGRAM_ISREFERUNIT" val="0"/>
+  <p:tag name="KSO_WM_UNIT_LAYERLEVEL" val="1"/>
+</p:tagLst>
+</file>
+
+<file path=ppt/tags/tag21.xml><?xml version="1.0" encoding="utf-8"?>
+<p:tagLst xmlns:p="http://schemas.openxmlformats.org/presentationml/2006/main">
+  <p:tag name="KSO_WM_UNIT_TYPE" val="a"/>
+  <p:tag name="KSO_WM_UNIT_INDEX" val="1"/>
+  <p:tag name="KSO_WM_BEAUTIFY_FLAG" val="#wm#"/>
+  <p:tag name="KSO_WM_TAG_VERSION" val="1.0"/>
+  <p:tag name="KSO_WM_UNIT_PRESET_TEXT" val="单击此处编辑母版标题样式"/>
+  <p:tag name="KSO_WM_UNIT_ID" val="_0*a*1"/>
+  <p:tag name="KSO_WM_UNIT_ISNUMDGMTITLE" val="0"/>
+  <p:tag name="KSO_WM_UNIT_NOCLEAR" val="0"/>
+  <p:tag name="KSO_WM_UNIT_HIGHLIGHT" val="0"/>
+  <p:tag name="KSO_WM_UNIT_COMPATIBLE" val="0"/>
+  <p:tag name="KSO_WM_UNIT_DIAGRAM_ISNUMVISUAL" val="0"/>
+  <p:tag name="KSO_WM_UNIT_DIAGRAM_ISREFERUNIT" val="0"/>
+  <p:tag name="KSO_WM_UNIT_LAYERLEVEL" val="1"/>
+  <p:tag name="KSO_WM_UNIT_ISCONTENTSTITLE" val="0"/>
+  <p:tag name="KSO_WM_TEMPLATE_CATEGORY" val="custom"/>
+  <p:tag name="KSO_WM_TEMPLATE_INDEX" val="40495200"/>
+</p:tagLst>
+</file>
+
+<file path=ppt/tags/tag22.xml><?xml version="1.0" encoding="utf-8"?>
+<p:tagLst xmlns:p="http://schemas.openxmlformats.org/presentationml/2006/main">
+  <p:tag name="KSO_WM_UNIT_TYPE" val="f"/>
+  <p:tag name="KSO_WM_UNIT_SUBTYPE" val="a"/>
+  <p:tag name="KSO_WM_UNIT_INDEX" val="1"/>
+  <p:tag name="KSO_WM_BEAUTIFY_FLAG" val="#wm#"/>
+  <p:tag name="KSO_WM_TAG_VERSION" val="1.0"/>
+  <p:tag name="KSO_WM_UNIT_PRESET_TEXT" val="单击此处编辑母版文本样式&#10;第二级&#10;第三级&#10;第四级&#10;第五级"/>
+  <p:tag name="KSO_WM_UNIT_ID" val="_0*f*1"/>
+  <p:tag name="KSO_WM_UNIT_ISNUMDGMTITLE" val="0"/>
+  <p:tag name="KSO_WM_UNIT_NOCLEAR" val="0"/>
+  <p:tag name="KSO_WM_UNIT_HIGHLIGHT" val="0"/>
+  <p:tag name="KSO_WM_UNIT_COMPATIBLE" val="0"/>
+  <p:tag name="KSO_WM_UNIT_DIAGRAM_ISNUMVISUAL" val="0"/>
+  <p:tag name="KSO_WM_UNIT_DIAGRAM_ISREFERUNIT" val="0"/>
+  <p:tag name="KSO_WM_UNIT_LAYERLEVEL" val="1"/>
+  <p:tag name="KSO_WM_UNIT_TEXT_LAYER_COUNT" val="1"/>
+  <p:tag name="KSO_WM_TEMPLATE_CATEGORY" val="custom"/>
+  <p:tag name="KSO_WM_TEMPLATE_INDEX" val="40495200"/>
+</p:tagLst>
+</file>
+
+<file path=ppt/tags/tag23.xml><?xml version="1.0" encoding="utf-8"?>
+<p:tagLst xmlns:p="http://schemas.openxmlformats.org/presentationml/2006/main">
+  <p:tag name="KSO_WM_UNIT_ID" val="_0**"/>
+  <p:tag name="KSO_WM_BEAUTIFY_FLAG" val="#wm#"/>
+  <p:tag name="KSO_WM_TAG_VERSION" val="3.0"/>
+  <p:tag name="KSO_WM_UNIT_ISNUMDGMTITLE" val="0"/>
+  <p:tag name="KSO_WM_UNIT_NOCLEAR" val="0"/>
+  <p:tag name="KSO_WM_UNIT_HIGHLIGHT" val="0"/>
+  <p:tag name="KSO_WM_UNIT_COMPATIBLE" val="0"/>
+  <p:tag name="KSO_WM_UNIT_DIAGRAM_ISNUMVISUAL" val="0"/>
+  <p:tag name="KSO_WM_UNIT_DIAGRAM_ISREFERUNIT" val="0"/>
+  <p:tag name="KSO_WM_UNIT_LAYERLEVEL" val="1"/>
+</p:tagLst>
+</file>
+
+<file path=ppt/tags/tag24.xml><?xml version="1.0" encoding="utf-8"?>
+<p:tagLst xmlns:p="http://schemas.openxmlformats.org/presentationml/2006/main">
+  <p:tag name="KSO_WM_UNIT_ID" val="_0**"/>
+  <p:tag name="KSO_WM_BEAUTIFY_FLAG" val="#wm#"/>
+  <p:tag name="KSO_WM_TAG_VERSION" val="3.0"/>
+  <p:tag name="KSO_WM_UNIT_ISNUMDGMTITLE" val="0"/>
+  <p:tag name="KSO_WM_UNIT_NOCLEAR" val="0"/>
+  <p:tag name="KSO_WM_UNIT_HIGHLIGHT" val="0"/>
+  <p:tag name="KSO_WM_UNIT_COMPATIBLE" val="0"/>
+  <p:tag name="KSO_WM_UNIT_DIAGRAM_ISNUMVISUAL" val="0"/>
+  <p:tag name="KSO_WM_UNIT_DIAGRAM_ISREFERUNIT" val="0"/>
+  <p:tag name="KSO_WM_UNIT_LAYERLEVEL" val="1"/>
+</p:tagLst>
+</file>
+
+<file path=ppt/tags/tag25.xml><?xml version="1.0" encoding="utf-8"?>
+<p:tagLst xmlns:p="http://schemas.openxmlformats.org/presentationml/2006/main">
+  <p:tag name="KSO_WM_UNIT_ID" val="_0**"/>
+  <p:tag name="KSO_WM_BEAUTIFY_FLAG" val="#wm#"/>
+  <p:tag name="KSO_WM_TAG_VERSION" val="3.0"/>
+  <p:tag name="KSO_WM_UNIT_ISNUMDGMTITLE" val="0"/>
+  <p:tag name="KSO_WM_UNIT_NOCLEAR" val="0"/>
+  <p:tag name="KSO_WM_UNIT_HIGHLIGHT" val="0"/>
+  <p:tag name="KSO_WM_UNIT_COMPATIBLE" val="0"/>
+  <p:tag name="KSO_WM_UNIT_DIAGRAM_ISNUMVISUAL" val="0"/>
+  <p:tag name="KSO_WM_UNIT_DIAGRAM_ISREFERUNIT" val="0"/>
+  <p:tag name="KSO_WM_UNIT_LAYERLEVEL" val="1"/>
+</p:tagLst>
+</file>
+
+<file path=ppt/tags/tag26.xml><?xml version="1.0" encoding="utf-8"?>
+<p:tagLst xmlns:p="http://schemas.openxmlformats.org/presentationml/2006/main">
+  <p:tag name="KSO_WM_TEMPLATE_SUBCATEGORY" val="29"/>
+  <p:tag name="KSO_WM_TEMPLATE_COLOR_TYPE" val="0"/>
+  <p:tag name="KSO_WM_TAG_VERSION" val="3.0"/>
+  <p:tag name="KSO_WM_TEMPLATE_THUMBS_INDEX" val="1、9"/>
+  <p:tag name="KSO_WM_BEAUTIFY_FLAG" val="#wm#"/>
+  <p:tag name="KSO_WM_TEMPLATE_INDEX" val="40495200"/>
+  <p:tag name="KSO_WM_TEMPLATE_CATEGORY" val="custom"/>
+  <p:tag name="KSO_WM_TEMPLATE_MASTER_TYPE" val="0"/>
+</p:tagLst>
+</file>
+
+<file path=ppt/tags/tag27.xml><?xml version="1.0" encoding="utf-8"?>
+<p:tagLst xmlns:p="http://schemas.openxmlformats.org/presentationml/2006/main">
+  <p:tag name="KSO_WM_UNIT_TYPE" val="a"/>
+  <p:tag name="KSO_WM_UNIT_INDEX" val="1"/>
+  <p:tag name="KSO_WM_BEAUTIFY_FLAG" val="#wm#"/>
+  <p:tag name="KSO_WM_TAG_VERSION" val="3.0"/>
+  <p:tag name="KSO_WM_UNIT_PRESET_TEXT" val="单击此处添加页面标题"/>
+  <p:tag name="KSO_WM_UNIT_ID" val="custom40495200_1*a*1"/>
+  <p:tag name="KSO_WM_UNIT_ISNUMDGMTITLE" val="0"/>
+  <p:tag name="KSO_WM_UNIT_NOCLEAR" val="0"/>
+  <p:tag name="KSO_WM_UNIT_HIGHLIGHT" val="0"/>
+  <p:tag name="KSO_WM_UNIT_COMPATIBLE" val="0"/>
+  <p:tag name="KSO_WM_UNIT_DIAGRAM_ISNUMVISUAL" val="0"/>
+  <p:tag name="KSO_WM_UNIT_DIAGRAM_ISREFERUNIT" val="0"/>
+  <p:tag name="KSO_WM_UNIT_LAYERLEVEL" val="1"/>
+  <p:tag name="KSO_WM_TEMPLATE_INDEX" val="40495200"/>
+  <p:tag name="KSO_WM_TEMPLATE_CATEGORY" val="custom"/>
+  <p:tag name="KSO_WM_UNIT_ISCONTENTSTITLE" val="0"/>
+</p:tagLst>
+</file>
+
+<file path=ppt/tags/tag28.xml><?xml version="1.0" encoding="utf-8"?>
+<p:tagLst xmlns:p="http://schemas.openxmlformats.org/presentationml/2006/main">
+  <p:tag name="KSO_WM_UNIT_TYPE" val="b"/>
+  <p:tag name="KSO_WM_UNIT_INDEX" val="1"/>
+  <p:tag name="KSO_WM_BEAUTIFY_FLAG" val="#wm#"/>
+  <p:tag name="KSO_WM_TAG_VERSION" val="3.0"/>
+  <p:tag name="KSO_WM_UNIT_ID" val="custom40495200_1*b*1"/>
+  <p:tag name="KSO_WM_UNIT_ISNUMDGMTITLE" val="0"/>
+  <p:tag name="KSO_WM_UNIT_HIGHLIGHT" val="0"/>
+  <p:tag name="KSO_WM_UNIT_COMPATIBLE" val="0"/>
+  <p:tag name="KSO_WM_UNIT_DIAGRAM_ISNUMVISUAL" val="0"/>
+  <p:tag name="KSO_WM_UNIT_DIAGRAM_ISREFERUNIT" val="0"/>
+  <p:tag name="KSO_WM_UNIT_LAYERLEVEL" val="1"/>
+  <p:tag name="KSO_WM_TEMPLATE_INDEX" val="40495200"/>
+  <p:tag name="KSO_WM_TEMPLATE_CATEGORY" val="custom"/>
+  <p:tag name="KSO_WM_UNIT_ISCONTENTSTITLE" val="0"/>
+  <p:tag name="KSO_WM_UNIT_TEXT_TYPE" val="1"/>
+  <p:tag name="KSO_WM_UNIT_NOCLEAR" val="0"/>
+  <p:tag name="KSO_WM_UNIT_PRESET_TEXT" val="单击此处添加你的文档副标题内容"/>
+</p:tagLst>
+</file>
+
+<file path=ppt/tags/tag29.xml><?xml version="1.0" encoding="utf-8"?>
+<p:tagLst xmlns:p="http://schemas.openxmlformats.org/presentationml/2006/main">
+  <p:tag name="KSO_WM_SLIDE_TYPE" val="title"/>
+  <p:tag name="KSO_WM_TEMPLATE_SUBCATEGORY" val="29"/>
+  <p:tag name="KSO_WM_TEMPLATE_COLOR_TYPE" val="0"/>
+  <p:tag name="KSO_WM_TAG_VERSION" val="3.0"/>
+  <p:tag name="KSO_WM_SLIDE_SUBTYPE" val="pureTxt"/>
+  <p:tag name="KSO_WM_SLIDE_ITEM_CNT" val="0"/>
+  <p:tag name="KSO_WM_TEMPLATE_THUMBS_INDEX" val="1、9"/>
+  <p:tag name="KSO_WM_BEAUTIFY_FLAG" val="#wm#"/>
+  <p:tag name="KSO_WM_TEMPLATE_INDEX" val="40495200"/>
+  <p:tag name="KSO_WM_TEMPLATE_CATEGORY" val="custom"/>
+  <p:tag name="KSO_WM_SLIDE_INDEX" val="1"/>
+  <p:tag name="KSO_WM_SLIDE_ID" val="custom40495200_1"/>
+  <p:tag name="KSO_WM_TEMPLATE_MASTER_TYPE" val="0"/>
+  <p:tag name="KSO_WM_SLIDE_LAYOUT" val="a_b"/>
+  <p:tag name="KSO_WM_SLIDE_LAYOUT_CNT" val="1_1"/>
+</p:tagLst>
+</file>
+
+<file path=ppt/tags/tag3.xml><?xml version="1.0" encoding="utf-8"?>
+<p:tagLst xmlns:p="http://schemas.openxmlformats.org/presentationml/2006/main">
+  <p:tag name="KSO_WM_UNIT_TYPE" val="i"/>
+  <p:tag name="KSO_WM_UNIT_INDEX" val="7"/>
+  <p:tag name="KSO_WM_BEAUTIFY_FLAG" val="#wm#"/>
+  <p:tag name="KSO_WM_TAG_VERSION" val="3.0"/>
+  <p:tag name="KSO_WM_UNIT_ID" val="_1*i*7"/>
+  <p:tag name="KSO_WM_UNIT_ISNUMDGMTITLE" val="0"/>
+  <p:tag name="KSO_WM_UNIT_NOCLEAR" val="0"/>
+  <p:tag name="KSO_WM_UNIT_HIGHLIGHT" val="0"/>
+  <p:tag name="KSO_WM_UNIT_COMPATIBLE" val="0"/>
+  <p:tag name="KSO_WM_UNIT_DIAGRAM_ISNUMVISUAL" val="0"/>
+  <p:tag name="KSO_WM_UNIT_DIAGRAM_ISREFERUNIT" val="0"/>
+  <p:tag name="KSO_WM_UNIT_LAYERLEVEL" val="1"/>
+</p:tagLst>
+</file>
+
+<file path=ppt/tags/tag4.xml><?xml version="1.0" encoding="utf-8"?>
+<p:tagLst xmlns:p="http://schemas.openxmlformats.org/presentationml/2006/main">
+  <p:tag name="KSO_WM_UNIT_TYPE" val="i"/>
+  <p:tag name="KSO_WM_UNIT_INDEX" val="2"/>
+  <p:tag name="KSO_WM_BEAUTIFY_FLAG" val="#wm#"/>
+  <p:tag name="KSO_WM_TAG_VERSION" val="3.0"/>
+  <p:tag name="KSO_WM_UNIT_ID" val="_1*i*2"/>
+  <p:tag name="KSO_WM_UNIT_ISNUMDGMTITLE" val="0"/>
+  <p:tag name="KSO_WM_UNIT_NOCLEAR" val="0"/>
+  <p:tag name="KSO_WM_UNIT_HIGHLIGHT" val="0"/>
+  <p:tag name="KSO_WM_UNIT_COMPATIBLE" val="0"/>
+  <p:tag name="KSO_WM_UNIT_DIAGRAM_ISNUMVISUAL" val="0"/>
+  <p:tag name="KSO_WM_UNIT_DIAGRAM_ISREFERUNIT" val="0"/>
+  <p:tag name="KSO_WM_UNIT_LAYERLEVEL" val="1"/>
+</p:tagLst>
+</file>
+
+<file path=ppt/tags/tag5.xml><?xml version="1.0" encoding="utf-8"?>
+<p:tagLst xmlns:p="http://schemas.openxmlformats.org/presentationml/2006/main">
+  <p:tag name="KSO_WM_UNIT_TYPE" val="i"/>
+  <p:tag name="KSO_WM_UNIT_INDEX" val="5"/>
+  <p:tag name="KSO_WM_BEAUTIFY_FLAG" val="#wm#"/>
+  <p:tag name="KSO_WM_TAG_VERSION" val="3.0"/>
+  <p:tag name="KSO_WM_UNIT_ID" val="_1*i*5"/>
+  <p:tag name="KSO_WM_UNIT_ISNUMDGMTITLE" val="0"/>
+  <p:tag name="KSO_WM_UNIT_NOCLEAR" val="0"/>
+  <p:tag name="KSO_WM_UNIT_HIGHLIGHT" val="0"/>
+  <p:tag name="KSO_WM_UNIT_COMPATIBLE" val="0"/>
+  <p:tag name="KSO_WM_UNIT_DIAGRAM_ISNUMVISUAL" val="0"/>
+  <p:tag name="KSO_WM_UNIT_DIAGRAM_ISREFERUNIT" val="0"/>
+  <p:tag name="KSO_WM_UNIT_LAYERLEVEL" val="1"/>
+</p:tagLst>
+</file>
+
+<file path=ppt/tags/tag6.xml><?xml version="1.0" encoding="utf-8"?>
+<p:tagLst xmlns:p="http://schemas.openxmlformats.org/presentationml/2006/main">
+  <p:tag name="KSO_WM_UNIT_TYPE" val="i"/>
+  <p:tag name="KSO_WM_UNIT_INDEX" val="11"/>
+  <p:tag name="KSO_WM_BEAUTIFY_FLAG" val="#wm#"/>
+  <p:tag name="KSO_WM_TAG_VERSION" val="3.0"/>
+  <p:tag name="KSO_WM_UNIT_ID" val="_1*i*11"/>
+  <p:tag name="KSO_WM_UNIT_ISNUMDGMTITLE" val="0"/>
+  <p:tag name="KSO_WM_UNIT_NOCLEAR" val="0"/>
+  <p:tag name="KSO_WM_UNIT_HIGHLIGHT" val="0"/>
+  <p:tag name="KSO_WM_UNIT_COMPATIBLE" val="0"/>
+  <p:tag name="KSO_WM_UNIT_DIAGRAM_ISNUMVISUAL" val="0"/>
+  <p:tag name="KSO_WM_UNIT_DIAGRAM_ISREFERUNIT" val="0"/>
+  <p:tag name="KSO_WM_UNIT_LAYERLEVEL" val="1"/>
+</p:tagLst>
+</file>
+
+<file path=ppt/tags/tag7.xml><?xml version="1.0" encoding="utf-8"?>
+<p:tagLst xmlns:p="http://schemas.openxmlformats.org/presentationml/2006/main">
+  <p:tag name="KSO_WM_UNIT_TYPE" val="i"/>
+  <p:tag name="KSO_WM_UNIT_INDEX" val="9"/>
+  <p:tag name="KSO_WM_BEAUTIFY_FLAG" val="#wm#"/>
+  <p:tag name="KSO_WM_TAG_VERSION" val="3.0"/>
+  <p:tag name="KSO_WM_UNIT_ID" val="_1*i*9"/>
+  <p:tag name="KSO_WM_UNIT_ISNUMDGMTITLE" val="0"/>
+  <p:tag name="KSO_WM_UNIT_NOCLEAR" val="0"/>
+  <p:tag name="KSO_WM_UNIT_HIGHLIGHT" val="0"/>
+  <p:tag name="KSO_WM_UNIT_COMPATIBLE" val="0"/>
+  <p:tag name="KSO_WM_UNIT_DIAGRAM_ISNUMVISUAL" val="0"/>
+  <p:tag name="KSO_WM_UNIT_DIAGRAM_ISREFERUNIT" val="0"/>
+  <p:tag name="KSO_WM_UNIT_LAYERLEVEL" val="1"/>
+</p:tagLst>
+</file>
+
+<file path=ppt/tags/tag8.xml><?xml version="1.0" encoding="utf-8"?>
+<p:tagLst xmlns:p="http://schemas.openxmlformats.org/presentationml/2006/main">
+  <p:tag name="KSO_WM_UNIT_TYPE" val="i"/>
+  <p:tag name="KSO_WM_UNIT_INDEX" val="3"/>
+  <p:tag name="KSO_WM_BEAUTIFY_FLAG" val="#wm#"/>
+  <p:tag name="KSO_WM_TAG_VERSION" val="3.0"/>
+  <p:tag name="KSO_WM_UNIT_ID" val="_1*i*3"/>
+  <p:tag name="KSO_WM_UNIT_ISNUMDGMTITLE" val="0"/>
+  <p:tag name="KSO_WM_UNIT_NOCLEAR" val="0"/>
+  <p:tag name="KSO_WM_UNIT_HIGHLIGHT" val="0"/>
+  <p:tag name="KSO_WM_UNIT_COMPATIBLE" val="0"/>
+  <p:tag name="KSO_WM_UNIT_DIAGRAM_ISNUMVISUAL" val="0"/>
+  <p:tag name="KSO_WM_UNIT_DIAGRAM_ISREFERUNIT" val="0"/>
+  <p:tag name="KSO_WM_UNIT_LAYERLEVEL" val="1"/>
+</p:tagLst>
+</file>
+
+<file path=ppt/tags/tag9.xml><?xml version="1.0" encoding="utf-8"?>
+<p:tagLst xmlns:p="http://schemas.openxmlformats.org/presentationml/2006/main">
+  <p:tag name="KSO_WM_UNIT_TYPE" val="i"/>
+  <p:tag name="KSO_WM_UNIT_INDEX" val="4"/>
+  <p:tag name="KSO_WM_BEAUTIFY_FLAG" val="#wm#"/>
+  <p:tag name="KSO_WM_TAG_VERSION" val="3.0"/>
+  <p:tag name="KSO_WM_UNIT_ID" val="_1*i*4"/>
+  <p:tag name="KSO_WM_UNIT_ISNUMDGMTITLE" val="0"/>
+  <p:tag name="KSO_WM_UNIT_NOCLEAR" val="0"/>
+  <p:tag name="KSO_WM_UNIT_HIGHLIGHT" val="0"/>
+  <p:tag name="KSO_WM_UNIT_COMPATIBLE" val="0"/>
+  <p:tag name="KSO_WM_UNIT_DIAGRAM_ISNUMVISUAL" val="0"/>
+  <p:tag name="KSO_WM_UNIT_DIAGRAM_ISREFERUNIT" val="0"/>
+  <p:tag name="KSO_WM_UNIT_LAYERLEVEL" val="1"/>
+</p:tagLst>
 </file>
 
 <file path=ppt/theme/theme1.xml><?xml version="1.0" encoding="utf-8"?>
@@ -4355,121 +7166,65 @@
       </a:style>
     </a:lnDef>
   </a:objectDefaults>
-  <a:extraClrSchemeLst/>
+  <a:extLst>
+    <a:ext uri="{05A4C25C-085E-4340-85A3-A5531E510DB2}">
+      <thm15:themeFamily xmlns:thm15="http://schemas.microsoft.com/office/thememl/2012/main" name="Office Theme" id="{62F939B6-93AF-4DB8-9C6B-D6C7DFDC589F}" vid="{4A3C46E8-61CC-4603-A589-7422A47A8E4A}"/>
+    </a:ext>
+  </a:extLst>
 </a:theme>
 </file>
 
 <file path=ppt/theme/theme2.xml><?xml version="1.0" encoding="utf-8"?>
-<a:theme xmlns:a="http://schemas.openxmlformats.org/drawingml/2006/main" name="Office Theme">
+<a:theme xmlns:a="http://schemas.openxmlformats.org/drawingml/2006/main" name="Office 主题​​">
   <a:themeElements>
-    <a:clrScheme name="Office">
+    <a:clrScheme name="自定义 1176">
       <a:dk1>
-        <a:sysClr val="windowText" lastClr="000000"/>
+        <a:srgbClr val="000000"/>
       </a:dk1>
       <a:lt1>
-        <a:sysClr val="window" lastClr="FFFFFF"/>
+        <a:srgbClr val="FFFFFF"/>
       </a:lt1>
       <a:dk2>
-        <a:srgbClr val="44546A"/>
+        <a:srgbClr val="0066C6"/>
       </a:dk2>
       <a:lt2>
-        <a:srgbClr val="E7E6E6"/>
+        <a:srgbClr val="F6F9FF"/>
       </a:lt2>
       <a:accent1>
-        <a:srgbClr val="5B9BD5"/>
+        <a:srgbClr val="77C4FF"/>
       </a:accent1>
       <a:accent2>
-        <a:srgbClr val="ED7D31"/>
+        <a:srgbClr val="FF8F29"/>
       </a:accent2>
       <a:accent3>
-        <a:srgbClr val="A5A5A5"/>
+        <a:srgbClr val="39E990"/>
       </a:accent3>
       <a:accent4>
-        <a:srgbClr val="FFC000"/>
+        <a:srgbClr val="FFA728"/>
       </a:accent4>
       <a:accent5>
-        <a:srgbClr val="4472C4"/>
+        <a:srgbClr val="24D3BA"/>
       </a:accent5>
       <a:accent6>
-        <a:srgbClr val="70AD47"/>
+        <a:srgbClr val="55DD95"/>
       </a:accent6>
       <a:hlink>
         <a:srgbClr val="0563C1"/>
       </a:hlink>
       <a:folHlink>
-        <a:srgbClr val="954F72"/>
+        <a:srgbClr val="954D72"/>
       </a:folHlink>
     </a:clrScheme>
-    <a:fontScheme name="Office">
+    <a:fontScheme name="自定义 26">
       <a:majorFont>
-        <a:latin typeface="Calibri Light" panose="020F0302020204030204"/>
-        <a:ea typeface=""/>
+        <a:latin typeface="微软雅黑"/>
+        <a:ea typeface="微软雅黑"/>
         <a:cs typeface=""/>
-        <a:font script="Jpan" typeface="ＭＳ Ｐゴシック"/>
-        <a:font script="Hang" typeface="맑은 고딕"/>
-        <a:font script="Hans" typeface="宋体"/>
-        <a:font script="Hant" typeface="新細明體"/>
-        <a:font script="Arab" typeface="Times New Roman"/>
-        <a:font script="Hebr" typeface="Times New Roman"/>
-        <a:font script="Thai" typeface="Angsana New"/>
-        <a:font script="Ethi" typeface="Nyala"/>
-        <a:font script="Beng" typeface="Vrinda"/>
-        <a:font script="Gujr" typeface="Shruti"/>
-        <a:font script="Khmr" typeface="MoolBoran"/>
-        <a:font script="Knda" typeface="Tunga"/>
-        <a:font script="Guru" typeface="Raavi"/>
-        <a:font script="Cans" typeface="Euphemia"/>
-        <a:font script="Cher" typeface="Plantagenet Cherokee"/>
-        <a:font script="Yiii" typeface="Microsoft Yi Baiti"/>
-        <a:font script="Tibt" typeface="Microsoft Himalaya"/>
-        <a:font script="Thaa" typeface="MV Boli"/>
-        <a:font script="Deva" typeface="Mangal"/>
-        <a:font script="Telu" typeface="Gautami"/>
-        <a:font script="Taml" typeface="Latha"/>
-        <a:font script="Syrc" typeface="Estrangelo Edessa"/>
-        <a:font script="Orya" typeface="Kalinga"/>
-        <a:font script="Mlym" typeface="Kartika"/>
-        <a:font script="Laoo" typeface="DokChampa"/>
-        <a:font script="Sinh" typeface="Iskoola Pota"/>
-        <a:font script="Mong" typeface="Mongolian Baiti"/>
-        <a:font script="Viet" typeface="Times New Roman"/>
-        <a:font script="Uigh" typeface="Microsoft Uighur"/>
-        <a:font script="Geor" typeface="Sylfaen"/>
       </a:majorFont>
       <a:minorFont>
-        <a:latin typeface="Calibri" panose="020F0502020204030204"/>
-        <a:ea typeface=""/>
+        <a:latin typeface="微软雅黑"/>
+        <a:ea typeface="微软雅黑"/>
         <a:cs typeface=""/>
-        <a:font script="Jpan" typeface="ＭＳ Ｐゴシック"/>
-        <a:font script="Hang" typeface="맑은 고딕"/>
-        <a:font script="Hans" typeface="宋体"/>
-        <a:font script="Hant" typeface="新細明體"/>
-        <a:font script="Arab" typeface="Arial"/>
-        <a:font script="Hebr" typeface="Arial"/>
-        <a:font script="Thai" typeface="Cordia New"/>
-        <a:font script="Ethi" typeface="Nyala"/>
-        <a:font script="Beng" typeface="Vrinda"/>
-        <a:font script="Gujr" typeface="Shruti"/>
-        <a:font script="Khmr" typeface="DaunPenh"/>
-        <a:font script="Knda" typeface="Tunga"/>
-        <a:font script="Guru" typeface="Raavi"/>
-        <a:font script="Cans" typeface="Euphemia"/>
-        <a:font script="Cher" typeface="Plantagenet Cherokee"/>
-        <a:font script="Yiii" typeface="Microsoft Yi Baiti"/>
-        <a:font script="Tibt" typeface="Microsoft Himalaya"/>
-        <a:font script="Thaa" typeface="MV Boli"/>
-        <a:font script="Deva" typeface="Mangal"/>
-        <a:font script="Telu" typeface="Gautami"/>
-        <a:font script="Taml" typeface="Latha"/>
-        <a:font script="Syrc" typeface="Estrangelo Edessa"/>
-        <a:font script="Orya" typeface="Kalinga"/>
-        <a:font script="Mlym" typeface="Kartika"/>
-        <a:font script="Laoo" typeface="DokChampa"/>
-        <a:font script="Sinh" typeface="Iskoola Pota"/>
-        <a:font script="Mong" typeface="Mongolian Baiti"/>
-        <a:font script="Viet" typeface="Arial"/>
-        <a:font script="Uigh" typeface="Microsoft Uighur"/>
-        <a:font script="Geor" typeface="Sylfaen"/>
       </a:minorFont>
     </a:fontScheme>
     <a:fmtScheme name="Office">
@@ -4610,8 +7365,6 @@
       </a:bgFillStyleLst>
     </a:fmtScheme>
   </a:themeElements>
-  <a:objectDefaults/>
-  <a:extraClrSchemeLst/>
   <a:extLst>
     <a:ext uri="{05A4C25C-085E-4340-85A3-A5531E510DB2}">
       <thm15:themeFamily xmlns:thm15="http://schemas.microsoft.com/office/thememl/2012/main" name="Office Theme" id="{62F939B6-93AF-4DB8-9C6B-D6C7DFDC589F}" vid="{4A3C46E8-61CC-4603-A589-7422A47A8E4A}"/>

</xml_diff>